<commit_message>
Add model architecture and A/B workload explanations to performance deck
</commit_message>
<xml_diff>
--- a/docs/performance_key_items/performance_key_items_ko.pptx
+++ b/docs/performance_key_items/performance_key_items_ko.pptx
@@ -2,20 +2,22 @@
 <file path=ppt/presentation.xml><?xml version="1.0" encoding="utf-8"?>
 <p:presentation xmlns:p="http://schemas.openxmlformats.org/presentationml/2006/main">
   <p:sldMasterIdLst>
-    <p:sldMasterId xmlns:r="http://schemas.openxmlformats.org/officeDocument/2006/relationships" id="2147483648" r:id="R9cf14940b70748a7"/>
+    <p:sldMasterId xmlns:r="http://schemas.openxmlformats.org/officeDocument/2006/relationships" id="2147483648" r:id="R4f783c077fa24f70"/>
   </p:sldMasterIdLst>
   <p:notesMasterIdLst>
-    <p:notesMasterId xmlns:r="http://schemas.openxmlformats.org/officeDocument/2006/relationships" r:id="R320ac2b8bce948b4"/>
+    <p:notesMasterId xmlns:r="http://schemas.openxmlformats.org/officeDocument/2006/relationships" r:id="R853627180e8e42dc"/>
   </p:notesMasterIdLst>
   <p:sldIdLst>
-    <p:sldId xmlns:r="http://schemas.openxmlformats.org/officeDocument/2006/relationships" id="256" r:id="R4a83ca1778d24ab2"/>
-    <p:sldId xmlns:r="http://schemas.openxmlformats.org/officeDocument/2006/relationships" id="257" r:id="R19946e9984414ebf"/>
-    <p:sldId xmlns:r="http://schemas.openxmlformats.org/officeDocument/2006/relationships" id="258" r:id="R122c248705f74471"/>
-    <p:sldId xmlns:r="http://schemas.openxmlformats.org/officeDocument/2006/relationships" id="259" r:id="R53777452fb004ac6"/>
-    <p:sldId xmlns:r="http://schemas.openxmlformats.org/officeDocument/2006/relationships" id="260" r:id="R48e2dee5fc554039"/>
-    <p:sldId xmlns:r="http://schemas.openxmlformats.org/officeDocument/2006/relationships" id="261" r:id="R805eb05ab6124366"/>
-    <p:sldId xmlns:r="http://schemas.openxmlformats.org/officeDocument/2006/relationships" id="262" r:id="R733b393032c046a0"/>
-    <p:sldId xmlns:r="http://schemas.openxmlformats.org/officeDocument/2006/relationships" id="263" r:id="R6ef95d283d7d4997"/>
+    <p:sldId xmlns:r="http://schemas.openxmlformats.org/officeDocument/2006/relationships" id="256" r:id="R88b66dfa1ae04708"/>
+    <p:sldId xmlns:r="http://schemas.openxmlformats.org/officeDocument/2006/relationships" id="257" r:id="R99f320958fbf43b2"/>
+    <p:sldId xmlns:r="http://schemas.openxmlformats.org/officeDocument/2006/relationships" id="258" r:id="Rbb0b0bfad2a1457d"/>
+    <p:sldId xmlns:r="http://schemas.openxmlformats.org/officeDocument/2006/relationships" id="259" r:id="R0e180eafd598462d"/>
+    <p:sldId xmlns:r="http://schemas.openxmlformats.org/officeDocument/2006/relationships" id="260" r:id="R9b73e2670def40af"/>
+    <p:sldId xmlns:r="http://schemas.openxmlformats.org/officeDocument/2006/relationships" id="261" r:id="R76dc242db12948f4"/>
+    <p:sldId xmlns:r="http://schemas.openxmlformats.org/officeDocument/2006/relationships" id="262" r:id="R40d40d2658884a48"/>
+    <p:sldId xmlns:r="http://schemas.openxmlformats.org/officeDocument/2006/relationships" id="263" r:id="R69ece9600f1b4874"/>
+    <p:sldId xmlns:r="http://schemas.openxmlformats.org/officeDocument/2006/relationships" id="264" r:id="R631ab3b125de4cd3"/>
+    <p:sldId xmlns:r="http://schemas.openxmlformats.org/officeDocument/2006/relationships" id="265" r:id="Rfa5b88aedbda45c3"/>
   </p:sldIdLst>
   <p:sldSz cx="12192000" cy="6858000"/>
   <p:notesSz cx="6858000" cy="9144000"/>
@@ -449,7 +451,7 @@
           <a:lstStyle xmlns:a="http://schemas.openxmlformats.org/drawingml/2006/main"/>
           <a:p xmlns:a="http://schemas.openxmlformats.org/drawingml/2006/main">
             <a:r>
-              <a:t>저장된 실험 결과를 설명하는 자료다. 세 항목은 스케줄러 정책, 물리 자원과 데이터 배치, 실행 설정의 조합이다. 실험 조건이 다르므로 개선율을 누적하거나 합산하지 않는다. 수치는 제품 실측이나 공식 사양 보장이 아닌 본 모델의 결과다. 새 성능 실험이나 모델 변경 없이 기존 원자료를 정리했다.</a:t>
+              <a:t>이 구조는 현재 시뮬레이터 기준이다. 4개 Port는 독립적인 요청/응답 주체로, 한 Port도 주소에 따라 모든 Channel을 사용할 수 있다. Port와 Channel을 고정 1:1로 연결하지 않는다. Host IF는 Port당 512bit, 1GHz로 64GB/s이며 합계256GB/s다. 요청 수락 시 QD와 버퍼 용량을 확인하고, 신규16KiB 물리 페이지 작업에 대한 공유 버퍼 공간을 예약한다. 동일 물리 페이지 요청은 기존 작업에 연결할 수 있다. Lookup 이후 물리 주소의 연속성과 Port 선두 대기를 고려해 CA를 발행한다. NAND는4채널, 채널당16Plane, Plane당page buffer1개다. NAND출력은16KiB 전체 페이지이며 ECC 후 Controller buffer의 데이터가 반환 가능해진다. Port별 FIFO 선두만 응답하며 연결된 마지막 응답이 끝나면 Controller buffer를 해제한다. 영구cache나LRU 정책은 적용하지 않았다. UCIe의 모든 프로토콜 계층을 상세 구현한 회로도가 아니라 본 평가 모델의 동작 구조다.</a:t>
             </a:r>
           </a:p>
           <a:p xmlns:a="http://schemas.openxmlformats.org/drawingml/2006/main">
@@ -464,7 +466,117 @@
           </a:p>
           <a:p xmlns:a="http://schemas.openxmlformats.org/drawingml/2006/main">
             <a:r>
-              <a:t>https://github.com/JBRARAPARK/HBF_zNAND_Research/blob/22d9b33f085991f33d5273fdd9ce5688fb429fa4/README.md</a:t>
+              <a:t>https://github.com/JBRARAPARK/HBF_zNAND_Research/blob/22d9b33f085991f33d5273fdd9ce5688fb429fa4/znand/model.py</a:t>
+            </a:r>
+          </a:p>
+          <a:p xmlns:a="http://schemas.openxmlformats.org/drawingml/2006/main">
+            <a:r>
+              <a:t>https://github.com/JBRARAPARK/HBF_zNAND_Research/blob/22d9b33f085991f33d5273fdd9ce5688fb429fa4/docs/12_controller_scheduling_ko.md</a:t>
+            </a:r>
+          </a:p>
+          <a:p xmlns:a="http://schemas.openxmlformats.org/drawingml/2006/main">
+            <a:r>
+              <a:t>https://github.com/JBRARAPARK/HBF_zNAND_Research/blob/22d9b33f085991f33d5273fdd9ce5688fb429fa4/results/znand/saturation/RESULTS_KO.md</a:t>
+            </a:r>
+          </a:p>
+        </p:txBody>
+      </p:sp>
+      <p:sp>
+        <p:nvSpPr>
+          <p:cNvPr id="4" name="Slide Number Placeholder 3"/>
+          <p:cNvSpPr>
+            <a:spLocks xmlns:a="http://schemas.openxmlformats.org/drawingml/2006/main" noGrp="1"/>
+          </p:cNvSpPr>
+          <p:nvPr>
+            <p:ph type="sldNum" idx="5"/>
+          </p:nvPr>
+        </p:nvSpPr>
+        <p:spPr/>
+        <p:txBody>
+          <a:bodyPr xmlns:a="http://schemas.openxmlformats.org/drawingml/2006/main"/>
+          <a:lstStyle xmlns:a="http://schemas.openxmlformats.org/drawingml/2006/main"/>
+          <a:p xmlns:a="http://schemas.openxmlformats.org/drawingml/2006/main"/>
+        </p:txBody>
+      </p:sp>
+    </p:spTree>
+  </p:cSld>
+  <p:clrMapOvr>
+    <a:masterClrMapping xmlns:a="http://schemas.openxmlformats.org/drawingml/2006/main"/>
+  </p:clrMapOvr>
+</p:notes>
+</file>
+
+<file path=ppt/notesSlides/notesSlide10.xml><?xml version="1.0" encoding="utf-8"?>
+<p:notes xmlns:p="http://schemas.openxmlformats.org/presentationml/2006/main">
+  <p:cSld>
+    <p:spTree>
+      <p:nvGrpSpPr>
+        <p:cNvPr id="1" name=""/>
+        <p:cNvGrpSpPr/>
+        <p:nvPr/>
+      </p:nvGrpSpPr>
+      <p:grpSpPr>
+        <a:xfrm xmlns:a="http://schemas.openxmlformats.org/drawingml/2006/main"/>
+      </p:grpSpPr>
+      <p:sp>
+        <p:nvSpPr>
+          <p:cNvPr id="2" name="Slide Image Placeholder 1"/>
+          <p:cNvSpPr>
+            <a:spLocks xmlns:a="http://schemas.openxmlformats.org/drawingml/2006/main" noGrp="1"/>
+          </p:cNvSpPr>
+          <p:nvPr>
+            <p:ph type="sldImg" idx="0"/>
+          </p:nvPr>
+        </p:nvSpPr>
+        <p:spPr/>
+      </p:sp>
+      <p:sp>
+        <p:nvSpPr>
+          <p:cNvPr id="3" name="Notes Placeholder 2"/>
+          <p:cNvSpPr>
+            <a:spLocks xmlns:a="http://schemas.openxmlformats.org/drawingml/2006/main" noGrp="1"/>
+          </p:cNvSpPr>
+          <p:nvPr>
+            <p:ph type="body" idx="1"/>
+          </p:nvPr>
+        </p:nvSpPr>
+        <p:spPr/>
+        <p:txBody>
+          <a:bodyPr xmlns:a="http://schemas.openxmlformats.org/drawingml/2006/main"/>
+          <a:lstStyle xmlns:a="http://schemas.openxmlformats.org/drawingml/2006/main"/>
+          <a:p xmlns:a="http://schemas.openxmlformats.org/drawingml/2006/main">
+            <a:r>
+              <a:t>A1/A2의 16KiB당 유효 데이터는 4개의 4KiB 논리 요청 전체다. B1/B2는 각 4KiB 논리 페이지의 처음 64B만 읽으므로, 같은 물리 페이지의 4개 논리 영역을 다 사용해도 256B다. 명목 효율은 1/64이며, 실제 구간에서 반환한 Host 바이트와 완료한 NAND 전송량은 구간 경계 및 버퍼 체류 때문에 정확히 64배로 맞지 않을 수 있다. B1의 NAND 처리량은 256.778240GB/s, B2는 256.991232GB/s다. 8MiB와 QD512에서 A1/B1은 같은 4KiB stripe와 head_locality 프로파일 및 동일 매핑을 사용한다. A2는 16KiB stripe/locality, B2는 4KiB stripe/head_locality라 크기만의 효과를 분리한 쌍이 아니다. 작은 요청에 필요 없는 바이트를 더 반환하면 유효 성능이 자동으로 늘어나는 것은 아니다. 같은 물리 페이지에서 실제로 소비하는 데이터량과 재사용률이 중요하다. B3의 이전 32 Plane 유한 요청열 결과를 현재 64 Plane 지속 부하 표에 혼합하지 않았다.</a:t>
+            </a:r>
+          </a:p>
+          <a:p xmlns:a="http://schemas.openxmlformats.org/drawingml/2006/main">
+            <a:r>
+              <a:t/>
+            </a:r>
+          </a:p>
+          <a:p xmlns:a="http://schemas.openxmlformats.org/drawingml/2006/main">
+            <a:r>
+              <a:t>출처</a:t>
+            </a:r>
+          </a:p>
+          <a:p xmlns:a="http://schemas.openxmlformats.org/drawingml/2006/main">
+            <a:r>
+              <a:t>https://github.com/JBRARAPARK/HBF_zNAND_Research/blob/22d9b33f085991f33d5273fdd9ce5688fb429fa4/results/znand/saturation/sweep.csv</a:t>
+            </a:r>
+          </a:p>
+          <a:p xmlns:a="http://schemas.openxmlformats.org/drawingml/2006/main">
+            <a:r>
+              <a:t>https://github.com/JBRARAPARK/HBF_zNAND_Research/blob/22d9b33f085991f33d5273fdd9ce5688fb429fa4/results/znand/partial_saturation/sweep.csv</a:t>
+            </a:r>
+          </a:p>
+          <a:p xmlns:a="http://schemas.openxmlformats.org/drawingml/2006/main">
+            <a:r>
+              <a:t>https://github.com/JBRARAPARK/HBF_zNAND_Research/blob/22d9b33f085991f33d5273fdd9ce5688fb429fa4/results/znand/partial_saturation/RESULTS_KO.md</a:t>
+            </a:r>
+          </a:p>
+          <a:p xmlns:a="http://schemas.openxmlformats.org/drawingml/2006/main">
+            <a:r>
+              <a:t>https://github.com/JBRARAPARK/HBF_zNAND_Research/blob/22d9b33f085991f33d5273fdd9ce5688fb429fa4/results/znand/partial_saturation/reference_validation.json</a:t>
             </a:r>
           </a:p>
         </p:txBody>
@@ -1169,6 +1281,101 @@
 </p:notes>
 </file>
 
+<file path=ppt/notesSlides/notesSlide9.xml><?xml version="1.0" encoding="utf-8"?>
+<p:notes xmlns:p="http://schemas.openxmlformats.org/presentationml/2006/main">
+  <p:cSld>
+    <p:spTree>
+      <p:nvGrpSpPr>
+        <p:cNvPr id="1" name=""/>
+        <p:cNvGrpSpPr/>
+        <p:nvPr/>
+      </p:nvGrpSpPr>
+      <p:grpSpPr>
+        <a:xfrm xmlns:a="http://schemas.openxmlformats.org/drawingml/2006/main"/>
+      </p:grpSpPr>
+      <p:sp>
+        <p:nvSpPr>
+          <p:cNvPr id="2" name="Slide Image Placeholder 1"/>
+          <p:cNvSpPr>
+            <a:spLocks xmlns:a="http://schemas.openxmlformats.org/drawingml/2006/main" noGrp="1"/>
+          </p:cNvSpPr>
+          <p:nvPr>
+            <p:ph type="sldImg" idx="0"/>
+          </p:nvPr>
+        </p:nvSpPr>
+        <p:spPr/>
+      </p:sp>
+      <p:sp>
+        <p:nvSpPr>
+          <p:cNvPr id="3" name="Notes Placeholder 2"/>
+          <p:cNvSpPr>
+            <a:spLocks xmlns:a="http://schemas.openxmlformats.org/drawingml/2006/main" noGrp="1"/>
+          </p:cNvSpPr>
+          <p:nvPr>
+            <p:ph type="body" idx="1"/>
+          </p:nvPr>
+        </p:nvSpPr>
+        <p:spPr/>
+        <p:txBody>
+          <a:bodyPr xmlns:a="http://schemas.openxmlformats.org/drawingml/2006/main"/>
+          <a:lstStyle xmlns:a="http://schemas.openxmlformats.org/drawingml/2006/main"/>
+          <a:p xmlns:a="http://schemas.openxmlformats.org/drawingml/2006/main">
+            <a:r>
+              <a:t>A1은 요청마다 다음 4KiB 논리 페이지를 읽고, A2는 3개 묶음의 0,2,1 순열을 반복한다. 예시의 페이지 번호는 1부터 표시했다. A2/B2는 전체 주소 영역의 균등 난수 접근이 아니다. B1/B2는 각 페이지의 offset 0에서 64B만 반환한다. B3는 3개 논리 페이지 묶음에서 0,2,0,1 순서로 읽고 세 번째 요청에만 offset 64를 적용한다. 그러므로 P1의 첫 64B와 재방문의 두 번째 64B는 다른 데이터지만 동일 논리 페이지에 속하며, 동일 물리 페이지로 매핑될 수 있다. NAND page buffer 또는 Controller buffer에서 재사용할 수 있는지는 그 시점의 상태에 따른다. 항상 hit이나 항상 새 tR을 가정하지 않는다. B3는 기존 유한 요청열 모델에 구현되어 있으나 최근 64 Plane의 2ms 지속 부하 비교에는 포함하지 않았다.</a:t>
+            </a:r>
+          </a:p>
+          <a:p xmlns:a="http://schemas.openxmlformats.org/drawingml/2006/main">
+            <a:r>
+              <a:t/>
+            </a:r>
+          </a:p>
+          <a:p xmlns:a="http://schemas.openxmlformats.org/drawingml/2006/main">
+            <a:r>
+              <a:t>출처</a:t>
+            </a:r>
+          </a:p>
+          <a:p xmlns:a="http://schemas.openxmlformats.org/drawingml/2006/main">
+            <a:r>
+              <a:t>https://github.com/JBRARAPARK/HBF_zNAND_Research/blob/22d9b33f085991f33d5273fdd9ce5688fb429fa4/znand/model.py</a:t>
+            </a:r>
+          </a:p>
+          <a:p xmlns:a="http://schemas.openxmlformats.org/drawingml/2006/main">
+            <a:r>
+              <a:t>https://github.com/JBRARAPARK/HBF_zNAND_Research/blob/22d9b33f085991f33d5273fdd9ce5688fb429fa4/znand/saturation.py</a:t>
+            </a:r>
+          </a:p>
+          <a:p xmlns:a="http://schemas.openxmlformats.org/drawingml/2006/main">
+            <a:r>
+              <a:t>https://github.com/JBRARAPARK/HBF_zNAND_Research/blob/22d9b33f085991f33d5273fdd9ce5688fb429fa4/znand/partial_saturation.py</a:t>
+            </a:r>
+          </a:p>
+        </p:txBody>
+      </p:sp>
+      <p:sp>
+        <p:nvSpPr>
+          <p:cNvPr id="4" name="Slide Number Placeholder 3"/>
+          <p:cNvSpPr>
+            <a:spLocks xmlns:a="http://schemas.openxmlformats.org/drawingml/2006/main" noGrp="1"/>
+          </p:cNvSpPr>
+          <p:nvPr>
+            <p:ph type="sldNum" idx="5"/>
+          </p:nvPr>
+        </p:nvSpPr>
+        <p:spPr/>
+        <p:txBody>
+          <a:bodyPr xmlns:a="http://schemas.openxmlformats.org/drawingml/2006/main"/>
+          <a:lstStyle xmlns:a="http://schemas.openxmlformats.org/drawingml/2006/main"/>
+          <a:p xmlns:a="http://schemas.openxmlformats.org/drawingml/2006/main"/>
+        </p:txBody>
+      </p:sp>
+    </p:spTree>
+  </p:cSld>
+  <p:clrMapOvr>
+    <a:masterClrMapping xmlns:a="http://schemas.openxmlformats.org/drawingml/2006/main"/>
+  </p:clrMapOvr>
+</p:notes>
+</file>
+
 <file path=ppt/slideLayouts/slideLayout1.xml><?xml version="1.0" encoding="utf-8"?>
 <p:sldLayout xmlns:p="http://schemas.openxmlformats.org/presentationml/2006/main" type="title">
   <p:cSld name="Title Slide">
@@ -1186,7 +1393,7 @@
           <p:cNvPr id="3" name="Title">
             <a:extLst xmlns:a="http://schemas.openxmlformats.org/drawingml/2006/main">
               <a:ext uri="{FF2B5EF4-FFF2-40B4-BE49-F238E27FC236}">
-                <a16:creationId xmlns:a16="http://schemas.microsoft.com/office/drawing/2014/main" id="{A2773C5F-39EF-4004-87CD-23D308AB0180}"/>
+                <a16:creationId xmlns:a16="http://schemas.microsoft.com/office/drawing/2014/main" id="{FD0C6BF5-6925-4BDC-B221-1C61FCD25EAE}"/>
               </a:ext>
             </a:extLst>
           </p:cNvPr>
@@ -1343,7 +1550,7 @@
           <p:cNvPr id="2" name="Subtitle">
             <a:extLst xmlns:a="http://schemas.openxmlformats.org/drawingml/2006/main">
               <a:ext uri="{FF2B5EF4-FFF2-40B4-BE49-F238E27FC236}">
-                <a16:creationId xmlns:a16="http://schemas.microsoft.com/office/drawing/2014/main" id="{B5B076E3-25CE-47B8-8574-BA62C773405B}"/>
+                <a16:creationId xmlns:a16="http://schemas.microsoft.com/office/drawing/2014/main" id="{81A20068-658E-4A3C-97C2-0934D0488CA4}"/>
               </a:ext>
             </a:extLst>
           </p:cNvPr>
@@ -1517,7 +1724,7 @@
           <p:cNvPr id="2" name="Section title">
             <a:extLst xmlns:a="http://schemas.openxmlformats.org/drawingml/2006/main">
               <a:ext uri="{FF2B5EF4-FFF2-40B4-BE49-F238E27FC236}">
-                <a16:creationId xmlns:a16="http://schemas.microsoft.com/office/drawing/2014/main" id="{36C0E923-BD43-4427-9683-1C04D0C79838}"/>
+                <a16:creationId xmlns:a16="http://schemas.microsoft.com/office/drawing/2014/main" id="{B602A182-7E0F-46D6-8B71-4D7FF1865536}"/>
               </a:ext>
             </a:extLst>
           </p:cNvPr>
@@ -1691,7 +1898,7 @@
           <p:cNvPr id="3" name="Title">
             <a:extLst xmlns:a="http://schemas.openxmlformats.org/drawingml/2006/main">
               <a:ext uri="{FF2B5EF4-FFF2-40B4-BE49-F238E27FC236}">
-                <a16:creationId xmlns:a16="http://schemas.microsoft.com/office/drawing/2014/main" id="{B68B4EE3-1571-41F5-B97B-1D9AF7FAEF15}"/>
+                <a16:creationId xmlns:a16="http://schemas.microsoft.com/office/drawing/2014/main" id="{1B82C72F-EE21-4FBB-8578-FF31EA70E549}"/>
               </a:ext>
             </a:extLst>
           </p:cNvPr>
@@ -1848,7 +2055,7 @@
           <p:cNvPr id="2" name="Body">
             <a:extLst xmlns:a="http://schemas.openxmlformats.org/drawingml/2006/main">
               <a:ext uri="{FF2B5EF4-FFF2-40B4-BE49-F238E27FC236}">
-                <a16:creationId xmlns:a16="http://schemas.microsoft.com/office/drawing/2014/main" id="{D6DC9912-CB87-4F1E-8209-0FE4007A0457}"/>
+                <a16:creationId xmlns:a16="http://schemas.microsoft.com/office/drawing/2014/main" id="{E8DCF33F-9488-4147-8D0C-408FC5A14298}"/>
               </a:ext>
             </a:extLst>
           </p:cNvPr>
@@ -2022,7 +2229,7 @@
           <p:cNvPr id="4" name="Title">
             <a:extLst xmlns:a="http://schemas.openxmlformats.org/drawingml/2006/main">
               <a:ext uri="{FF2B5EF4-FFF2-40B4-BE49-F238E27FC236}">
-                <a16:creationId xmlns:a16="http://schemas.microsoft.com/office/drawing/2014/main" id="{D25D1394-563D-44D6-8EAC-14F94A3FD2A2}"/>
+                <a16:creationId xmlns:a16="http://schemas.microsoft.com/office/drawing/2014/main" id="{D1173980-01EF-4FF6-B338-3FBE4F102971}"/>
               </a:ext>
             </a:extLst>
           </p:cNvPr>
@@ -2179,7 +2386,7 @@
           <p:cNvPr id="2" name="Left column">
             <a:extLst xmlns:a="http://schemas.openxmlformats.org/drawingml/2006/main">
               <a:ext uri="{FF2B5EF4-FFF2-40B4-BE49-F238E27FC236}">
-                <a16:creationId xmlns:a16="http://schemas.microsoft.com/office/drawing/2014/main" id="{950E7220-2257-4928-8748-4C2767D4807B}"/>
+                <a16:creationId xmlns:a16="http://schemas.microsoft.com/office/drawing/2014/main" id="{F3BAD56A-0F68-44F3-B155-DD21C18384E6}"/>
               </a:ext>
             </a:extLst>
           </p:cNvPr>
@@ -2336,7 +2543,7 @@
           <p:cNvPr id="3" name="Right column">
             <a:extLst xmlns:a="http://schemas.openxmlformats.org/drawingml/2006/main">
               <a:ext uri="{FF2B5EF4-FFF2-40B4-BE49-F238E27FC236}">
-                <a16:creationId xmlns:a16="http://schemas.microsoft.com/office/drawing/2014/main" id="{BBE3D6BF-05A7-453A-A03A-32517BCBEF66}"/>
+                <a16:creationId xmlns:a16="http://schemas.microsoft.com/office/drawing/2014/main" id="{736D6A69-876F-4FFB-ADDC-9EDF6EDA579F}"/>
               </a:ext>
             </a:extLst>
           </p:cNvPr>
@@ -2510,7 +2717,7 @@
           <p:cNvPr id="3" name="Title">
             <a:extLst xmlns:a="http://schemas.openxmlformats.org/drawingml/2006/main">
               <a:ext uri="{FF2B5EF4-FFF2-40B4-BE49-F238E27FC236}">
-                <a16:creationId xmlns:a16="http://schemas.microsoft.com/office/drawing/2014/main" id="{9421E750-8B9F-4536-825A-FB30A926DFF8}"/>
+                <a16:creationId xmlns:a16="http://schemas.microsoft.com/office/drawing/2014/main" id="{1DC5527A-F8B7-492A-8C7B-A2B3FAB9FC20}"/>
               </a:ext>
             </a:extLst>
           </p:cNvPr>
@@ -2667,7 +2874,7 @@
           <p:cNvPr id="2" name="Left column">
             <a:extLst xmlns:a="http://schemas.openxmlformats.org/drawingml/2006/main">
               <a:ext uri="{FF2B5EF4-FFF2-40B4-BE49-F238E27FC236}">
-                <a16:creationId xmlns:a16="http://schemas.microsoft.com/office/drawing/2014/main" id="{15F253DC-2FEF-42B9-9B12-2FC6790D6EAE}"/>
+                <a16:creationId xmlns:a16="http://schemas.microsoft.com/office/drawing/2014/main" id="{EC5293B3-9834-4F30-9011-D7286E722BE9}"/>
               </a:ext>
             </a:extLst>
           </p:cNvPr>
@@ -2862,12 +3069,12 @@
   </p:cSld>
   <p:clrMap bg1="lt1" tx1="dk1" bg2="lt2" tx2="dk2" accent1="accent1" accent2="accent2" accent3="accent3" accent4="accent4" accent5="accent5" accent6="accent6" hlink="hlink" folHlink="folHlink"/>
   <p:sldLayoutIdLst>
-    <p:sldLayoutId xmlns:r="http://schemas.openxmlformats.org/officeDocument/2006/relationships" id="2147483649" r:id="Rd8ec38e252d24bfa"/>
-    <p:sldLayoutId xmlns:r="http://schemas.openxmlformats.org/officeDocument/2006/relationships" id="2147483650" r:id="R54e5acec7a57448c"/>
-    <p:sldLayoutId xmlns:r="http://schemas.openxmlformats.org/officeDocument/2006/relationships" id="2147483651" r:id="R17b87609fe044cb1"/>
-    <p:sldLayoutId xmlns:r="http://schemas.openxmlformats.org/officeDocument/2006/relationships" id="2147483652" r:id="Ra73f6892da814cb9"/>
-    <p:sldLayoutId xmlns:r="http://schemas.openxmlformats.org/officeDocument/2006/relationships" id="2147483653" r:id="R80c6d4cf0a114834"/>
-    <p:sldLayoutId xmlns:r="http://schemas.openxmlformats.org/officeDocument/2006/relationships" id="2147483654" r:id="R19b52d7ff3754848"/>
+    <p:sldLayoutId xmlns:r="http://schemas.openxmlformats.org/officeDocument/2006/relationships" id="2147483649" r:id="Rf2937172dc074926"/>
+    <p:sldLayoutId xmlns:r="http://schemas.openxmlformats.org/officeDocument/2006/relationships" id="2147483650" r:id="Ree239dd1a0bf4ebe"/>
+    <p:sldLayoutId xmlns:r="http://schemas.openxmlformats.org/officeDocument/2006/relationships" id="2147483651" r:id="Rfac25942ecb34a83"/>
+    <p:sldLayoutId xmlns:r="http://schemas.openxmlformats.org/officeDocument/2006/relationships" id="2147483652" r:id="R0202da8d36f149d1"/>
+    <p:sldLayoutId xmlns:r="http://schemas.openxmlformats.org/officeDocument/2006/relationships" id="2147483653" r:id="R62d305d070f7462a"/>
+    <p:sldLayoutId xmlns:r="http://schemas.openxmlformats.org/officeDocument/2006/relationships" id="2147483654" r:id="R286cbfa20b0e4a5b"/>
   </p:sldLayoutIdLst>
   <p:txStyles>
     <p:titleStyle>
@@ -4204,7 +4411,7 @@
     <p:bg>
       <p:bgPr>
         <a:solidFill xmlns:a="http://schemas.openxmlformats.org/drawingml/2006/main">
-          <a:srgbClr val="122C40"/>
+          <a:srgbClr val="FFFFFF"/>
         </a:solidFill>
       </p:bgPr>
     </p:bg>
@@ -4219,10 +4426,10 @@
       </p:grpSpPr>
       <p:sp>
         <p:nvSpPr>
-          <p:cNvPr id="5" name="eyebrow">
+          <p:cNvPr id="7" name="title">
             <a:extLst xmlns:a="http://schemas.openxmlformats.org/drawingml/2006/main">
               <a:ext uri="{FF2B5EF4-FFF2-40B4-BE49-F238E27FC236}">
-                <a16:creationId xmlns:a16="http://schemas.microsoft.com/office/drawing/2014/main" id="{FF9945B9-DC3D-4791-8005-BCBB52793C6D}"/>
+                <a16:creationId xmlns:a16="http://schemas.microsoft.com/office/drawing/2014/main" id="{A6CADAF3-00BC-4EA3-A8ED-572CF9A63DD2}"/>
               </a:ext>
             </a:extLst>
           </p:cNvPr>
@@ -4233,8 +4440,8 @@
         </p:nvSpPr>
         <p:spPr>
           <a:xfrm xmlns:a="http://schemas.openxmlformats.org/drawingml/2006/main">
-            <a:off x="647700" y="733425"/>
-            <a:ext cx="9525000" cy="419100"/>
+            <a:off x="533400" y="438150"/>
+            <a:ext cx="11125200" cy="628650"/>
           </a:xfrm>
           <a:prstGeom xmlns:a="http://schemas.openxmlformats.org/drawingml/2006/main" prst="rect">
             <a:avLst/>
@@ -4250,9 +4457,9 @@
           </a:bodyPr>
           <a:lstStyle xmlns:a="http://schemas.openxmlformats.org/drawingml/2006/main">
             <a:defPPr>
-              <a:defRPr sz="1950" b="0">
-                <a:solidFill>
-                  <a:srgbClr val="AFC8DA"/>
+              <a:defRPr sz="3300" b="1">
+                <a:solidFill>
+                  <a:srgbClr val="172738"/>
                 </a:solidFill>
                 <a:latin typeface="Apple SD Gothic Neo"/>
                 <a:ea typeface="Apple SD Gothic Neo"/>
@@ -4262,9 +4469,9 @@
           </a:lstStyle>
           <a:p xmlns:a="http://schemas.openxmlformats.org/drawingml/2006/main">
             <a:pPr>
-              <a:defRPr sz="1950" b="0">
-                <a:solidFill>
-                  <a:srgbClr val="AFC8DA"/>
+              <a:defRPr sz="3300" b="1">
+                <a:solidFill>
+                  <a:srgbClr val="172738"/>
                 </a:solidFill>
                 <a:latin typeface="Apple SD Gothic Neo"/>
                 <a:ea typeface="Apple SD Gothic Neo"/>
@@ -4272,25 +4479,25 @@
               </a:defRPr>
             </a:pPr>
             <a:r>
-              <a:rPr sz="1950" b="0">
-                <a:solidFill>
-                  <a:srgbClr val="AFC8DA"/>
+              <a:rPr sz="3300" b="1">
+                <a:solidFill>
+                  <a:srgbClr val="172738"/>
                 </a:solidFill>
                 <a:latin typeface="Apple SD Gothic Neo"/>
                 <a:ea typeface="Apple SD Gothic Neo"/>
                 <a:cs typeface="Apple SD Gothic Neo"/>
               </a:rPr>
-              <a:t>zNAND 성능 모델링</a:t>
+              <a:t>전체 구조와 데이터 흐름</a:t>
             </a:r>
           </a:p>
         </p:txBody>
       </p:sp>
       <p:sp>
         <p:nvSpPr>
-          <p:cNvPr id="2" name="cover-title">
+          <p:cNvPr id="2" name="subtitle">
             <a:extLst xmlns:a="http://schemas.openxmlformats.org/drawingml/2006/main">
               <a:ext uri="{FF2B5EF4-FFF2-40B4-BE49-F238E27FC236}">
-                <a16:creationId xmlns:a16="http://schemas.microsoft.com/office/drawing/2014/main" id="{F3AE9E00-7ED2-452D-8CC9-BF4D223F94A4}"/>
+                <a16:creationId xmlns:a16="http://schemas.microsoft.com/office/drawing/2014/main" id="{9A81B3B3-4230-45CF-A65A-99058955A534}"/>
               </a:ext>
             </a:extLst>
           </p:cNvPr>
@@ -4301,167 +4508,8 @@
         </p:nvSpPr>
         <p:spPr>
           <a:xfrm xmlns:a="http://schemas.openxmlformats.org/drawingml/2006/main">
-            <a:off x="609600" y="1838325"/>
-            <a:ext cx="10477500" cy="2000250"/>
-          </a:xfrm>
-          <a:prstGeom xmlns:a="http://schemas.openxmlformats.org/drawingml/2006/main" prst="rect">
-            <a:avLst/>
-          </a:prstGeom>
-          <a:noFill xmlns:a="http://schemas.openxmlformats.org/drawingml/2006/main"/>
-          <a:ln xmlns:a="http://schemas.openxmlformats.org/drawingml/2006/main" w="0">
-            <a:noFill/>
-          </a:ln>
-        </p:spPr>
-        <p:txBody>
-          <a:bodyPr xmlns:a="http://schemas.openxmlformats.org/drawingml/2006/main" wrap="square" lIns="0" tIns="0" rIns="0" bIns="0" anchor="t">
-            <a:noAutofit/>
-          </a:bodyPr>
-          <a:lstStyle xmlns:a="http://schemas.openxmlformats.org/drawingml/2006/main">
-            <a:defPPr>
-              <a:defRPr sz="5400" b="1">
-                <a:solidFill>
-                  <a:srgbClr val="FFFFFF"/>
-                </a:solidFill>
-                <a:latin typeface="Apple SD Gothic Neo"/>
-                <a:ea typeface="Apple SD Gothic Neo"/>
-                <a:cs typeface="Apple SD Gothic Neo"/>
-              </a:defRPr>
-            </a:defPPr>
-          </a:lstStyle>
-          <a:p xmlns:a="http://schemas.openxmlformats.org/drawingml/2006/main">
-            <a:pPr>
-              <a:defRPr sz="5400" b="1">
-                <a:solidFill>
-                  <a:srgbClr val="FFFFFF"/>
-                </a:solidFill>
-                <a:latin typeface="Apple SD Gothic Neo"/>
-                <a:ea typeface="Apple SD Gothic Neo"/>
-                <a:cs typeface="Apple SD Gothic Neo"/>
-              </a:defRPr>
-            </a:pPr>
-            <a:r>
-              <a:rPr sz="5400" b="1">
-                <a:solidFill>
-                  <a:srgbClr val="FFFFFF"/>
-                </a:solidFill>
-                <a:latin typeface="Apple SD Gothic Neo"/>
-                <a:ea typeface="Apple SD Gothic Neo"/>
-                <a:cs typeface="Apple SD Gothic Neo"/>
-              </a:rPr>
-              <a:t>성능 개선</a:t>
-            </a:r>
-          </a:p>
-          <a:p xmlns:a="http://schemas.openxmlformats.org/drawingml/2006/main">
-            <a:pPr>
-              <a:defRPr sz="5400" b="1">
-                <a:solidFill>
-                  <a:srgbClr val="FFFFFF"/>
-                </a:solidFill>
-                <a:latin typeface="Apple SD Gothic Neo"/>
-                <a:ea typeface="Apple SD Gothic Neo"/>
-                <a:cs typeface="Apple SD Gothic Neo"/>
-              </a:defRPr>
-            </a:pPr>
-            <a:r>
-              <a:rPr sz="5400" b="1">
-                <a:solidFill>
-                  <a:srgbClr val="FFFFFF"/>
-                </a:solidFill>
-                <a:latin typeface="Apple SD Gothic Neo"/>
-                <a:ea typeface="Apple SD Gothic Neo"/>
-                <a:cs typeface="Apple SD Gothic Neo"/>
-              </a:rPr>
-              <a:t>핵심 3가지</a:t>
-            </a:r>
-          </a:p>
-        </p:txBody>
-      </p:sp>
-      <p:sp>
-        <p:nvSpPr>
-          <p:cNvPr id="3" name="cover-subtitle">
-            <a:extLst xmlns:a="http://schemas.openxmlformats.org/drawingml/2006/main">
-              <a:ext uri="{FF2B5EF4-FFF2-40B4-BE49-F238E27FC236}">
-                <a16:creationId xmlns:a16="http://schemas.microsoft.com/office/drawing/2014/main" id="{17E923B4-902B-4650-B0C4-FFEA34025CE3}"/>
-              </a:ext>
-            </a:extLst>
-          </p:cNvPr>
-          <p:cNvSpPr>
-            <a:spLocks xmlns:a="http://schemas.openxmlformats.org/drawingml/2006/main" noGrp="1"/>
-          </p:cNvSpPr>
-          <p:nvPr/>
-        </p:nvSpPr>
-        <p:spPr>
-          <a:xfrm xmlns:a="http://schemas.openxmlformats.org/drawingml/2006/main">
-            <a:off x="647700" y="4229100"/>
-            <a:ext cx="10668000" cy="552450"/>
-          </a:xfrm>
-          <a:prstGeom xmlns:a="http://schemas.openxmlformats.org/drawingml/2006/main" prst="rect">
-            <a:avLst/>
-          </a:prstGeom>
-          <a:noFill xmlns:a="http://schemas.openxmlformats.org/drawingml/2006/main"/>
-          <a:ln xmlns:a="http://schemas.openxmlformats.org/drawingml/2006/main" w="0">
-            <a:noFill/>
-          </a:ln>
-        </p:spPr>
-        <p:txBody>
-          <a:bodyPr xmlns:a="http://schemas.openxmlformats.org/drawingml/2006/main" wrap="square" lIns="0" tIns="0" rIns="0" bIns="0" anchor="t">
-            <a:noAutofit/>
-          </a:bodyPr>
-          <a:lstStyle xmlns:a="http://schemas.openxmlformats.org/drawingml/2006/main">
-            <a:defPPr>
-              <a:defRPr sz="2100" b="0">
-                <a:solidFill>
-                  <a:srgbClr val="DBE7EF"/>
-                </a:solidFill>
-                <a:latin typeface="Apple SD Gothic Neo"/>
-                <a:ea typeface="Apple SD Gothic Neo"/>
-                <a:cs typeface="Apple SD Gothic Neo"/>
-              </a:defRPr>
-            </a:defPPr>
-          </a:lstStyle>
-          <a:p xmlns:a="http://schemas.openxmlformats.org/drawingml/2006/main">
-            <a:pPr>
-              <a:defRPr sz="2100" b="0">
-                <a:solidFill>
-                  <a:srgbClr val="DBE7EF"/>
-                </a:solidFill>
-                <a:latin typeface="Apple SD Gothic Neo"/>
-                <a:ea typeface="Apple SD Gothic Neo"/>
-                <a:cs typeface="Apple SD Gothic Neo"/>
-              </a:defRPr>
-            </a:pPr>
-            <a:r>
-              <a:rPr sz="2100" b="0">
-                <a:solidFill>
-                  <a:srgbClr val="DBE7EF"/>
-                </a:solidFill>
-                <a:latin typeface="Apple SD Gothic Neo"/>
-                <a:ea typeface="Apple SD Gothic Neo"/>
-                <a:cs typeface="Apple SD Gothic Neo"/>
-              </a:rPr>
-              <a:t>컨트롤러 스케줄링, 물리 배치, 버퍼와 Outstanding</a:t>
-            </a:r>
-          </a:p>
-        </p:txBody>
-      </p:sp>
-      <p:sp>
-        <p:nvSpPr>
-          <p:cNvPr id="4" name="cover-scope">
-            <a:extLst xmlns:a="http://schemas.openxmlformats.org/drawingml/2006/main">
-              <a:ext uri="{FF2B5EF4-FFF2-40B4-BE49-F238E27FC236}">
-                <a16:creationId xmlns:a16="http://schemas.microsoft.com/office/drawing/2014/main" id="{58296B08-080D-4739-B67E-243CB0DE06B1}"/>
-              </a:ext>
-            </a:extLst>
-          </p:cNvPr>
-          <p:cNvSpPr>
-            <a:spLocks xmlns:a="http://schemas.openxmlformats.org/drawingml/2006/main" noGrp="1"/>
-          </p:cNvSpPr>
-          <p:nvPr/>
-        </p:nvSpPr>
-        <p:spPr>
-          <a:xfrm xmlns:a="http://schemas.openxmlformats.org/drawingml/2006/main">
-            <a:off x="647700" y="5391150"/>
-            <a:ext cx="10001250" cy="666750"/>
+            <a:off x="552450" y="1104900"/>
+            <a:ext cx="11087100" cy="571500"/>
           </a:xfrm>
           <a:prstGeom xmlns:a="http://schemas.openxmlformats.org/drawingml/2006/main" prst="rect">
             <a:avLst/>
@@ -4479,7 +4527,7 @@
             <a:defPPr>
               <a:defRPr sz="1800" b="0">
                 <a:solidFill>
-                  <a:srgbClr val="AFC8DA"/>
+                  <a:srgbClr val="586875"/>
                 </a:solidFill>
                 <a:latin typeface="Apple SD Gothic Neo"/>
                 <a:ea typeface="Apple SD Gothic Neo"/>
@@ -4491,7 +4539,7 @@
             <a:pPr>
               <a:defRPr sz="1800" b="0">
                 <a:solidFill>
-                  <a:srgbClr val="AFC8DA"/>
+                  <a:srgbClr val="586875"/>
                 </a:solidFill>
                 <a:latin typeface="Apple SD Gothic Neo"/>
                 <a:ea typeface="Apple SD Gothic Neo"/>
@@ -4501,20 +4549,65 @@
             <a:r>
               <a:rPr sz="1800" b="0">
                 <a:solidFill>
-                  <a:srgbClr val="AFC8DA"/>
+                  <a:srgbClr val="586875"/>
                 </a:solidFill>
                 <a:latin typeface="Apple SD Gothic Neo"/>
                 <a:ea typeface="Apple SD Gothic Neo"/>
                 <a:cs typeface="Apple SD Gothic Neo"/>
               </a:rPr>
-              <a:t>기존 실험 결과와 동작 원리</a:t>
-            </a:r>
-          </a:p>
+              <a:t>4개의 독립 Port가 4채널 전체를 공유하며, 읽기 주소가 Channel과 Plane을 결정합니다.</a:t>
+            </a:r>
+          </a:p>
+        </p:txBody>
+      </p:sp>
+      <p:sp>
+        <p:nvSpPr>
+          <p:cNvPr id="3" name="footer">
+            <a:extLst xmlns:a="http://schemas.openxmlformats.org/drawingml/2006/main">
+              <a:ext uri="{FF2B5EF4-FFF2-40B4-BE49-F238E27FC236}">
+                <a16:creationId xmlns:a16="http://schemas.microsoft.com/office/drawing/2014/main" id="{9E3665FE-02F5-4E50-961A-840098871DD6}"/>
+              </a:ext>
+            </a:extLst>
+          </p:cNvPr>
+          <p:cNvSpPr>
+            <a:spLocks xmlns:a="http://schemas.openxmlformats.org/drawingml/2006/main" noGrp="1"/>
+          </p:cNvSpPr>
+          <p:nvPr/>
+        </p:nvSpPr>
+        <p:spPr>
+          <a:xfrm xmlns:a="http://schemas.openxmlformats.org/drawingml/2006/main">
+            <a:off x="533400" y="6419850"/>
+            <a:ext cx="10477500" cy="257175"/>
+          </a:xfrm>
+          <a:prstGeom xmlns:a="http://schemas.openxmlformats.org/drawingml/2006/main" prst="rect">
+            <a:avLst/>
+          </a:prstGeom>
+          <a:noFill xmlns:a="http://schemas.openxmlformats.org/drawingml/2006/main"/>
+          <a:ln xmlns:a="http://schemas.openxmlformats.org/drawingml/2006/main" w="0">
+            <a:noFill/>
+          </a:ln>
+        </p:spPr>
+        <p:txBody>
+          <a:bodyPr xmlns:a="http://schemas.openxmlformats.org/drawingml/2006/main" wrap="square" lIns="0" tIns="0" rIns="0" bIns="0" anchor="t">
+            <a:noAutofit/>
+          </a:bodyPr>
+          <a:lstStyle xmlns:a="http://schemas.openxmlformats.org/drawingml/2006/main">
+            <a:defPPr>
+              <a:defRPr sz="1200" b="0">
+                <a:solidFill>
+                  <a:srgbClr val="586875"/>
+                </a:solidFill>
+                <a:latin typeface="Apple SD Gothic Neo"/>
+                <a:ea typeface="Apple SD Gothic Neo"/>
+                <a:cs typeface="Apple SD Gothic Neo"/>
+              </a:defRPr>
+            </a:defPPr>
+          </a:lstStyle>
           <a:p xmlns:a="http://schemas.openxmlformats.org/drawingml/2006/main">
             <a:pPr>
-              <a:defRPr sz="1800" b="0">
-                <a:solidFill>
-                  <a:srgbClr val="AFC8DA"/>
+              <a:defRPr sz="1200" b="0">
+                <a:solidFill>
+                  <a:srgbClr val="586875"/>
                 </a:solidFill>
                 <a:latin typeface="Apple SD Gothic Neo"/>
                 <a:ea typeface="Apple SD Gothic Neo"/>
@@ -4522,15 +4615,728 @@
               </a:defRPr>
             </a:pPr>
             <a:r>
-              <a:rPr sz="1800" b="0">
-                <a:solidFill>
-                  <a:srgbClr val="AFC8DA"/>
+              <a:rPr sz="1200" b="0">
+                <a:solidFill>
+                  <a:srgbClr val="586875"/>
                 </a:solidFill>
                 <a:latin typeface="Apple SD Gothic Neo"/>
                 <a:ea typeface="Apple SD Gothic Neo"/>
                 <a:cs typeface="Apple SD Gothic Neo"/>
               </a:rPr>
-              <a:t>2026년 10월 11일 기준</a:t>
+              <a:t>성능 개선 핵심 3가지    2026-10-11    현재 대표 실행 기준: 총 64 Plane, PF OFF</a:t>
+            </a:r>
+          </a:p>
+        </p:txBody>
+      </p:sp>
+      <p:sp>
+        <p:nvSpPr>
+          <p:cNvPr id="4" name="page">
+            <a:extLst xmlns:a="http://schemas.openxmlformats.org/drawingml/2006/main">
+              <a:ext uri="{FF2B5EF4-FFF2-40B4-BE49-F238E27FC236}">
+                <a16:creationId xmlns:a16="http://schemas.microsoft.com/office/drawing/2014/main" id="{B055A781-DE0D-4C17-8FB0-0C0CB327DE84}"/>
+              </a:ext>
+            </a:extLst>
+          </p:cNvPr>
+          <p:cNvSpPr>
+            <a:spLocks xmlns:a="http://schemas.openxmlformats.org/drawingml/2006/main" noGrp="1"/>
+          </p:cNvSpPr>
+          <p:nvPr/>
+        </p:nvSpPr>
+        <p:spPr>
+          <a:xfrm xmlns:a="http://schemas.openxmlformats.org/drawingml/2006/main">
+            <a:off x="11144250" y="6419850"/>
+            <a:ext cx="495300" cy="257175"/>
+          </a:xfrm>
+          <a:prstGeom xmlns:a="http://schemas.openxmlformats.org/drawingml/2006/main" prst="rect">
+            <a:avLst/>
+          </a:prstGeom>
+          <a:noFill xmlns:a="http://schemas.openxmlformats.org/drawingml/2006/main"/>
+          <a:ln xmlns:a="http://schemas.openxmlformats.org/drawingml/2006/main" w="0">
+            <a:noFill/>
+          </a:ln>
+        </p:spPr>
+        <p:txBody>
+          <a:bodyPr xmlns:a="http://schemas.openxmlformats.org/drawingml/2006/main" wrap="square" lIns="0" tIns="0" rIns="0" bIns="0" anchor="t">
+            <a:noAutofit/>
+          </a:bodyPr>
+          <a:lstStyle xmlns:a="http://schemas.openxmlformats.org/drawingml/2006/main">
+            <a:defPPr>
+              <a:defRPr sz="1200" b="0">
+                <a:solidFill>
+                  <a:srgbClr val="586875"/>
+                </a:solidFill>
+                <a:latin typeface="Apple SD Gothic Neo"/>
+                <a:ea typeface="Apple SD Gothic Neo"/>
+                <a:cs typeface="Apple SD Gothic Neo"/>
+              </a:defRPr>
+            </a:defPPr>
+          </a:lstStyle>
+          <a:p xmlns:a="http://schemas.openxmlformats.org/drawingml/2006/main">
+            <a:pPr>
+              <a:defRPr sz="1200" b="0">
+                <a:solidFill>
+                  <a:srgbClr val="586875"/>
+                </a:solidFill>
+                <a:latin typeface="Apple SD Gothic Neo"/>
+                <a:ea typeface="Apple SD Gothic Neo"/>
+                <a:cs typeface="Apple SD Gothic Neo"/>
+              </a:defRPr>
+            </a:pPr>
+            <a:r>
+              <a:rPr sz="1200" b="0">
+                <a:solidFill>
+                  <a:srgbClr val="586875"/>
+                </a:solidFill>
+                <a:latin typeface="Apple SD Gothic Neo"/>
+                <a:ea typeface="Apple SD Gothic Neo"/>
+                <a:cs typeface="Apple SD Gothic Neo"/>
+              </a:rPr>
+              <a:t>01</a:t>
+            </a:r>
+          </a:p>
+        </p:txBody>
+      </p:sp>
+      <p:graphicFrame>
+        <p:nvGraphicFramePr>
+          <p:cNvPr id="5" name="model-architecture">
+            <a:extLst xmlns:a="http://schemas.openxmlformats.org/drawingml/2006/main">
+              <a:ext uri="{FF2B5EF4-FFF2-40B4-BE49-F238E27FC236}">
+                <a16:creationId xmlns:a16="http://schemas.microsoft.com/office/drawing/2014/main" id="{632AFC34-CA54-49B7-A1CA-26C4DB6C0260}"/>
+              </a:ext>
+            </a:extLst>
+          </p:cNvPr>
+          <p:cNvGraphicFramePr/>
+          <p:nvPr/>
+        </p:nvGraphicFramePr>
+        <p:xfrm>
+          <a:off xmlns:a="http://schemas.openxmlformats.org/drawingml/2006/main" x="533400" y="1752600"/>
+          <a:ext xmlns:a="http://schemas.openxmlformats.org/drawingml/2006/main" cx="11125200" cy="4171950"/>
+        </p:xfrm>
+        <a:graphic xmlns:a="http://schemas.openxmlformats.org/drawingml/2006/main">
+          <a:graphicData uri="http://schemas.openxmlformats.org/drawingml/2006/table">
+            <a:tbl>
+              <a:tblPr/>
+              <a:tblGrid>
+                <a:gridCol w="2171700"/>
+                <a:gridCol w="5372100"/>
+                <a:gridCol w="3581400"/>
+              </a:tblGrid>
+              <a:tr h="695325">
+                <a:tc>
+                  <a:txBody>
+                    <a:bodyPr lIns="114300" tIns="114300" rIns="114300" bIns="114300"/>
+                    <a:lstStyle/>
+                    <a:p>
+                      <a:r>
+                        <a:rPr sz="1725" b="1">
+                          <a:solidFill>
+                            <a:srgbClr val="FFFFFF"/>
+                          </a:solidFill>
+                          <a:latin typeface="Apple SD Gothic Neo"/>
+                          <a:ea typeface="Apple SD Gothic Neo"/>
+                          <a:cs typeface="Apple SD Gothic Neo"/>
+                        </a:rPr>
+                        <a:t>처리 구간</a:t>
+                      </a:r>
+                    </a:p>
+                  </a:txBody>
+                  <a:tcPr marL="133350" marR="133350" marT="95250" marB="95250" anchor="ctr">
+                    <a:solidFill>
+                      <a:srgbClr val="122C40"/>
+                    </a:solidFill>
+                  </a:tcPr>
+                </a:tc>
+                <a:tc>
+                  <a:txBody>
+                    <a:bodyPr lIns="114300" tIns="114300" rIns="114300" bIns="114300"/>
+                    <a:lstStyle/>
+                    <a:p>
+                      <a:r>
+                        <a:rPr sz="1725" b="1">
+                          <a:solidFill>
+                            <a:srgbClr val="FFFFFF"/>
+                          </a:solidFill>
+                          <a:latin typeface="Apple SD Gothic Neo"/>
+                          <a:ea typeface="Apple SD Gothic Neo"/>
+                          <a:cs typeface="Apple SD Gothic Neo"/>
+                        </a:rPr>
+                        <a:t>주요 동작</a:t>
+                      </a:r>
+                    </a:p>
+                  </a:txBody>
+                  <a:tcPr marL="133350" marR="133350" marT="95250" marB="95250" anchor="ctr">
+                    <a:solidFill>
+                      <a:srgbClr val="122C40"/>
+                    </a:solidFill>
+                  </a:tcPr>
+                </a:tc>
+                <a:tc>
+                  <a:txBody>
+                    <a:bodyPr lIns="114300" tIns="114300" rIns="114300" bIns="114300"/>
+                    <a:lstStyle/>
+                    <a:p>
+                      <a:r>
+                        <a:rPr sz="1725" b="1">
+                          <a:solidFill>
+                            <a:srgbClr val="FFFFFF"/>
+                          </a:solidFill>
+                          <a:latin typeface="Apple SD Gothic Neo"/>
+                          <a:ea typeface="Apple SD Gothic Neo"/>
+                          <a:cs typeface="Apple SD Gothic Neo"/>
+                        </a:rPr>
+                        <a:t>자원과 순서 규칙</a:t>
+                      </a:r>
+                    </a:p>
+                  </a:txBody>
+                  <a:tcPr marL="133350" marR="133350" marT="95250" marB="95250" anchor="ctr">
+                    <a:solidFill>
+                      <a:srgbClr val="122C40"/>
+                    </a:solidFill>
+                  </a:tcPr>
+                </a:tc>
+              </a:tr>
+              <a:tr h="695325">
+                <a:tc>
+                  <a:txBody>
+                    <a:bodyPr lIns="114300" tIns="114300" rIns="114300" bIns="114300"/>
+                    <a:lstStyle/>
+                    <a:p>
+                      <a:r>
+                        <a:rPr sz="1725" b="0">
+                          <a:solidFill>
+                            <a:srgbClr val="172738"/>
+                          </a:solidFill>
+                          <a:latin typeface="Apple SD Gothic Neo"/>
+                          <a:ea typeface="Apple SD Gothic Neo"/>
+                          <a:cs typeface="Apple SD Gothic Neo"/>
+                        </a:rPr>
+                        <a:t>1. Host IF</a:t>
+                      </a:r>
+                    </a:p>
+                  </a:txBody>
+                  <a:tcPr marL="133350" marR="133350" marT="95250" marB="95250" anchor="ctr">
+                    <a:solidFill>
+                      <a:srgbClr val="FFFFFF"/>
+                    </a:solidFill>
+                  </a:tcPr>
+                </a:tc>
+                <a:tc>
+                  <a:txBody>
+                    <a:bodyPr lIns="114300" tIns="114300" rIns="114300" bIns="114300"/>
+                    <a:lstStyle/>
+                    <a:p>
+                      <a:r>
+                        <a:rPr sz="1725" b="0">
+                          <a:solidFill>
+                            <a:srgbClr val="172738"/>
+                          </a:solidFill>
+                          <a:latin typeface="Apple SD Gothic Neo"/>
+                          <a:ea typeface="Apple SD Gothic Neo"/>
+                          <a:cs typeface="Apple SD Gothic Neo"/>
+                        </a:rPr>
+                        <a:t>Port 0–3에서 독립적으로 읽기 요청</a:t>
+                      </a:r>
+                    </a:p>
+                  </a:txBody>
+                  <a:tcPr marL="133350" marR="133350" marT="95250" marB="95250" anchor="ctr">
+                    <a:solidFill>
+                      <a:srgbClr val="FFFFFF"/>
+                    </a:solidFill>
+                  </a:tcPr>
+                </a:tc>
+                <a:tc>
+                  <a:txBody>
+                    <a:bodyPr lIns="114300" tIns="114300" rIns="114300" bIns="114300"/>
+                    <a:lstStyle/>
+                    <a:p>
+                      <a:r>
+                        <a:rPr sz="1725" b="0">
+                          <a:solidFill>
+                            <a:srgbClr val="172738"/>
+                          </a:solidFill>
+                          <a:latin typeface="Apple SD Gothic Neo"/>
+                          <a:ea typeface="Apple SD Gothic Neo"/>
+                          <a:cs typeface="Apple SD Gothic Neo"/>
+                        </a:rPr>
+                        <a:t>Port당 64GB/s</a:t>
+                      </a:r>
+                    </a:p>
+                    <a:p>
+                      <a:r>
+                        <a:rPr sz="1725" b="0">
+                          <a:solidFill>
+                            <a:srgbClr val="172738"/>
+                          </a:solidFill>
+                          <a:latin typeface="Apple SD Gothic Neo"/>
+                          <a:ea typeface="Apple SD Gothic Neo"/>
+                          <a:cs typeface="Apple SD Gothic Neo"/>
+                        </a:rPr>
+                        <a:t>합계 256GB/s</a:t>
+                      </a:r>
+                    </a:p>
+                  </a:txBody>
+                  <a:tcPr marL="133350" marR="133350" marT="95250" marB="95250" anchor="ctr">
+                    <a:solidFill>
+                      <a:srgbClr val="FFFFFF"/>
+                    </a:solidFill>
+                  </a:tcPr>
+                </a:tc>
+              </a:tr>
+              <a:tr h="695325">
+                <a:tc>
+                  <a:txBody>
+                    <a:bodyPr lIns="114300" tIns="114300" rIns="114300" bIns="114300"/>
+                    <a:lstStyle/>
+                    <a:p>
+                      <a:r>
+                        <a:rPr sz="1725" b="0">
+                          <a:solidFill>
+                            <a:srgbClr val="172738"/>
+                          </a:solidFill>
+                          <a:latin typeface="Apple SD Gothic Neo"/>
+                          <a:ea typeface="Apple SD Gothic Neo"/>
+                          <a:cs typeface="Apple SD Gothic Neo"/>
+                        </a:rPr>
+                        <a:t>2. Controller 수락</a:t>
+                      </a:r>
+                    </a:p>
+                  </a:txBody>
+                  <a:tcPr marL="133350" marR="133350" marT="95250" marB="95250" anchor="ctr">
+                    <a:solidFill>
+                      <a:srgbClr val="F1F5F8"/>
+                    </a:solidFill>
+                  </a:tcPr>
+                </a:tc>
+                <a:tc>
+                  <a:txBody>
+                    <a:bodyPr lIns="114300" tIns="114300" rIns="114300" bIns="114300"/>
+                    <a:lstStyle/>
+                    <a:p>
+                      <a:r>
+                        <a:rPr sz="1725" b="0">
+                          <a:solidFill>
+                            <a:srgbClr val="172738"/>
+                          </a:solidFill>
+                          <a:latin typeface="Apple SD Gothic Neo"/>
+                          <a:ea typeface="Apple SD Gothic Neo"/>
+                          <a:cs typeface="Apple SD Gothic Neo"/>
+                        </a:rPr>
+                        <a:t>Port별 QD 확인, 공유 버퍼 예약</a:t>
+                      </a:r>
+                    </a:p>
+                    <a:p>
+                      <a:r>
+                        <a:rPr sz="1725" b="0">
+                          <a:solidFill>
+                            <a:srgbClr val="172738"/>
+                          </a:solidFill>
+                          <a:latin typeface="Apple SD Gothic Neo"/>
+                          <a:ea typeface="Apple SD Gothic Neo"/>
+                          <a:cs typeface="Apple SD Gothic Neo"/>
+                        </a:rPr>
+                        <a:t>L2P 조회로 물리 주소 확인</a:t>
+                      </a:r>
+                    </a:p>
+                  </a:txBody>
+                  <a:tcPr marL="133350" marR="133350" marT="95250" marB="95250" anchor="ctr">
+                    <a:solidFill>
+                      <a:srgbClr val="F1F5F8"/>
+                    </a:solidFill>
+                  </a:tcPr>
+                </a:tc>
+                <a:tc>
+                  <a:txBody>
+                    <a:bodyPr lIns="114300" tIns="114300" rIns="114300" bIns="114300"/>
+                    <a:lstStyle/>
+                    <a:p>
+                      <a:r>
+                        <a:rPr sz="1725" b="0">
+                          <a:solidFill>
+                            <a:srgbClr val="172738"/>
+                          </a:solidFill>
+                          <a:latin typeface="Apple SD Gothic Neo"/>
+                          <a:ea typeface="Apple SD Gothic Neo"/>
+                          <a:cs typeface="Apple SD Gothic Neo"/>
+                        </a:rPr>
+                        <a:t>대표 설정: 8MiB</a:t>
+                      </a:r>
+                    </a:p>
+                    <a:p>
+                      <a:r>
+                        <a:rPr sz="1725" b="0">
+                          <a:solidFill>
+                            <a:srgbClr val="172738"/>
+                          </a:solidFill>
+                          <a:latin typeface="Apple SD Gothic Neo"/>
+                          <a:ea typeface="Apple SD Gothic Neo"/>
+                          <a:cs typeface="Apple SD Gothic Neo"/>
+                        </a:rPr>
+                        <a:t>QD 512/Port</a:t>
+                      </a:r>
+                    </a:p>
+                  </a:txBody>
+                  <a:tcPr marL="133350" marR="133350" marT="95250" marB="95250" anchor="ctr">
+                    <a:solidFill>
+                      <a:srgbClr val="F1F5F8"/>
+                    </a:solidFill>
+                  </a:tcPr>
+                </a:tc>
+              </a:tr>
+              <a:tr h="695325">
+                <a:tc>
+                  <a:txBody>
+                    <a:bodyPr lIns="114300" tIns="114300" rIns="114300" bIns="114300"/>
+                    <a:lstStyle/>
+                    <a:p>
+                      <a:r>
+                        <a:rPr sz="1725" b="0">
+                          <a:solidFill>
+                            <a:srgbClr val="172738"/>
+                          </a:solidFill>
+                          <a:latin typeface="Apple SD Gothic Neo"/>
+                          <a:ea typeface="Apple SD Gothic Neo"/>
+                          <a:cs typeface="Apple SD Gothic Neo"/>
+                        </a:rPr>
+                        <a:t>3. CA 스케줄링</a:t>
+                      </a:r>
+                    </a:p>
+                  </a:txBody>
+                  <a:tcPr marL="133350" marR="133350" marT="95250" marB="95250" anchor="ctr">
+                    <a:solidFill>
+                      <a:srgbClr val="FFFFFF"/>
+                    </a:solidFill>
+                  </a:tcPr>
+                </a:tc>
+                <a:tc>
+                  <a:txBody>
+                    <a:bodyPr lIns="114300" tIns="114300" rIns="114300" bIns="114300"/>
+                    <a:lstStyle/>
+                    <a:p>
+                      <a:r>
+                        <a:rPr sz="1725" b="0">
+                          <a:solidFill>
+                            <a:srgbClr val="172738"/>
+                          </a:solidFill>
+                          <a:latin typeface="Apple SD Gothic Neo"/>
+                          <a:ea typeface="Apple SD Gothic Neo"/>
+                          <a:cs typeface="Apple SD Gothic Neo"/>
+                        </a:rPr>
+                        <a:t>발행 가능한 물리 페이지의 처리 순서 선택</a:t>
+                      </a:r>
+                    </a:p>
+                  </a:txBody>
+                  <a:tcPr marL="133350" marR="133350" marT="95250" marB="95250" anchor="ctr">
+                    <a:solidFill>
+                      <a:srgbClr val="FFFFFF"/>
+                    </a:solidFill>
+                  </a:tcPr>
+                </a:tc>
+                <a:tc>
+                  <a:txBody>
+                    <a:bodyPr lIns="114300" tIns="114300" rIns="114300" bIns="114300"/>
+                    <a:lstStyle/>
+                    <a:p>
+                      <a:r>
+                        <a:rPr sz="1725" b="0">
+                          <a:solidFill>
+                            <a:srgbClr val="172738"/>
+                          </a:solidFill>
+                          <a:latin typeface="Apple SD Gothic Neo"/>
+                          <a:ea typeface="Apple SD Gothic Neo"/>
+                          <a:cs typeface="Apple SD Gothic Neo"/>
+                        </a:rPr>
+                        <a:t>연속 주소 우선</a:t>
+                      </a:r>
+                    </a:p>
+                    <a:p>
+                      <a:r>
+                        <a:rPr sz="1725" b="0">
+                          <a:solidFill>
+                            <a:srgbClr val="172738"/>
+                          </a:solidFill>
+                          <a:latin typeface="Apple SD Gothic Neo"/>
+                          <a:ea typeface="Apple SD Gothic Neo"/>
+                          <a:cs typeface="Apple SD Gothic Neo"/>
+                        </a:rPr>
+                        <a:t>필요 시 Port 선두 우선</a:t>
+                      </a:r>
+                    </a:p>
+                  </a:txBody>
+                  <a:tcPr marL="133350" marR="133350" marT="95250" marB="95250" anchor="ctr">
+                    <a:solidFill>
+                      <a:srgbClr val="FFFFFF"/>
+                    </a:solidFill>
+                  </a:tcPr>
+                </a:tc>
+              </a:tr>
+              <a:tr h="695325">
+                <a:tc>
+                  <a:txBody>
+                    <a:bodyPr lIns="114300" tIns="114300" rIns="114300" bIns="114300"/>
+                    <a:lstStyle/>
+                    <a:p>
+                      <a:r>
+                        <a:rPr sz="1725" b="0">
+                          <a:solidFill>
+                            <a:srgbClr val="172738"/>
+                          </a:solidFill>
+                          <a:latin typeface="Apple SD Gothic Neo"/>
+                          <a:ea typeface="Apple SD Gothic Neo"/>
+                          <a:cs typeface="Apple SD Gothic Neo"/>
+                        </a:rPr>
+                        <a:t>4. NAND Read</a:t>
+                      </a:r>
+                    </a:p>
+                  </a:txBody>
+                  <a:tcPr marL="133350" marR="133350" marT="95250" marB="95250" anchor="ctr">
+                    <a:solidFill>
+                      <a:srgbClr val="F1F5F8"/>
+                    </a:solidFill>
+                  </a:tcPr>
+                </a:tc>
+                <a:tc>
+                  <a:txBody>
+                    <a:bodyPr lIns="114300" tIns="114300" rIns="114300" bIns="114300"/>
+                    <a:lstStyle/>
+                    <a:p>
+                      <a:r>
+                        <a:rPr sz="1725" b="0">
+                          <a:solidFill>
+                            <a:srgbClr val="172738"/>
+                          </a:solidFill>
+                          <a:latin typeface="Apple SD Gothic Neo"/>
+                          <a:ea typeface="Apple SD Gothic Neo"/>
+                          <a:cs typeface="Apple SD Gothic Neo"/>
+                        </a:rPr>
+                        <a:t>4채널 × 16Plane에서 sensing</a:t>
+                      </a:r>
+                    </a:p>
+                    <a:p>
+                      <a:r>
+                        <a:rPr sz="1725" b="0">
+                          <a:solidFill>
+                            <a:srgbClr val="172738"/>
+                          </a:solidFill>
+                          <a:latin typeface="Apple SD Gothic Neo"/>
+                          <a:ea typeface="Apple SD Gothic Neo"/>
+                          <a:cs typeface="Apple SD Gothic Neo"/>
+                        </a:rPr>
+                        <a:t>물리 페이지 크기는 16KiB</a:t>
+                      </a:r>
+                    </a:p>
+                  </a:txBody>
+                  <a:tcPr marL="133350" marR="133350" marT="95250" marB="95250" anchor="ctr">
+                    <a:solidFill>
+                      <a:srgbClr val="F1F5F8"/>
+                    </a:solidFill>
+                  </a:tcPr>
+                </a:tc>
+                <a:tc>
+                  <a:txBody>
+                    <a:bodyPr lIns="114300" tIns="114300" rIns="114300" bIns="114300"/>
+                    <a:lstStyle/>
+                    <a:p>
+                      <a:r>
+                        <a:rPr sz="1725" b="0">
+                          <a:solidFill>
+                            <a:srgbClr val="172738"/>
+                          </a:solidFill>
+                          <a:latin typeface="Apple SD Gothic Neo"/>
+                          <a:ea typeface="Apple SD Gothic Neo"/>
+                          <a:cs typeface="Apple SD Gothic Neo"/>
+                        </a:rPr>
+                        <a:t>Plane당 page buffer 1개</a:t>
+                      </a:r>
+                    </a:p>
+                    <a:p>
+                      <a:r>
+                        <a:rPr sz="1725" b="0">
+                          <a:solidFill>
+                            <a:srgbClr val="172738"/>
+                          </a:solidFill>
+                          <a:latin typeface="Apple SD Gothic Neo"/>
+                          <a:ea typeface="Apple SD Gothic Neo"/>
+                          <a:cs typeface="Apple SD Gothic Neo"/>
+                        </a:rPr>
+                        <a:t>채널별 CA와 Data 경로</a:t>
+                      </a:r>
+                    </a:p>
+                  </a:txBody>
+                  <a:tcPr marL="133350" marR="133350" marT="95250" marB="95250" anchor="ctr">
+                    <a:solidFill>
+                      <a:srgbClr val="F1F5F8"/>
+                    </a:solidFill>
+                  </a:tcPr>
+                </a:tc>
+              </a:tr>
+              <a:tr h="695325">
+                <a:tc>
+                  <a:txBody>
+                    <a:bodyPr lIns="114300" tIns="114300" rIns="114300" bIns="114300"/>
+                    <a:lstStyle/>
+                    <a:p>
+                      <a:r>
+                        <a:rPr sz="1725" b="0">
+                          <a:solidFill>
+                            <a:srgbClr val="172738"/>
+                          </a:solidFill>
+                          <a:latin typeface="Apple SD Gothic Neo"/>
+                          <a:ea typeface="Apple SD Gothic Neo"/>
+                          <a:cs typeface="Apple SD Gothic Neo"/>
+                        </a:rPr>
+                        <a:t>5. Data와 반환</a:t>
+                      </a:r>
+                    </a:p>
+                  </a:txBody>
+                  <a:tcPr marL="133350" marR="133350" marT="95250" marB="95250" anchor="ctr">
+                    <a:solidFill>
+                      <a:srgbClr val="FFFFFF"/>
+                    </a:solidFill>
+                  </a:tcPr>
+                </a:tc>
+                <a:tc>
+                  <a:txBody>
+                    <a:bodyPr lIns="114300" tIns="114300" rIns="114300" bIns="114300"/>
+                    <a:lstStyle/>
+                    <a:p>
+                      <a:r>
+                        <a:rPr sz="1725" b="0">
+                          <a:solidFill>
+                            <a:srgbClr val="172738"/>
+                          </a:solidFill>
+                          <a:latin typeface="Apple SD Gothic Neo"/>
+                          <a:ea typeface="Apple SD Gothic Neo"/>
+                          <a:cs typeface="Apple SD Gothic Neo"/>
+                        </a:rPr>
+                        <a:t>NAND 출력과 ECC 후 Controller buffer 준비</a:t>
+                      </a:r>
+                    </a:p>
+                    <a:p>
+                      <a:r>
+                        <a:rPr sz="1725" b="0">
+                          <a:solidFill>
+                            <a:srgbClr val="172738"/>
+                          </a:solidFill>
+                          <a:latin typeface="Apple SD Gothic Neo"/>
+                          <a:ea typeface="Apple SD Gothic Neo"/>
+                          <a:cs typeface="Apple SD Gothic Neo"/>
+                        </a:rPr>
+                        <a:t>Port별로 Host에 읽기 데이터 반환</a:t>
+                      </a:r>
+                    </a:p>
+                  </a:txBody>
+                  <a:tcPr marL="133350" marR="133350" marT="95250" marB="95250" anchor="ctr">
+                    <a:solidFill>
+                      <a:srgbClr val="FFFFFF"/>
+                    </a:solidFill>
+                  </a:tcPr>
+                </a:tc>
+                <a:tc>
+                  <a:txBody>
+                    <a:bodyPr lIns="114300" tIns="114300" rIns="114300" bIns="114300"/>
+                    <a:lstStyle/>
+                    <a:p>
+                      <a:r>
+                        <a:rPr sz="1725" b="0">
+                          <a:solidFill>
+                            <a:srgbClr val="172738"/>
+                          </a:solidFill>
+                          <a:latin typeface="Apple SD Gothic Neo"/>
+                          <a:ea typeface="Apple SD Gothic Neo"/>
+                          <a:cs typeface="Apple SD Gothic Neo"/>
+                        </a:rPr>
+                        <a:t>Port 내부 in-order</a:t>
+                      </a:r>
+                    </a:p>
+                    <a:p>
+                      <a:r>
+                        <a:rPr sz="1725" b="0">
+                          <a:solidFill>
+                            <a:srgbClr val="172738"/>
+                          </a:solidFill>
+                          <a:latin typeface="Apple SD Gothic Neo"/>
+                          <a:ea typeface="Apple SD Gothic Neo"/>
+                          <a:cs typeface="Apple SD Gothic Neo"/>
+                        </a:rPr>
+                        <a:t>연결된 마지막 응답 후 버퍼 해제</a:t>
+                      </a:r>
+                    </a:p>
+                  </a:txBody>
+                  <a:tcPr marL="133350" marR="133350" marT="95250" marB="95250" anchor="ctr">
+                    <a:solidFill>
+                      <a:srgbClr val="FFFFFF"/>
+                    </a:solidFill>
+                  </a:tcPr>
+                </a:tc>
+              </a:tr>
+            </a:tbl>
+          </a:graphicData>
+        </a:graphic>
+      </p:graphicFrame>
+      <p:sp>
+        <p:nvSpPr>
+          <p:cNvPr id="6" name="buffer-distinction">
+            <a:extLst xmlns:a="http://schemas.openxmlformats.org/drawingml/2006/main">
+              <a:ext uri="{FF2B5EF4-FFF2-40B4-BE49-F238E27FC236}">
+                <a16:creationId xmlns:a16="http://schemas.microsoft.com/office/drawing/2014/main" id="{72CA7D65-6343-42EB-AB54-C43476A41F16}"/>
+              </a:ext>
+            </a:extLst>
+          </p:cNvPr>
+          <p:cNvSpPr>
+            <a:spLocks xmlns:a="http://schemas.openxmlformats.org/drawingml/2006/main" noGrp="1"/>
+          </p:cNvSpPr>
+          <p:nvPr/>
+        </p:nvSpPr>
+        <p:spPr>
+          <a:xfrm xmlns:a="http://schemas.openxmlformats.org/drawingml/2006/main">
+            <a:off x="571500" y="6038850"/>
+            <a:ext cx="11049000" cy="285750"/>
+          </a:xfrm>
+          <a:prstGeom xmlns:a="http://schemas.openxmlformats.org/drawingml/2006/main" prst="rect">
+            <a:avLst/>
+          </a:prstGeom>
+          <a:noFill xmlns:a="http://schemas.openxmlformats.org/drawingml/2006/main"/>
+          <a:ln xmlns:a="http://schemas.openxmlformats.org/drawingml/2006/main" w="0">
+            <a:noFill/>
+          </a:ln>
+        </p:spPr>
+        <p:txBody>
+          <a:bodyPr xmlns:a="http://schemas.openxmlformats.org/drawingml/2006/main" wrap="square" lIns="0" tIns="0" rIns="0" bIns="0" anchor="t">
+            <a:noAutofit/>
+          </a:bodyPr>
+          <a:lstStyle xmlns:a="http://schemas.openxmlformats.org/drawingml/2006/main">
+            <a:defPPr>
+              <a:defRPr sz="1650" b="0">
+                <a:solidFill>
+                  <a:srgbClr val="586875"/>
+                </a:solidFill>
+                <a:latin typeface="Apple SD Gothic Neo"/>
+                <a:ea typeface="Apple SD Gothic Neo"/>
+                <a:cs typeface="Apple SD Gothic Neo"/>
+              </a:defRPr>
+            </a:defPPr>
+          </a:lstStyle>
+          <a:p xmlns:a="http://schemas.openxmlformats.org/drawingml/2006/main">
+            <a:pPr>
+              <a:defRPr sz="1650" b="0">
+                <a:solidFill>
+                  <a:srgbClr val="586875"/>
+                </a:solidFill>
+                <a:latin typeface="Apple SD Gothic Neo"/>
+                <a:ea typeface="Apple SD Gothic Neo"/>
+                <a:cs typeface="Apple SD Gothic Neo"/>
+              </a:defRPr>
+            </a:pPr>
+            <a:r>
+              <a:rPr sz="1650" b="0">
+                <a:solidFill>
+                  <a:srgbClr val="586875"/>
+                </a:solidFill>
+                <a:latin typeface="Apple SD Gothic Neo"/>
+                <a:ea typeface="Apple SD Gothic Neo"/>
+                <a:cs typeface="Apple SD Gothic Neo"/>
+              </a:rPr>
+              <a:t>NAND page buffer는 Plane별 자원이며, Controller buffer는 여러 Port가 공유하는 임시 보관 공간입니다.</a:t>
             </a:r>
           </a:p>
         </p:txBody>
@@ -4538,7 +5344,889 @@
     </p:spTree>
     <p:extLst>
       <p:ext uri="{BB962C8B-B14F-4D97-AF65-F5344CB8AC3E}">
-        <p14:creationId xmlns:p14="http://schemas.microsoft.com/office/powerpoint/2010/main" val="869296119"/>
+        <p14:creationId xmlns:p14="http://schemas.microsoft.com/office/powerpoint/2010/main" val="637003154"/>
+      </p:ext>
+    </p:extLst>
+  </p:cSld>
+</p:sld>
+</file>
+
+<file path=ppt/slides/slide10.xml><?xml version="1.0" encoding="utf-8"?>
+<p:sld xmlns:p="http://schemas.openxmlformats.org/presentationml/2006/main">
+  <p:cSld>
+    <p:bg>
+      <p:bgPr>
+        <a:solidFill xmlns:a="http://schemas.openxmlformats.org/drawingml/2006/main">
+          <a:srgbClr val="FFFFFF"/>
+        </a:solidFill>
+      </p:bgPr>
+    </p:bg>
+    <p:spTree>
+      <p:nvGrpSpPr>
+        <p:cNvPr id="1" name=""/>
+        <p:cNvGrpSpPr/>
+        <p:nvPr/>
+      </p:nvGrpSpPr>
+      <p:grpSpPr>
+        <a:xfrm xmlns:a="http://schemas.openxmlformats.org/drawingml/2006/main"/>
+      </p:grpSpPr>
+      <p:sp>
+        <p:nvSpPr>
+          <p:cNvPr id="8" name="title">
+            <a:extLst xmlns:a="http://schemas.openxmlformats.org/drawingml/2006/main">
+              <a:ext uri="{FF2B5EF4-FFF2-40B4-BE49-F238E27FC236}">
+                <a16:creationId xmlns:a16="http://schemas.microsoft.com/office/drawing/2014/main" id="{DD4445C3-E04B-40AB-B33D-54F10A07DFC3}"/>
+              </a:ext>
+            </a:extLst>
+          </p:cNvPr>
+          <p:cNvSpPr>
+            <a:spLocks xmlns:a="http://schemas.openxmlformats.org/drawingml/2006/main" noGrp="1"/>
+          </p:cNvSpPr>
+          <p:nvPr/>
+        </p:nvSpPr>
+        <p:spPr>
+          <a:xfrm xmlns:a="http://schemas.openxmlformats.org/drawingml/2006/main">
+            <a:off x="533400" y="438150"/>
+            <a:ext cx="11125200" cy="628650"/>
+          </a:xfrm>
+          <a:prstGeom xmlns:a="http://schemas.openxmlformats.org/drawingml/2006/main" prst="rect">
+            <a:avLst/>
+          </a:prstGeom>
+          <a:noFill xmlns:a="http://schemas.openxmlformats.org/drawingml/2006/main"/>
+          <a:ln xmlns:a="http://schemas.openxmlformats.org/drawingml/2006/main" w="0">
+            <a:noFill/>
+          </a:ln>
+        </p:spPr>
+        <p:txBody>
+          <a:bodyPr xmlns:a="http://schemas.openxmlformats.org/drawingml/2006/main" wrap="square" lIns="0" tIns="0" rIns="0" bIns="0" anchor="t">
+            <a:noAutofit/>
+          </a:bodyPr>
+          <a:lstStyle xmlns:a="http://schemas.openxmlformats.org/drawingml/2006/main">
+            <a:defPPr>
+              <a:defRPr sz="3300" b="1">
+                <a:solidFill>
+                  <a:srgbClr val="172738"/>
+                </a:solidFill>
+                <a:latin typeface="Apple SD Gothic Neo"/>
+                <a:ea typeface="Apple SD Gothic Neo"/>
+                <a:cs typeface="Apple SD Gothic Neo"/>
+              </a:defRPr>
+            </a:defPPr>
+          </a:lstStyle>
+          <a:p xmlns:a="http://schemas.openxmlformats.org/drawingml/2006/main">
+            <a:pPr>
+              <a:defRPr sz="3300" b="1">
+                <a:solidFill>
+                  <a:srgbClr val="172738"/>
+                </a:solidFill>
+                <a:latin typeface="Apple SD Gothic Neo"/>
+                <a:ea typeface="Apple SD Gothic Neo"/>
+                <a:cs typeface="Apple SD Gothic Neo"/>
+              </a:defRPr>
+            </a:pPr>
+            <a:r>
+              <a:rPr sz="3300" b="1">
+                <a:solidFill>
+                  <a:srgbClr val="172738"/>
+                </a:solidFill>
+                <a:latin typeface="Apple SD Gothic Neo"/>
+                <a:ea typeface="Apple SD Gothic Neo"/>
+                <a:cs typeface="Apple SD Gothic Neo"/>
+              </a:rPr>
+              <a:t>A·B의 유효 데이터량과 처리량</a:t>
+            </a:r>
+          </a:p>
+        </p:txBody>
+      </p:sp>
+      <p:sp>
+        <p:nvSpPr>
+          <p:cNvPr id="2" name="subtitle">
+            <a:extLst xmlns:a="http://schemas.openxmlformats.org/drawingml/2006/main">
+              <a:ext uri="{FF2B5EF4-FFF2-40B4-BE49-F238E27FC236}">
+                <a16:creationId xmlns:a16="http://schemas.microsoft.com/office/drawing/2014/main" id="{85496E9E-BBDC-4BE7-A772-9D5A86A419FF}"/>
+              </a:ext>
+            </a:extLst>
+          </p:cNvPr>
+          <p:cNvSpPr>
+            <a:spLocks xmlns:a="http://schemas.openxmlformats.org/drawingml/2006/main" noGrp="1"/>
+          </p:cNvSpPr>
+          <p:nvPr/>
+        </p:nvSpPr>
+        <p:spPr>
+          <a:xfrm xmlns:a="http://schemas.openxmlformats.org/drawingml/2006/main">
+            <a:off x="552450" y="1104900"/>
+            <a:ext cx="11087100" cy="571500"/>
+          </a:xfrm>
+          <a:prstGeom xmlns:a="http://schemas.openxmlformats.org/drawingml/2006/main" prst="rect">
+            <a:avLst/>
+          </a:prstGeom>
+          <a:noFill xmlns:a="http://schemas.openxmlformats.org/drawingml/2006/main"/>
+          <a:ln xmlns:a="http://schemas.openxmlformats.org/drawingml/2006/main" w="0">
+            <a:noFill/>
+          </a:ln>
+        </p:spPr>
+        <p:txBody>
+          <a:bodyPr xmlns:a="http://schemas.openxmlformats.org/drawingml/2006/main" wrap="square" lIns="0" tIns="0" rIns="0" bIns="0" anchor="t">
+            <a:noAutofit/>
+          </a:bodyPr>
+          <a:lstStyle xmlns:a="http://schemas.openxmlformats.org/drawingml/2006/main">
+            <a:defPPr>
+              <a:defRPr sz="1800" b="0">
+                <a:solidFill>
+                  <a:srgbClr val="586875"/>
+                </a:solidFill>
+                <a:latin typeface="Apple SD Gothic Neo"/>
+                <a:ea typeface="Apple SD Gothic Neo"/>
+                <a:cs typeface="Apple SD Gothic Neo"/>
+              </a:defRPr>
+            </a:defPPr>
+          </a:lstStyle>
+          <a:p xmlns:a="http://schemas.openxmlformats.org/drawingml/2006/main">
+            <a:pPr>
+              <a:defRPr sz="1800" b="0">
+                <a:solidFill>
+                  <a:srgbClr val="586875"/>
+                </a:solidFill>
+                <a:latin typeface="Apple SD Gothic Neo"/>
+                <a:ea typeface="Apple SD Gothic Neo"/>
+                <a:cs typeface="Apple SD Gothic Neo"/>
+              </a:defRPr>
+            </a:pPr>
+            <a:r>
+              <a:rPr sz="1800" b="0">
+                <a:solidFill>
+                  <a:srgbClr val="586875"/>
+                </a:solidFill>
+                <a:latin typeface="Apple SD Gothic Neo"/>
+                <a:ea typeface="Apple SD Gothic Neo"/>
+                <a:cs typeface="Apple SD Gothic Neo"/>
+              </a:rPr>
+              <a:t>현재 모델은 64B 요청에도 NAND에서 물리 페이지 전체 16KiB를 출력합니다.</a:t>
+            </a:r>
+          </a:p>
+        </p:txBody>
+      </p:sp>
+      <p:sp>
+        <p:nvSpPr>
+          <p:cNvPr id="3" name="footer">
+            <a:extLst xmlns:a="http://schemas.openxmlformats.org/drawingml/2006/main">
+              <a:ext uri="{FF2B5EF4-FFF2-40B4-BE49-F238E27FC236}">
+                <a16:creationId xmlns:a16="http://schemas.microsoft.com/office/drawing/2014/main" id="{043C7520-4E55-41D4-A35E-668A74C30FA2}"/>
+              </a:ext>
+            </a:extLst>
+          </p:cNvPr>
+          <p:cNvSpPr>
+            <a:spLocks xmlns:a="http://schemas.openxmlformats.org/drawingml/2006/main" noGrp="1"/>
+          </p:cNvSpPr>
+          <p:nvPr/>
+        </p:nvSpPr>
+        <p:spPr>
+          <a:xfrm xmlns:a="http://schemas.openxmlformats.org/drawingml/2006/main">
+            <a:off x="533400" y="6419850"/>
+            <a:ext cx="10477500" cy="257175"/>
+          </a:xfrm>
+          <a:prstGeom xmlns:a="http://schemas.openxmlformats.org/drawingml/2006/main" prst="rect">
+            <a:avLst/>
+          </a:prstGeom>
+          <a:noFill xmlns:a="http://schemas.openxmlformats.org/drawingml/2006/main"/>
+          <a:ln xmlns:a="http://schemas.openxmlformats.org/drawingml/2006/main" w="0">
+            <a:noFill/>
+          </a:ln>
+        </p:spPr>
+        <p:txBody>
+          <a:bodyPr xmlns:a="http://schemas.openxmlformats.org/drawingml/2006/main" wrap="square" lIns="0" tIns="0" rIns="0" bIns="0" anchor="t">
+            <a:noAutofit/>
+          </a:bodyPr>
+          <a:lstStyle xmlns:a="http://schemas.openxmlformats.org/drawingml/2006/main">
+            <a:defPPr>
+              <a:defRPr sz="1200" b="0">
+                <a:solidFill>
+                  <a:srgbClr val="586875"/>
+                </a:solidFill>
+                <a:latin typeface="Apple SD Gothic Neo"/>
+                <a:ea typeface="Apple SD Gothic Neo"/>
+                <a:cs typeface="Apple SD Gothic Neo"/>
+              </a:defRPr>
+            </a:defPPr>
+          </a:lstStyle>
+          <a:p xmlns:a="http://schemas.openxmlformats.org/drawingml/2006/main">
+            <a:pPr>
+              <a:defRPr sz="1200" b="0">
+                <a:solidFill>
+                  <a:srgbClr val="586875"/>
+                </a:solidFill>
+                <a:latin typeface="Apple SD Gothic Neo"/>
+                <a:ea typeface="Apple SD Gothic Neo"/>
+                <a:cs typeface="Apple SD Gothic Neo"/>
+              </a:defRPr>
+            </a:pPr>
+            <a:r>
+              <a:rPr sz="1200" b="0">
+                <a:solidFill>
+                  <a:srgbClr val="586875"/>
+                </a:solidFill>
+                <a:latin typeface="Apple SD Gothic Neo"/>
+                <a:ea typeface="Apple SD Gothic Neo"/>
+                <a:cs typeface="Apple SD Gothic Neo"/>
+              </a:rPr>
+              <a:t>조건: 64 Plane, 영역 배치, 8MiB, QD512/Port, PF OFF. 200–2,200µs 고정 평균</a:t>
+            </a:r>
+          </a:p>
+        </p:txBody>
+      </p:sp>
+      <p:sp>
+        <p:nvSpPr>
+          <p:cNvPr id="4" name="page">
+            <a:extLst xmlns:a="http://schemas.openxmlformats.org/drawingml/2006/main">
+              <a:ext uri="{FF2B5EF4-FFF2-40B4-BE49-F238E27FC236}">
+                <a16:creationId xmlns:a16="http://schemas.microsoft.com/office/drawing/2014/main" id="{DFEE60A2-B2F8-4386-8D73-0265689726FE}"/>
+              </a:ext>
+            </a:extLst>
+          </p:cNvPr>
+          <p:cNvSpPr>
+            <a:spLocks xmlns:a="http://schemas.openxmlformats.org/drawingml/2006/main" noGrp="1"/>
+          </p:cNvSpPr>
+          <p:nvPr/>
+        </p:nvSpPr>
+        <p:spPr>
+          <a:xfrm xmlns:a="http://schemas.openxmlformats.org/drawingml/2006/main">
+            <a:off x="11144250" y="6419850"/>
+            <a:ext cx="495300" cy="257175"/>
+          </a:xfrm>
+          <a:prstGeom xmlns:a="http://schemas.openxmlformats.org/drawingml/2006/main" prst="rect">
+            <a:avLst/>
+          </a:prstGeom>
+          <a:noFill xmlns:a="http://schemas.openxmlformats.org/drawingml/2006/main"/>
+          <a:ln xmlns:a="http://schemas.openxmlformats.org/drawingml/2006/main" w="0">
+            <a:noFill/>
+          </a:ln>
+        </p:spPr>
+        <p:txBody>
+          <a:bodyPr xmlns:a="http://schemas.openxmlformats.org/drawingml/2006/main" wrap="square" lIns="0" tIns="0" rIns="0" bIns="0" anchor="t">
+            <a:noAutofit/>
+          </a:bodyPr>
+          <a:lstStyle xmlns:a="http://schemas.openxmlformats.org/drawingml/2006/main">
+            <a:defPPr>
+              <a:defRPr sz="1200" b="0">
+                <a:solidFill>
+                  <a:srgbClr val="586875"/>
+                </a:solidFill>
+                <a:latin typeface="Apple SD Gothic Neo"/>
+                <a:ea typeface="Apple SD Gothic Neo"/>
+                <a:cs typeface="Apple SD Gothic Neo"/>
+              </a:defRPr>
+            </a:defPPr>
+          </a:lstStyle>
+          <a:p xmlns:a="http://schemas.openxmlformats.org/drawingml/2006/main">
+            <a:pPr>
+              <a:defRPr sz="1200" b="0">
+                <a:solidFill>
+                  <a:srgbClr val="586875"/>
+                </a:solidFill>
+                <a:latin typeface="Apple SD Gothic Neo"/>
+                <a:ea typeface="Apple SD Gothic Neo"/>
+                <a:cs typeface="Apple SD Gothic Neo"/>
+              </a:defRPr>
+            </a:pPr>
+            <a:r>
+              <a:rPr sz="1200" b="0">
+                <a:solidFill>
+                  <a:srgbClr val="586875"/>
+                </a:solidFill>
+                <a:latin typeface="Apple SD Gothic Neo"/>
+                <a:ea typeface="Apple SD Gothic Neo"/>
+                <a:cs typeface="Apple SD Gothic Neo"/>
+              </a:rPr>
+              <a:t>10</a:t>
+            </a:r>
+          </a:p>
+        </p:txBody>
+      </p:sp>
+      <p:graphicFrame>
+        <p:nvGraphicFramePr>
+          <p:cNvPr id="5" name="workload-byte-efficiency">
+            <a:extLst xmlns:a="http://schemas.openxmlformats.org/drawingml/2006/main">
+              <a:ext uri="{FF2B5EF4-FFF2-40B4-BE49-F238E27FC236}">
+                <a16:creationId xmlns:a16="http://schemas.microsoft.com/office/drawing/2014/main" id="{AB29E4C8-B7BD-46DB-812F-D86C5F50F685}"/>
+              </a:ext>
+            </a:extLst>
+          </p:cNvPr>
+          <p:cNvGraphicFramePr/>
+          <p:nvPr/>
+        </p:nvGraphicFramePr>
+        <p:xfrm>
+          <a:off xmlns:a="http://schemas.openxmlformats.org/drawingml/2006/main" x="533400" y="1800225"/>
+          <a:ext xmlns:a="http://schemas.openxmlformats.org/drawingml/2006/main" cx="11125200" cy="2857500"/>
+        </p:xfrm>
+        <a:graphic xmlns:a="http://schemas.openxmlformats.org/drawingml/2006/main">
+          <a:graphicData uri="http://schemas.openxmlformats.org/drawingml/2006/table">
+            <a:tbl>
+              <a:tblPr/>
+              <a:tblGrid>
+                <a:gridCol w="3286125"/>
+                <a:gridCol w="3905250"/>
+                <a:gridCol w="3933825"/>
+              </a:tblGrid>
+              <a:tr h="571500">
+                <a:tc>
+                  <a:txBody>
+                    <a:bodyPr lIns="114300" tIns="114300" rIns="114300" bIns="114300"/>
+                    <a:lstStyle/>
+                    <a:p>
+                      <a:r>
+                        <a:rPr sz="1800" b="1">
+                          <a:solidFill>
+                            <a:srgbClr val="FFFFFF"/>
+                          </a:solidFill>
+                          <a:latin typeface="Apple SD Gothic Neo"/>
+                          <a:ea typeface="Apple SD Gothic Neo"/>
+                          <a:cs typeface="Apple SD Gothic Neo"/>
+                        </a:rPr>
+                        <a:t>비교 항목</a:t>
+                      </a:r>
+                    </a:p>
+                  </a:txBody>
+                  <a:tcPr marL="133350" marR="133350" marT="95250" marB="95250" anchor="ctr">
+                    <a:solidFill>
+                      <a:srgbClr val="122C40"/>
+                    </a:solidFill>
+                  </a:tcPr>
+                </a:tc>
+                <a:tc>
+                  <a:txBody>
+                    <a:bodyPr lIns="114300" tIns="114300" rIns="114300" bIns="114300"/>
+                    <a:lstStyle/>
+                    <a:p>
+                      <a:r>
+                        <a:rPr sz="1800" b="1">
+                          <a:solidFill>
+                            <a:srgbClr val="FFFFFF"/>
+                          </a:solidFill>
+                          <a:latin typeface="Apple SD Gothic Neo"/>
+                          <a:ea typeface="Apple SD Gothic Neo"/>
+                          <a:cs typeface="Apple SD Gothic Neo"/>
+                        </a:rPr>
+                        <a:t>A1 / A2</a:t>
+                      </a:r>
+                    </a:p>
+                  </a:txBody>
+                  <a:tcPr marL="133350" marR="133350" marT="95250" marB="95250" anchor="ctr">
+                    <a:solidFill>
+                      <a:srgbClr val="122C40"/>
+                    </a:solidFill>
+                  </a:tcPr>
+                </a:tc>
+                <a:tc>
+                  <a:txBody>
+                    <a:bodyPr lIns="114300" tIns="114300" rIns="114300" bIns="114300"/>
+                    <a:lstStyle/>
+                    <a:p>
+                      <a:r>
+                        <a:rPr sz="1800" b="1">
+                          <a:solidFill>
+                            <a:srgbClr val="FFFFFF"/>
+                          </a:solidFill>
+                          <a:latin typeface="Apple SD Gothic Neo"/>
+                          <a:ea typeface="Apple SD Gothic Neo"/>
+                          <a:cs typeface="Apple SD Gothic Neo"/>
+                        </a:rPr>
+                        <a:t>B1 / B2</a:t>
+                      </a:r>
+                    </a:p>
+                  </a:txBody>
+                  <a:tcPr marL="133350" marR="133350" marT="95250" marB="95250" anchor="ctr">
+                    <a:solidFill>
+                      <a:srgbClr val="122C40"/>
+                    </a:solidFill>
+                  </a:tcPr>
+                </a:tc>
+              </a:tr>
+              <a:tr h="571500">
+                <a:tc>
+                  <a:txBody>
+                    <a:bodyPr lIns="114300" tIns="114300" rIns="114300" bIns="114300"/>
+                    <a:lstStyle/>
+                    <a:p>
+                      <a:r>
+                        <a:rPr sz="1800" b="0">
+                          <a:solidFill>
+                            <a:srgbClr val="172738"/>
+                          </a:solidFill>
+                          <a:latin typeface="Apple SD Gothic Neo"/>
+                          <a:ea typeface="Apple SD Gothic Neo"/>
+                          <a:cs typeface="Apple SD Gothic Neo"/>
+                        </a:rPr>
+                        <a:t>Host 요청당 반환량</a:t>
+                      </a:r>
+                    </a:p>
+                  </a:txBody>
+                  <a:tcPr marL="133350" marR="133350" marT="95250" marB="95250" anchor="ctr">
+                    <a:solidFill>
+                      <a:srgbClr val="FFFFFF"/>
+                    </a:solidFill>
+                  </a:tcPr>
+                </a:tc>
+                <a:tc>
+                  <a:txBody>
+                    <a:bodyPr lIns="114300" tIns="114300" rIns="114300" bIns="114300"/>
+                    <a:lstStyle/>
+                    <a:p>
+                      <a:r>
+                        <a:rPr sz="1800" b="0">
+                          <a:solidFill>
+                            <a:srgbClr val="172738"/>
+                          </a:solidFill>
+                          <a:latin typeface="Apple SD Gothic Neo"/>
+                          <a:ea typeface="Apple SD Gothic Neo"/>
+                          <a:cs typeface="Apple SD Gothic Neo"/>
+                        </a:rPr>
+                        <a:t>4KiB</a:t>
+                      </a:r>
+                    </a:p>
+                  </a:txBody>
+                  <a:tcPr marL="133350" marR="133350" marT="95250" marB="95250" anchor="ctr">
+                    <a:solidFill>
+                      <a:srgbClr val="FFFFFF"/>
+                    </a:solidFill>
+                  </a:tcPr>
+                </a:tc>
+                <a:tc>
+                  <a:txBody>
+                    <a:bodyPr lIns="114300" tIns="114300" rIns="114300" bIns="114300"/>
+                    <a:lstStyle/>
+                    <a:p>
+                      <a:r>
+                        <a:rPr sz="1800" b="0">
+                          <a:solidFill>
+                            <a:srgbClr val="172738"/>
+                          </a:solidFill>
+                          <a:latin typeface="Apple SD Gothic Neo"/>
+                          <a:ea typeface="Apple SD Gothic Neo"/>
+                          <a:cs typeface="Apple SD Gothic Neo"/>
+                        </a:rPr>
+                        <a:t>64B</a:t>
+                      </a:r>
+                    </a:p>
+                  </a:txBody>
+                  <a:tcPr marL="133350" marR="133350" marT="95250" marB="95250" anchor="ctr">
+                    <a:solidFill>
+                      <a:srgbClr val="FFFFFF"/>
+                    </a:solidFill>
+                  </a:tcPr>
+                </a:tc>
+              </a:tr>
+              <a:tr h="571500">
+                <a:tc>
+                  <a:txBody>
+                    <a:bodyPr lIns="114300" tIns="114300" rIns="114300" bIns="114300"/>
+                    <a:lstStyle/>
+                    <a:p>
+                      <a:r>
+                        <a:rPr sz="1800" b="0">
+                          <a:solidFill>
+                            <a:srgbClr val="172738"/>
+                          </a:solidFill>
+                          <a:latin typeface="Apple SD Gothic Neo"/>
+                          <a:ea typeface="Apple SD Gothic Neo"/>
+                          <a:cs typeface="Apple SD Gothic Neo"/>
+                        </a:rPr>
+                        <a:t>물리 16KiB당 유효 데이터</a:t>
+                      </a:r>
+                    </a:p>
+                  </a:txBody>
+                  <a:tcPr marL="133350" marR="133350" marT="95250" marB="95250" anchor="ctr">
+                    <a:solidFill>
+                      <a:srgbClr val="F1F5F8"/>
+                    </a:solidFill>
+                  </a:tcPr>
+                </a:tc>
+                <a:tc>
+                  <a:txBody>
+                    <a:bodyPr lIns="114300" tIns="114300" rIns="114300" bIns="114300"/>
+                    <a:lstStyle/>
+                    <a:p>
+                      <a:r>
+                        <a:rPr sz="1800" b="0">
+                          <a:solidFill>
+                            <a:srgbClr val="172738"/>
+                          </a:solidFill>
+                          <a:latin typeface="Apple SD Gothic Neo"/>
+                          <a:ea typeface="Apple SD Gothic Neo"/>
+                          <a:cs typeface="Apple SD Gothic Neo"/>
+                        </a:rPr>
+                        <a:t>4 × 4KiB = 16KiB</a:t>
+                      </a:r>
+                    </a:p>
+                  </a:txBody>
+                  <a:tcPr marL="133350" marR="133350" marT="95250" marB="95250" anchor="ctr">
+                    <a:solidFill>
+                      <a:srgbClr val="F1F5F8"/>
+                    </a:solidFill>
+                  </a:tcPr>
+                </a:tc>
+                <a:tc>
+                  <a:txBody>
+                    <a:bodyPr lIns="114300" tIns="114300" rIns="114300" bIns="114300"/>
+                    <a:lstStyle/>
+                    <a:p>
+                      <a:r>
+                        <a:rPr sz="1800" b="0">
+                          <a:solidFill>
+                            <a:srgbClr val="172738"/>
+                          </a:solidFill>
+                          <a:latin typeface="Apple SD Gothic Neo"/>
+                          <a:ea typeface="Apple SD Gothic Neo"/>
+                          <a:cs typeface="Apple SD Gothic Neo"/>
+                        </a:rPr>
+                        <a:t>4 × 64B = 256B</a:t>
+                      </a:r>
+                    </a:p>
+                  </a:txBody>
+                  <a:tcPr marL="133350" marR="133350" marT="95250" marB="95250" anchor="ctr">
+                    <a:solidFill>
+                      <a:srgbClr val="F1F5F8"/>
+                    </a:solidFill>
+                  </a:tcPr>
+                </a:tc>
+              </a:tr>
+              <a:tr h="571500">
+                <a:tc>
+                  <a:txBody>
+                    <a:bodyPr lIns="114300" tIns="114300" rIns="114300" bIns="114300"/>
+                    <a:lstStyle/>
+                    <a:p>
+                      <a:r>
+                        <a:rPr sz="1800" b="0">
+                          <a:solidFill>
+                            <a:srgbClr val="172738"/>
+                          </a:solidFill>
+                          <a:latin typeface="Apple SD Gothic Neo"/>
+                          <a:ea typeface="Apple SD Gothic Neo"/>
+                          <a:cs typeface="Apple SD Gothic Neo"/>
+                        </a:rPr>
+                        <a:t>명목 유효 데이터 비율</a:t>
+                      </a:r>
+                    </a:p>
+                  </a:txBody>
+                  <a:tcPr marL="133350" marR="133350" marT="95250" marB="95250" anchor="ctr">
+                    <a:solidFill>
+                      <a:srgbClr val="FFFFFF"/>
+                    </a:solidFill>
+                  </a:tcPr>
+                </a:tc>
+                <a:tc>
+                  <a:txBody>
+                    <a:bodyPr lIns="114300" tIns="114300" rIns="114300" bIns="114300"/>
+                    <a:lstStyle/>
+                    <a:p>
+                      <a:r>
+                        <a:rPr sz="1800" b="0">
+                          <a:solidFill>
+                            <a:srgbClr val="172738"/>
+                          </a:solidFill>
+                          <a:latin typeface="Apple SD Gothic Neo"/>
+                          <a:ea typeface="Apple SD Gothic Neo"/>
+                          <a:cs typeface="Apple SD Gothic Neo"/>
+                        </a:rPr>
+                        <a:t>100%</a:t>
+                      </a:r>
+                    </a:p>
+                  </a:txBody>
+                  <a:tcPr marL="133350" marR="133350" marT="95250" marB="95250" anchor="ctr">
+                    <a:solidFill>
+                      <a:srgbClr val="FFFFFF"/>
+                    </a:solidFill>
+                  </a:tcPr>
+                </a:tc>
+                <a:tc>
+                  <a:txBody>
+                    <a:bodyPr lIns="114300" tIns="114300" rIns="114300" bIns="114300"/>
+                    <a:lstStyle/>
+                    <a:p>
+                      <a:r>
+                        <a:rPr sz="1800" b="0">
+                          <a:solidFill>
+                            <a:srgbClr val="172738"/>
+                          </a:solidFill>
+                          <a:latin typeface="Apple SD Gothic Neo"/>
+                          <a:ea typeface="Apple SD Gothic Neo"/>
+                          <a:cs typeface="Apple SD Gothic Neo"/>
+                        </a:rPr>
+                        <a:t>1/64 = 1.5625%</a:t>
+                      </a:r>
+                    </a:p>
+                  </a:txBody>
+                  <a:tcPr marL="133350" marR="133350" marT="95250" marB="95250" anchor="ctr">
+                    <a:solidFill>
+                      <a:srgbClr val="FFFFFF"/>
+                    </a:solidFill>
+                  </a:tcPr>
+                </a:tc>
+              </a:tr>
+              <a:tr h="571500">
+                <a:tc>
+                  <a:txBody>
+                    <a:bodyPr lIns="114300" tIns="114300" rIns="114300" bIns="114300"/>
+                    <a:lstStyle/>
+                    <a:p>
+                      <a:r>
+                        <a:rPr sz="1800" b="0">
+                          <a:solidFill>
+                            <a:srgbClr val="172738"/>
+                          </a:solidFill>
+                          <a:latin typeface="Apple SD Gothic Neo"/>
+                          <a:ea typeface="Apple SD Gothic Neo"/>
+                          <a:cs typeface="Apple SD Gothic Neo"/>
+                        </a:rPr>
+                        <a:t>Host 처리량 (GB/s)</a:t>
+                      </a:r>
+                    </a:p>
+                  </a:txBody>
+                  <a:tcPr marL="133350" marR="133350" marT="95250" marB="95250" anchor="ctr">
+                    <a:solidFill>
+                      <a:srgbClr val="F1F5F8"/>
+                    </a:solidFill>
+                  </a:tcPr>
+                </a:tc>
+                <a:tc>
+                  <a:txBody>
+                    <a:bodyPr lIns="114300" tIns="114300" rIns="114300" bIns="114300"/>
+                    <a:lstStyle/>
+                    <a:p>
+                      <a:r>
+                        <a:rPr sz="1800" b="0">
+                          <a:solidFill>
+                            <a:srgbClr val="172738"/>
+                          </a:solidFill>
+                          <a:latin typeface="Apple SD Gothic Neo"/>
+                          <a:ea typeface="Apple SD Gothic Neo"/>
+                          <a:cs typeface="Apple SD Gothic Neo"/>
+                        </a:rPr>
+                        <a:t>A1 255.366 / A2 255.058</a:t>
+                      </a:r>
+                    </a:p>
+                  </a:txBody>
+                  <a:tcPr marL="133350" marR="133350" marT="95250" marB="95250" anchor="ctr">
+                    <a:solidFill>
+                      <a:srgbClr val="F1F5F8"/>
+                    </a:solidFill>
+                  </a:tcPr>
+                </a:tc>
+                <a:tc>
+                  <a:txBody>
+                    <a:bodyPr lIns="114300" tIns="114300" rIns="114300" bIns="114300"/>
+                    <a:lstStyle/>
+                    <a:p>
+                      <a:r>
+                        <a:rPr sz="1800" b="0">
+                          <a:solidFill>
+                            <a:srgbClr val="172738"/>
+                          </a:solidFill>
+                          <a:latin typeface="Apple SD Gothic Neo"/>
+                          <a:ea typeface="Apple SD Gothic Neo"/>
+                          <a:cs typeface="Apple SD Gothic Neo"/>
+                        </a:rPr>
+                        <a:t>B1 3.995 / B2 4.001</a:t>
+                      </a:r>
+                    </a:p>
+                  </a:txBody>
+                  <a:tcPr marL="133350" marR="133350" marT="95250" marB="95250" anchor="ctr">
+                    <a:solidFill>
+                      <a:srgbClr val="F1F5F8"/>
+                    </a:solidFill>
+                  </a:tcPr>
+                </a:tc>
+              </a:tr>
+            </a:tbl>
+          </a:graphicData>
+        </a:graphic>
+      </p:graphicFrame>
+      <p:sp>
+        <p:nvSpPr>
+          <p:cNvPr id="6" name="partial-read-meaning">
+            <a:extLst xmlns:a="http://schemas.openxmlformats.org/drawingml/2006/main">
+              <a:ext uri="{FF2B5EF4-FFF2-40B4-BE49-F238E27FC236}">
+                <a16:creationId xmlns:a16="http://schemas.microsoft.com/office/drawing/2014/main" id="{1DB10328-557A-41DC-AEF6-35AB71995707}"/>
+              </a:ext>
+            </a:extLst>
+          </p:cNvPr>
+          <p:cNvSpPr>
+            <a:spLocks xmlns:a="http://schemas.openxmlformats.org/drawingml/2006/main" noGrp="1"/>
+          </p:cNvSpPr>
+          <p:nvPr/>
+        </p:nvSpPr>
+        <p:spPr>
+          <a:xfrm xmlns:a="http://schemas.openxmlformats.org/drawingml/2006/main">
+            <a:off x="571500" y="4914900"/>
+            <a:ext cx="11029950" cy="704850"/>
+          </a:xfrm>
+          <a:prstGeom xmlns:a="http://schemas.openxmlformats.org/drawingml/2006/main" prst="rect">
+            <a:avLst/>
+          </a:prstGeom>
+          <a:noFill xmlns:a="http://schemas.openxmlformats.org/drawingml/2006/main"/>
+          <a:ln xmlns:a="http://schemas.openxmlformats.org/drawingml/2006/main" w="0">
+            <a:noFill/>
+          </a:ln>
+        </p:spPr>
+        <p:txBody>
+          <a:bodyPr xmlns:a="http://schemas.openxmlformats.org/drawingml/2006/main" wrap="square" lIns="0" tIns="0" rIns="0" bIns="0" anchor="t">
+            <a:noAutofit/>
+          </a:bodyPr>
+          <a:lstStyle xmlns:a="http://schemas.openxmlformats.org/drawingml/2006/main">
+            <a:defPPr>
+              <a:defRPr sz="1800" b="0">
+                <a:solidFill>
+                  <a:srgbClr val="172738"/>
+                </a:solidFill>
+                <a:latin typeface="Apple SD Gothic Neo"/>
+                <a:ea typeface="Apple SD Gothic Neo"/>
+                <a:cs typeface="Apple SD Gothic Neo"/>
+              </a:defRPr>
+            </a:defPPr>
+          </a:lstStyle>
+          <a:p xmlns:a="http://schemas.openxmlformats.org/drawingml/2006/main">
+            <a:pPr>
+              <a:defRPr sz="1800" b="0">
+                <a:solidFill>
+                  <a:srgbClr val="172738"/>
+                </a:solidFill>
+                <a:latin typeface="Apple SD Gothic Neo"/>
+                <a:ea typeface="Apple SD Gothic Neo"/>
+                <a:cs typeface="Apple SD Gothic Neo"/>
+              </a:defRPr>
+            </a:pPr>
+            <a:r>
+              <a:rPr sz="1800" b="0">
+                <a:solidFill>
+                  <a:srgbClr val="172738"/>
+                </a:solidFill>
+                <a:latin typeface="Apple SD Gothic Neo"/>
+                <a:ea typeface="Apple SD Gothic Neo"/>
+                <a:cs typeface="Apple SD Gothic Neo"/>
+              </a:rPr>
+              <a:t>B1/B2는 한 페이지 안의 64B를 모두 이어 읽는 부하가 아닙니다.</a:t>
+            </a:r>
+          </a:p>
+          <a:p xmlns:a="http://schemas.openxmlformats.org/drawingml/2006/main">
+            <a:pPr>
+              <a:defRPr sz="1800" b="0">
+                <a:solidFill>
+                  <a:srgbClr val="172738"/>
+                </a:solidFill>
+                <a:latin typeface="Apple SD Gothic Neo"/>
+                <a:ea typeface="Apple SD Gothic Neo"/>
+                <a:cs typeface="Apple SD Gothic Neo"/>
+              </a:defRPr>
+            </a:pPr>
+            <a:r>
+              <a:rPr sz="1800" b="0">
+                <a:solidFill>
+                  <a:srgbClr val="172738"/>
+                </a:solidFill>
+                <a:latin typeface="Apple SD Gothic Neo"/>
+                <a:ea typeface="Apple SD Gothic Neo"/>
+                <a:cs typeface="Apple SD Gothic Neo"/>
+              </a:rPr>
+              <a:t>B의 내부 NAND 전송은 약 257GB/s지만, Host가 사용하는 데이터는 그 일부입니다.</a:t>
+            </a:r>
+          </a:p>
+        </p:txBody>
+      </p:sp>
+      <p:sp>
+        <p:nvSpPr>
+          <p:cNvPr id="7" name="comparison-limits">
+            <a:extLst xmlns:a="http://schemas.openxmlformats.org/drawingml/2006/main">
+              <a:ext uri="{FF2B5EF4-FFF2-40B4-BE49-F238E27FC236}">
+                <a16:creationId xmlns:a16="http://schemas.microsoft.com/office/drawing/2014/main" id="{C33B2A42-593B-4CEE-B154-F2C100496615}"/>
+              </a:ext>
+            </a:extLst>
+          </p:cNvPr>
+          <p:cNvSpPr>
+            <a:spLocks xmlns:a="http://schemas.openxmlformats.org/drawingml/2006/main" noGrp="1"/>
+          </p:cNvSpPr>
+          <p:nvPr/>
+        </p:nvSpPr>
+        <p:spPr>
+          <a:xfrm xmlns:a="http://schemas.openxmlformats.org/drawingml/2006/main">
+            <a:off x="571500" y="5800725"/>
+            <a:ext cx="11029950" cy="533400"/>
+          </a:xfrm>
+          <a:prstGeom xmlns:a="http://schemas.openxmlformats.org/drawingml/2006/main" prst="rect">
+            <a:avLst/>
+          </a:prstGeom>
+          <a:noFill xmlns:a="http://schemas.openxmlformats.org/drawingml/2006/main"/>
+          <a:ln xmlns:a="http://schemas.openxmlformats.org/drawingml/2006/main" w="0">
+            <a:noFill/>
+          </a:ln>
+        </p:spPr>
+        <p:txBody>
+          <a:bodyPr xmlns:a="http://schemas.openxmlformats.org/drawingml/2006/main" wrap="square" lIns="0" tIns="0" rIns="0" bIns="0" anchor="t">
+            <a:noAutofit/>
+          </a:bodyPr>
+          <a:lstStyle xmlns:a="http://schemas.openxmlformats.org/drawingml/2006/main">
+            <a:defPPr>
+              <a:defRPr sz="1650" b="0">
+                <a:solidFill>
+                  <a:srgbClr val="586875"/>
+                </a:solidFill>
+                <a:latin typeface="Apple SD Gothic Neo"/>
+                <a:ea typeface="Apple SD Gothic Neo"/>
+                <a:cs typeface="Apple SD Gothic Neo"/>
+              </a:defRPr>
+            </a:defPPr>
+          </a:lstStyle>
+          <a:p xmlns:a="http://schemas.openxmlformats.org/drawingml/2006/main">
+            <a:pPr>
+              <a:defRPr sz="1650" b="0">
+                <a:solidFill>
+                  <a:srgbClr val="586875"/>
+                </a:solidFill>
+                <a:latin typeface="Apple SD Gothic Neo"/>
+                <a:ea typeface="Apple SD Gothic Neo"/>
+                <a:cs typeface="Apple SD Gothic Neo"/>
+              </a:defRPr>
+            </a:pPr>
+            <a:r>
+              <a:rPr sz="1650" b="0">
+                <a:solidFill>
+                  <a:srgbClr val="586875"/>
+                </a:solidFill>
+                <a:latin typeface="Apple SD Gothic Neo"/>
+                <a:ea typeface="Apple SD Gothic Neo"/>
+                <a:cs typeface="Apple SD Gothic Neo"/>
+              </a:rPr>
+              <a:t>A1/B1은 매핑과 장치 설정이 같습니다. A2/B2는 stripe와 CA 정책이 다릅니다.</a:t>
+            </a:r>
+          </a:p>
+          <a:p xmlns:a="http://schemas.openxmlformats.org/drawingml/2006/main">
+            <a:pPr>
+              <a:defRPr sz="1650" b="0">
+                <a:solidFill>
+                  <a:srgbClr val="586875"/>
+                </a:solidFill>
+                <a:latin typeface="Apple SD Gothic Neo"/>
+                <a:ea typeface="Apple SD Gothic Neo"/>
+                <a:cs typeface="Apple SD Gothic Neo"/>
+              </a:defRPr>
+            </a:pPr>
+            <a:r>
+              <a:rPr sz="1650" b="0">
+                <a:solidFill>
+                  <a:srgbClr val="586875"/>
+                </a:solidFill>
+                <a:latin typeface="Apple SD Gothic Neo"/>
+                <a:ea typeface="Apple SD Gothic Neo"/>
+                <a:cs typeface="Apple SD Gothic Neo"/>
+              </a:rPr>
+              <a:t>B3는 패턴 정의만 포함했으며, 이번 64 Plane 지속 부하의 성능 수치는 없습니다.</a:t>
+            </a:r>
+          </a:p>
+        </p:txBody>
+      </p:sp>
+    </p:spTree>
+    <p:extLst>
+      <p:ext uri="{BB962C8B-B14F-4D97-AF65-F5344CB8AC3E}">
+        <p14:creationId xmlns:p14="http://schemas.microsoft.com/office/powerpoint/2010/main" val="2140076940"/>
       </p:ext>
     </p:extLst>
   </p:cSld>
@@ -4569,7 +6257,7 @@
           <p:cNvPr id="7" name="title">
             <a:extLst xmlns:a="http://schemas.openxmlformats.org/drawingml/2006/main">
               <a:ext uri="{FF2B5EF4-FFF2-40B4-BE49-F238E27FC236}">
-                <a16:creationId xmlns:a16="http://schemas.microsoft.com/office/drawing/2014/main" id="{EF19B29A-BFDF-403F-8F79-94B887D58EE3}"/>
+                <a16:creationId xmlns:a16="http://schemas.microsoft.com/office/drawing/2014/main" id="{C4CE4C17-D2AD-45F1-B471-C7D48CDFE460}"/>
               </a:ext>
             </a:extLst>
           </p:cNvPr>
@@ -4637,7 +6325,7 @@
           <p:cNvPr id="2" name="subtitle">
             <a:extLst xmlns:a="http://schemas.openxmlformats.org/drawingml/2006/main">
               <a:ext uri="{FF2B5EF4-FFF2-40B4-BE49-F238E27FC236}">
-                <a16:creationId xmlns:a16="http://schemas.microsoft.com/office/drawing/2014/main" id="{7D062721-A30B-498E-B982-31C3A0712F4F}"/>
+                <a16:creationId xmlns:a16="http://schemas.microsoft.com/office/drawing/2014/main" id="{53342CCE-ADAC-42EF-8777-CF8C2080CF5C}"/>
               </a:ext>
             </a:extLst>
           </p:cNvPr>
@@ -4705,7 +6393,7 @@
           <p:cNvPr id="3" name="footer">
             <a:extLst xmlns:a="http://schemas.openxmlformats.org/drawingml/2006/main">
               <a:ext uri="{FF2B5EF4-FFF2-40B4-BE49-F238E27FC236}">
-                <a16:creationId xmlns:a16="http://schemas.microsoft.com/office/drawing/2014/main" id="{B51330B4-2C02-4C87-B0D3-42386DFF9E0E}"/>
+                <a16:creationId xmlns:a16="http://schemas.microsoft.com/office/drawing/2014/main" id="{C4C25565-4C49-41A7-AB41-B68B9039AFF2}"/>
               </a:ext>
             </a:extLst>
           </p:cNvPr>
@@ -4773,7 +6461,7 @@
           <p:cNvPr id="4" name="page">
             <a:extLst xmlns:a="http://schemas.openxmlformats.org/drawingml/2006/main">
               <a:ext uri="{FF2B5EF4-FFF2-40B4-BE49-F238E27FC236}">
-                <a16:creationId xmlns:a16="http://schemas.microsoft.com/office/drawing/2014/main" id="{6366547B-D9AF-4DA6-8619-1182447022F0}"/>
+                <a16:creationId xmlns:a16="http://schemas.microsoft.com/office/drawing/2014/main" id="{18F4FA18-D4D1-424C-90C5-C9516C74A305}"/>
               </a:ext>
             </a:extLst>
           </p:cNvPr>
@@ -4841,7 +6529,7 @@
           <p:cNvPr id="5" name="three-items">
             <a:extLst xmlns:a="http://schemas.openxmlformats.org/drawingml/2006/main">
               <a:ext uri="{FF2B5EF4-FFF2-40B4-BE49-F238E27FC236}">
-                <a16:creationId xmlns:a16="http://schemas.microsoft.com/office/drawing/2014/main" id="{779C5E4E-CB33-47A2-A59C-375E400CC495}"/>
+                <a16:creationId xmlns:a16="http://schemas.microsoft.com/office/drawing/2014/main" id="{7BDE875D-A732-4739-B53C-4E757691B06F}"/>
               </a:ext>
             </a:extLst>
           </p:cNvPr>
@@ -5244,7 +6932,7 @@
           <p:cNvPr id="6" name="measurement-caution">
             <a:extLst xmlns:a="http://schemas.openxmlformats.org/drawingml/2006/main">
               <a:ext uri="{FF2B5EF4-FFF2-40B4-BE49-F238E27FC236}">
-                <a16:creationId xmlns:a16="http://schemas.microsoft.com/office/drawing/2014/main" id="{3371E4DF-DB4F-4344-B4D9-9D206EB19775}"/>
+                <a16:creationId xmlns:a16="http://schemas.microsoft.com/office/drawing/2014/main" id="{F42FB49F-7D51-4E50-9EA6-1B3A23A00786}"/>
               </a:ext>
             </a:extLst>
           </p:cNvPr>
@@ -5333,7 +7021,7 @@
     </p:spTree>
     <p:extLst>
       <p:ext uri="{BB962C8B-B14F-4D97-AF65-F5344CB8AC3E}">
-        <p14:creationId xmlns:p14="http://schemas.microsoft.com/office/powerpoint/2010/main" val="2108635480"/>
+        <p14:creationId xmlns:p14="http://schemas.microsoft.com/office/powerpoint/2010/main" val="1900839396"/>
       </p:ext>
     </p:extLst>
   </p:cSld>
@@ -5364,7 +7052,7 @@
           <p:cNvPr id="12" name="title">
             <a:extLst xmlns:a="http://schemas.openxmlformats.org/drawingml/2006/main">
               <a:ext uri="{FF2B5EF4-FFF2-40B4-BE49-F238E27FC236}">
-                <a16:creationId xmlns:a16="http://schemas.microsoft.com/office/drawing/2014/main" id="{53412C9A-9128-4F8A-BD6F-E0B4F756B592}"/>
+                <a16:creationId xmlns:a16="http://schemas.microsoft.com/office/drawing/2014/main" id="{29510F5A-543A-4F4A-9078-AA1F529EFDC4}"/>
               </a:ext>
             </a:extLst>
           </p:cNvPr>
@@ -5432,7 +7120,7 @@
           <p:cNvPr id="2" name="subtitle">
             <a:extLst xmlns:a="http://schemas.openxmlformats.org/drawingml/2006/main">
               <a:ext uri="{FF2B5EF4-FFF2-40B4-BE49-F238E27FC236}">
-                <a16:creationId xmlns:a16="http://schemas.microsoft.com/office/drawing/2014/main" id="{6145FD1F-BD06-423B-B4D1-AAAA64D331CA}"/>
+                <a16:creationId xmlns:a16="http://schemas.microsoft.com/office/drawing/2014/main" id="{8CD8451F-0D9C-4B79-8359-5F96808A29C1}"/>
               </a:ext>
             </a:extLst>
           </p:cNvPr>
@@ -5500,7 +7188,7 @@
           <p:cNvPr id="3" name="footer">
             <a:extLst xmlns:a="http://schemas.openxmlformats.org/drawingml/2006/main">
               <a:ext uri="{FF2B5EF4-FFF2-40B4-BE49-F238E27FC236}">
-                <a16:creationId xmlns:a16="http://schemas.microsoft.com/office/drawing/2014/main" id="{D7CBB0FF-ACBE-4B11-BAF5-5081140FE989}"/>
+                <a16:creationId xmlns:a16="http://schemas.microsoft.com/office/drawing/2014/main" id="{EDD67E4C-117B-4476-A043-B570C52ADC7C}"/>
               </a:ext>
             </a:extLst>
           </p:cNvPr>
@@ -5568,7 +7256,7 @@
           <p:cNvPr id="4" name="page">
             <a:extLst xmlns:a="http://schemas.openxmlformats.org/drawingml/2006/main">
               <a:ext uri="{FF2B5EF4-FFF2-40B4-BE49-F238E27FC236}">
-                <a16:creationId xmlns:a16="http://schemas.microsoft.com/office/drawing/2014/main" id="{8B63CAD1-359F-405B-9058-C7956C30C987}"/>
+                <a16:creationId xmlns:a16="http://schemas.microsoft.com/office/drawing/2014/main" id="{85BC79B7-C0A1-40CC-BDA1-EBD2A6D47B4B}"/>
               </a:ext>
             </a:extLst>
           </p:cNvPr>
@@ -5636,7 +7324,7 @@
           <p:cNvPr id="5" name="chart-unit">
             <a:extLst xmlns:a="http://schemas.openxmlformats.org/drawingml/2006/main">
               <a:ext uri="{FF2B5EF4-FFF2-40B4-BE49-F238E27FC236}">
-                <a16:creationId xmlns:a16="http://schemas.microsoft.com/office/drawing/2014/main" id="{3C6F4D25-C8A2-4460-91F8-B4881B0F804E}"/>
+                <a16:creationId xmlns:a16="http://schemas.microsoft.com/office/drawing/2014/main" id="{FFADC929-5104-4FAD-ABD5-FB4D8992D812}"/>
               </a:ext>
             </a:extLst>
           </p:cNvPr>
@@ -5704,7 +7392,7 @@
           <p:cNvPr id="6" name="Chart">
             <a:extLst xmlns:a="http://schemas.openxmlformats.org/drawingml/2006/main">
               <a:ext uri="{FF2B5EF4-FFF2-40B4-BE49-F238E27FC236}">
-                <a16:creationId xmlns:a16="http://schemas.microsoft.com/office/drawing/2014/main" id="{98A6E3B0-DCDE-4C6E-8C94-31E73349368C}"/>
+                <a16:creationId xmlns:a16="http://schemas.microsoft.com/office/drawing/2014/main" id="{3CB3F939-8115-40EB-BC79-929BBC7414FE}"/>
               </a:ext>
             </a:extLst>
           </p:cNvPr>
@@ -5717,7 +7405,7 @@
         </p:xfrm>
         <a:graphic xmlns:a="http://schemas.openxmlformats.org/drawingml/2006/main">
           <a:graphicData uri="http://schemas.openxmlformats.org/drawingml/2006/chart">
-            <c:chart xmlns:r="http://schemas.openxmlformats.org/officeDocument/2006/relationships" xmlns:c="http://schemas.openxmlformats.org/drawingml/2006/chart" r:id="Rad397611640c4cf5"/>
+            <c:chart xmlns:r="http://schemas.openxmlformats.org/officeDocument/2006/relationships" xmlns:c="http://schemas.openxmlformats.org/drawingml/2006/chart" r:id="R9172a6eacdb34747"/>
           </a:graphicData>
         </a:graphic>
       </p:graphicFrame>
@@ -5726,7 +7414,7 @@
           <p:cNvPr id="7" name="tr-mix">
             <a:extLst xmlns:a="http://schemas.openxmlformats.org/drawingml/2006/main">
               <a:ext uri="{FF2B5EF4-FFF2-40B4-BE49-F238E27FC236}">
-                <a16:creationId xmlns:a16="http://schemas.microsoft.com/office/drawing/2014/main" id="{1F847281-51C9-4E93-9FCA-F0B67F4801B8}"/>
+                <a16:creationId xmlns:a16="http://schemas.microsoft.com/office/drawing/2014/main" id="{D62F2C68-D4B6-4C3F-BF9E-75489F4C8022}"/>
               </a:ext>
             </a:extLst>
           </p:cNvPr>
@@ -5903,7 +7591,7 @@
           <p:cNvPr id="8" name="mechanism1">
             <a:extLst xmlns:a="http://schemas.openxmlformats.org/drawingml/2006/main">
               <a:ext uri="{FF2B5EF4-FFF2-40B4-BE49-F238E27FC236}">
-                <a16:creationId xmlns:a16="http://schemas.microsoft.com/office/drawing/2014/main" id="{9F88E885-2C5D-4033-B458-2EB31D5083B1}"/>
+                <a16:creationId xmlns:a16="http://schemas.microsoft.com/office/drawing/2014/main" id="{A76D4E77-6DBA-4A0F-9BC5-E129A3CB389E}"/>
               </a:ext>
             </a:extLst>
           </p:cNvPr>
@@ -5971,7 +7659,7 @@
           <p:cNvPr id="9" name="mechanism1-detail">
             <a:extLst xmlns:a="http://schemas.openxmlformats.org/drawingml/2006/main">
               <a:ext uri="{FF2B5EF4-FFF2-40B4-BE49-F238E27FC236}">
-                <a16:creationId xmlns:a16="http://schemas.microsoft.com/office/drawing/2014/main" id="{E64A84B6-7021-4876-98B8-CA1AEB0FD141}"/>
+                <a16:creationId xmlns:a16="http://schemas.microsoft.com/office/drawing/2014/main" id="{AE74264C-0D53-41A9-A1F3-7C6008FFE8D5}"/>
               </a:ext>
             </a:extLst>
           </p:cNvPr>
@@ -6108,7 +7796,7 @@
           <p:cNvPr id="10" name="ordering">
             <a:extLst xmlns:a="http://schemas.openxmlformats.org/drawingml/2006/main">
               <a:ext uri="{FF2B5EF4-FFF2-40B4-BE49-F238E27FC236}">
-                <a16:creationId xmlns:a16="http://schemas.microsoft.com/office/drawing/2014/main" id="{C367FC6C-F225-4A57-BF3B-772C1B3EF6D8}"/>
+                <a16:creationId xmlns:a16="http://schemas.microsoft.com/office/drawing/2014/main" id="{9FAB3B4D-B6E3-42FC-A5FE-163B89FDA9CE}"/>
               </a:ext>
             </a:extLst>
           </p:cNvPr>
@@ -6199,7 +7887,7 @@
           <p:cNvPr id="11" name="bounded">
             <a:extLst xmlns:a="http://schemas.openxmlformats.org/drawingml/2006/main">
               <a:ext uri="{FF2B5EF4-FFF2-40B4-BE49-F238E27FC236}">
-                <a16:creationId xmlns:a16="http://schemas.microsoft.com/office/drawing/2014/main" id="{D3C90FDE-B2E3-421F-99C2-77F56F2B8FF7}"/>
+                <a16:creationId xmlns:a16="http://schemas.microsoft.com/office/drawing/2014/main" id="{D20FAB8B-3705-4A4E-897F-3A4F9D2A5033}"/>
               </a:ext>
             </a:extLst>
           </p:cNvPr>
@@ -6311,7 +7999,7 @@
     </p:spTree>
     <p:extLst>
       <p:ext uri="{BB962C8B-B14F-4D97-AF65-F5344CB8AC3E}">
-        <p14:creationId xmlns:p14="http://schemas.microsoft.com/office/powerpoint/2010/main" val="2103412581"/>
+        <p14:creationId xmlns:p14="http://schemas.microsoft.com/office/powerpoint/2010/main" val="561302251"/>
       </p:ext>
     </p:extLst>
   </p:cSld>
@@ -6342,7 +8030,7 @@
           <p:cNvPr id="12" name="title">
             <a:extLst xmlns:a="http://schemas.openxmlformats.org/drawingml/2006/main">
               <a:ext uri="{FF2B5EF4-FFF2-40B4-BE49-F238E27FC236}">
-                <a16:creationId xmlns:a16="http://schemas.microsoft.com/office/drawing/2014/main" id="{A97DD071-E417-468E-B5F2-E5ACD09690BF}"/>
+                <a16:creationId xmlns:a16="http://schemas.microsoft.com/office/drawing/2014/main" id="{2E3C4A48-4937-45AC-A2D2-5B2F3CC53735}"/>
               </a:ext>
             </a:extLst>
           </p:cNvPr>
@@ -6410,7 +8098,7 @@
           <p:cNvPr id="2" name="subtitle">
             <a:extLst xmlns:a="http://schemas.openxmlformats.org/drawingml/2006/main">
               <a:ext uri="{FF2B5EF4-FFF2-40B4-BE49-F238E27FC236}">
-                <a16:creationId xmlns:a16="http://schemas.microsoft.com/office/drawing/2014/main" id="{6F63C770-9E9B-425C-8E72-AA827FF2CCE1}"/>
+                <a16:creationId xmlns:a16="http://schemas.microsoft.com/office/drawing/2014/main" id="{41008C24-C444-4507-8916-3534EDDD019D}"/>
               </a:ext>
             </a:extLst>
           </p:cNvPr>
@@ -6478,7 +8166,7 @@
           <p:cNvPr id="3" name="footer">
             <a:extLst xmlns:a="http://schemas.openxmlformats.org/drawingml/2006/main">
               <a:ext uri="{FF2B5EF4-FFF2-40B4-BE49-F238E27FC236}">
-                <a16:creationId xmlns:a16="http://schemas.microsoft.com/office/drawing/2014/main" id="{DF18D896-33BD-4E92-A132-BE7C34E299D6}"/>
+                <a16:creationId xmlns:a16="http://schemas.microsoft.com/office/drawing/2014/main" id="{8D1339E9-4149-480F-B281-FBA4CF4C8D4C}"/>
               </a:ext>
             </a:extLst>
           </p:cNvPr>
@@ -6546,7 +8234,7 @@
           <p:cNvPr id="4" name="page">
             <a:extLst xmlns:a="http://schemas.openxmlformats.org/drawingml/2006/main">
               <a:ext uri="{FF2B5EF4-FFF2-40B4-BE49-F238E27FC236}">
-                <a16:creationId xmlns:a16="http://schemas.microsoft.com/office/drawing/2014/main" id="{2DE856A8-BDEA-4AE7-9329-0BCA63884533}"/>
+                <a16:creationId xmlns:a16="http://schemas.microsoft.com/office/drawing/2014/main" id="{0E93AC90-F016-4328-B961-F786F3225AF3}"/>
               </a:ext>
             </a:extLst>
           </p:cNvPr>
@@ -6614,7 +8302,7 @@
           <p:cNvPr id="5" name="chart-unit">
             <a:extLst xmlns:a="http://schemas.openxmlformats.org/drawingml/2006/main">
               <a:ext uri="{FF2B5EF4-FFF2-40B4-BE49-F238E27FC236}">
-                <a16:creationId xmlns:a16="http://schemas.microsoft.com/office/drawing/2014/main" id="{51F02156-43C4-44CA-B764-C12FB644A050}"/>
+                <a16:creationId xmlns:a16="http://schemas.microsoft.com/office/drawing/2014/main" id="{5578750B-94AB-4367-A4A2-02B1F7A6505D}"/>
               </a:ext>
             </a:extLst>
           </p:cNvPr>
@@ -6682,7 +8370,7 @@
           <p:cNvPr id="6" name="Chart">
             <a:extLst xmlns:a="http://schemas.openxmlformats.org/drawingml/2006/main">
               <a:ext uri="{FF2B5EF4-FFF2-40B4-BE49-F238E27FC236}">
-                <a16:creationId xmlns:a16="http://schemas.microsoft.com/office/drawing/2014/main" id="{B3F13C59-03A4-4999-BAF5-BDF8BB62F0E4}"/>
+                <a16:creationId xmlns:a16="http://schemas.microsoft.com/office/drawing/2014/main" id="{5C84F814-1503-4BC8-87DA-16E0B180DC04}"/>
               </a:ext>
             </a:extLst>
           </p:cNvPr>
@@ -6695,7 +8383,7 @@
         </p:xfrm>
         <a:graphic xmlns:a="http://schemas.openxmlformats.org/drawingml/2006/main">
           <a:graphicData uri="http://schemas.openxmlformats.org/drawingml/2006/chart">
-            <c:chart xmlns:r="http://schemas.openxmlformats.org/officeDocument/2006/relationships" xmlns:c="http://schemas.openxmlformats.org/drawingml/2006/chart" r:id="R722b22f7e515452d"/>
+            <c:chart xmlns:r="http://schemas.openxmlformats.org/officeDocument/2006/relationships" xmlns:c="http://schemas.openxmlformats.org/drawingml/2006/chart" r:id="Rd9682a1908ee412c"/>
           </a:graphicData>
         </a:graphic>
       </p:graphicFrame>
@@ -6704,7 +8392,7 @@
           <p:cNvPr id="7" name="geometry">
             <a:extLst xmlns:a="http://schemas.openxmlformats.org/drawingml/2006/main">
               <a:ext uri="{FF2B5EF4-FFF2-40B4-BE49-F238E27FC236}">
-                <a16:creationId xmlns:a16="http://schemas.microsoft.com/office/drawing/2014/main" id="{B41960E2-CDF1-4988-8D3C-9C37EA43DF1F}"/>
+                <a16:creationId xmlns:a16="http://schemas.microsoft.com/office/drawing/2014/main" id="{E0641A52-16AC-4C64-96EF-0C7395AE482D}"/>
               </a:ext>
             </a:extLst>
           </p:cNvPr>
@@ -6772,7 +8460,7 @@
           <p:cNvPr id="8" name="geometry-detail">
             <a:extLst xmlns:a="http://schemas.openxmlformats.org/drawingml/2006/main">
               <a:ext uri="{FF2B5EF4-FFF2-40B4-BE49-F238E27FC236}">
-                <a16:creationId xmlns:a16="http://schemas.microsoft.com/office/drawing/2014/main" id="{B0C74DFE-B104-4362-827D-ECBEA3E71F73}"/>
+                <a16:creationId xmlns:a16="http://schemas.microsoft.com/office/drawing/2014/main" id="{E48C1670-98F0-44C3-8DA2-1AF35E79F535}"/>
               </a:ext>
             </a:extLst>
           </p:cNvPr>
@@ -6909,7 +8597,7 @@
           <p:cNvPr id="9" name="layout">
             <a:extLst xmlns:a="http://schemas.openxmlformats.org/drawingml/2006/main">
               <a:ext uri="{FF2B5EF4-FFF2-40B4-BE49-F238E27FC236}">
-                <a16:creationId xmlns:a16="http://schemas.microsoft.com/office/drawing/2014/main" id="{36ABEF17-FDA8-4092-81D7-E013120FF6CF}"/>
+                <a16:creationId xmlns:a16="http://schemas.microsoft.com/office/drawing/2014/main" id="{B12426FE-406C-4924-8FEF-1A00B0EFA10D}"/>
               </a:ext>
             </a:extLst>
           </p:cNvPr>
@@ -6977,7 +8665,7 @@
           <p:cNvPr id="10" name="layout-detail">
             <a:extLst xmlns:a="http://schemas.openxmlformats.org/drawingml/2006/main">
               <a:ext uri="{FF2B5EF4-FFF2-40B4-BE49-F238E27FC236}">
-                <a16:creationId xmlns:a16="http://schemas.microsoft.com/office/drawing/2014/main" id="{61DFC526-AF6C-4A1B-8D68-72A4FD7DD411}"/>
+                <a16:creationId xmlns:a16="http://schemas.microsoft.com/office/drawing/2014/main" id="{5F244F46-65D6-441A-803A-84855EF3AC87}"/>
               </a:ext>
             </a:extLst>
           </p:cNvPr>
@@ -7091,7 +8779,7 @@
           <p:cNvPr id="11" name="separate-effects">
             <a:extLst xmlns:a="http://schemas.openxmlformats.org/drawingml/2006/main">
               <a:ext uri="{FF2B5EF4-FFF2-40B4-BE49-F238E27FC236}">
-                <a16:creationId xmlns:a16="http://schemas.microsoft.com/office/drawing/2014/main" id="{94903A39-A198-47C2-9992-610D92BC9C55}"/>
+                <a16:creationId xmlns:a16="http://schemas.microsoft.com/office/drawing/2014/main" id="{9C3C73E1-34EB-4678-A296-836E9FC7826B}"/>
               </a:ext>
             </a:extLst>
           </p:cNvPr>
@@ -7157,7 +8845,7 @@
     </p:spTree>
     <p:extLst>
       <p:ext uri="{BB962C8B-B14F-4D97-AF65-F5344CB8AC3E}">
-        <p14:creationId xmlns:p14="http://schemas.microsoft.com/office/powerpoint/2010/main" val="1117690244"/>
+        <p14:creationId xmlns:p14="http://schemas.microsoft.com/office/powerpoint/2010/main" val="489072794"/>
       </p:ext>
     </p:extLst>
   </p:cSld>
@@ -7188,7 +8876,7 @@
           <p:cNvPr id="8" name="title">
             <a:extLst xmlns:a="http://schemas.openxmlformats.org/drawingml/2006/main">
               <a:ext uri="{FF2B5EF4-FFF2-40B4-BE49-F238E27FC236}">
-                <a16:creationId xmlns:a16="http://schemas.microsoft.com/office/drawing/2014/main" id="{B02F1B10-DBF1-4D09-A7A8-2A9FE2E41B1C}"/>
+                <a16:creationId xmlns:a16="http://schemas.microsoft.com/office/drawing/2014/main" id="{2E2F138D-8297-405E-A686-03825131A2D7}"/>
               </a:ext>
             </a:extLst>
           </p:cNvPr>
@@ -7256,7 +8944,7 @@
           <p:cNvPr id="2" name="subtitle">
             <a:extLst xmlns:a="http://schemas.openxmlformats.org/drawingml/2006/main">
               <a:ext uri="{FF2B5EF4-FFF2-40B4-BE49-F238E27FC236}">
-                <a16:creationId xmlns:a16="http://schemas.microsoft.com/office/drawing/2014/main" id="{97468676-0D3C-4EBF-8CCE-2AD821A191CA}"/>
+                <a16:creationId xmlns:a16="http://schemas.microsoft.com/office/drawing/2014/main" id="{7EC21BDB-86C8-4D48-AD24-430ECB4ED243}"/>
               </a:ext>
             </a:extLst>
           </p:cNvPr>
@@ -7324,7 +9012,7 @@
           <p:cNvPr id="3" name="footer">
             <a:extLst xmlns:a="http://schemas.openxmlformats.org/drawingml/2006/main">
               <a:ext uri="{FF2B5EF4-FFF2-40B4-BE49-F238E27FC236}">
-                <a16:creationId xmlns:a16="http://schemas.microsoft.com/office/drawing/2014/main" id="{0566C511-8CFD-40C5-AC4E-423DCCB0CEC8}"/>
+                <a16:creationId xmlns:a16="http://schemas.microsoft.com/office/drawing/2014/main" id="{9CD151C6-F5AA-4C3C-AEBB-E2CF6DBF39CF}"/>
               </a:ext>
             </a:extLst>
           </p:cNvPr>
@@ -7392,7 +9080,7 @@
           <p:cNvPr id="4" name="page">
             <a:extLst xmlns:a="http://schemas.openxmlformats.org/drawingml/2006/main">
               <a:ext uri="{FF2B5EF4-FFF2-40B4-BE49-F238E27FC236}">
-                <a16:creationId xmlns:a16="http://schemas.microsoft.com/office/drawing/2014/main" id="{CBB726D5-09ED-4E23-BE2D-6B76D751B12B}"/>
+                <a16:creationId xmlns:a16="http://schemas.microsoft.com/office/drawing/2014/main" id="{FAE37E85-BE56-4198-AFF1-CD4FF4951697}"/>
               </a:ext>
             </a:extLst>
           </p:cNvPr>
@@ -7460,7 +9148,7 @@
           <p:cNvPr id="5" name="region-mapping">
             <a:extLst xmlns:a="http://schemas.openxmlformats.org/drawingml/2006/main">
               <a:ext uri="{FF2B5EF4-FFF2-40B4-BE49-F238E27FC236}">
-                <a16:creationId xmlns:a16="http://schemas.microsoft.com/office/drawing/2014/main" id="{6B243249-3DCD-4E12-9026-F46DD4833FCD}"/>
+                <a16:creationId xmlns:a16="http://schemas.microsoft.com/office/drawing/2014/main" id="{F2BF6877-5932-4489-A3EC-826DE3E3CEF0}"/>
               </a:ext>
             </a:extLst>
           </p:cNvPr>
@@ -8101,7 +9789,7 @@
           <p:cNvPr id="6" name="placement-why">
             <a:extLst xmlns:a="http://schemas.openxmlformats.org/drawingml/2006/main">
               <a:ext uri="{FF2B5EF4-FFF2-40B4-BE49-F238E27FC236}">
-                <a16:creationId xmlns:a16="http://schemas.microsoft.com/office/drawing/2014/main" id="{2E37D340-9F90-42FB-9E69-CC2A6B4C6FCC}"/>
+                <a16:creationId xmlns:a16="http://schemas.microsoft.com/office/drawing/2014/main" id="{A144EC24-07FE-45B1-9066-A6B0FFF4D6BA}"/>
               </a:ext>
             </a:extLst>
           </p:cNvPr>
@@ -8192,7 +9880,7 @@
           <p:cNvPr id="7" name="mapping-not-wiring">
             <a:extLst xmlns:a="http://schemas.openxmlformats.org/drawingml/2006/main">
               <a:ext uri="{FF2B5EF4-FFF2-40B4-BE49-F238E27FC236}">
-                <a16:creationId xmlns:a16="http://schemas.microsoft.com/office/drawing/2014/main" id="{8476982E-8EC3-4842-9074-4B11704AF0C4}"/>
+                <a16:creationId xmlns:a16="http://schemas.microsoft.com/office/drawing/2014/main" id="{6CA79791-B45A-4652-94AB-F8AEC5AB8EBE}"/>
               </a:ext>
             </a:extLst>
           </p:cNvPr>
@@ -8281,7 +9969,7 @@
     </p:spTree>
     <p:extLst>
       <p:ext uri="{BB962C8B-B14F-4D97-AF65-F5344CB8AC3E}">
-        <p14:creationId xmlns:p14="http://schemas.microsoft.com/office/powerpoint/2010/main" val="1679208374"/>
+        <p14:creationId xmlns:p14="http://schemas.microsoft.com/office/powerpoint/2010/main" val="1311429092"/>
       </p:ext>
     </p:extLst>
   </p:cSld>
@@ -8312,7 +10000,7 @@
           <p:cNvPr id="11" name="title">
             <a:extLst xmlns:a="http://schemas.openxmlformats.org/drawingml/2006/main">
               <a:ext uri="{FF2B5EF4-FFF2-40B4-BE49-F238E27FC236}">
-                <a16:creationId xmlns:a16="http://schemas.microsoft.com/office/drawing/2014/main" id="{477BC067-A9B9-4520-821F-6D9E0CF8FE62}"/>
+                <a16:creationId xmlns:a16="http://schemas.microsoft.com/office/drawing/2014/main" id="{879AF703-6157-44ED-882B-89FB823CE370}"/>
               </a:ext>
             </a:extLst>
           </p:cNvPr>
@@ -8380,7 +10068,7 @@
           <p:cNvPr id="2" name="subtitle">
             <a:extLst xmlns:a="http://schemas.openxmlformats.org/drawingml/2006/main">
               <a:ext uri="{FF2B5EF4-FFF2-40B4-BE49-F238E27FC236}">
-                <a16:creationId xmlns:a16="http://schemas.microsoft.com/office/drawing/2014/main" id="{6C7ADEED-8E27-468C-85FA-EB0D2F9A8DD4}"/>
+                <a16:creationId xmlns:a16="http://schemas.microsoft.com/office/drawing/2014/main" id="{4728DBDB-1886-445F-9234-01FD29070E4C}"/>
               </a:ext>
             </a:extLst>
           </p:cNvPr>
@@ -8448,7 +10136,7 @@
           <p:cNvPr id="3" name="footer">
             <a:extLst xmlns:a="http://schemas.openxmlformats.org/drawingml/2006/main">
               <a:ext uri="{FF2B5EF4-FFF2-40B4-BE49-F238E27FC236}">
-                <a16:creationId xmlns:a16="http://schemas.microsoft.com/office/drawing/2014/main" id="{7E0979DC-8679-48FF-8A46-BA50B3917BB5}"/>
+                <a16:creationId xmlns:a16="http://schemas.microsoft.com/office/drawing/2014/main" id="{9D5DD9FB-FAEA-4570-92E7-73CC6426EA35}"/>
               </a:ext>
             </a:extLst>
           </p:cNvPr>
@@ -8516,7 +10204,7 @@
           <p:cNvPr id="4" name="page">
             <a:extLst xmlns:a="http://schemas.openxmlformats.org/drawingml/2006/main">
               <a:ext uri="{FF2B5EF4-FFF2-40B4-BE49-F238E27FC236}">
-                <a16:creationId xmlns:a16="http://schemas.microsoft.com/office/drawing/2014/main" id="{E44018B4-E566-4355-A1F8-876A09731577}"/>
+                <a16:creationId xmlns:a16="http://schemas.microsoft.com/office/drawing/2014/main" id="{865F61A4-BE53-433B-A9BB-52DC0CF6F62D}"/>
               </a:ext>
             </a:extLst>
           </p:cNvPr>
@@ -8584,7 +10272,7 @@
           <p:cNvPr id="5" name="chart-unit">
             <a:extLst xmlns:a="http://schemas.openxmlformats.org/drawingml/2006/main">
               <a:ext uri="{FF2B5EF4-FFF2-40B4-BE49-F238E27FC236}">
-                <a16:creationId xmlns:a16="http://schemas.microsoft.com/office/drawing/2014/main" id="{166D2AF1-6989-4B98-A499-C359700DC8C8}"/>
+                <a16:creationId xmlns:a16="http://schemas.microsoft.com/office/drawing/2014/main" id="{7104EF7D-EDBD-4C38-99D6-207F758F5E51}"/>
               </a:ext>
             </a:extLst>
           </p:cNvPr>
@@ -8652,7 +10340,7 @@
           <p:cNvPr id="6" name="Chart">
             <a:extLst xmlns:a="http://schemas.openxmlformats.org/drawingml/2006/main">
               <a:ext uri="{FF2B5EF4-FFF2-40B4-BE49-F238E27FC236}">
-                <a16:creationId xmlns:a16="http://schemas.microsoft.com/office/drawing/2014/main" id="{656068C8-D023-4E47-896C-EB4BFDF9E377}"/>
+                <a16:creationId xmlns:a16="http://schemas.microsoft.com/office/drawing/2014/main" id="{60AEBD4C-C23F-4F04-874D-E5F895831361}"/>
               </a:ext>
             </a:extLst>
           </p:cNvPr>
@@ -8665,7 +10353,7 @@
         </p:xfrm>
         <a:graphic xmlns:a="http://schemas.openxmlformats.org/drawingml/2006/main">
           <a:graphicData uri="http://schemas.openxmlformats.org/drawingml/2006/chart">
-            <c:chart xmlns:r="http://schemas.openxmlformats.org/officeDocument/2006/relationships" xmlns:c="http://schemas.openxmlformats.org/drawingml/2006/chart" r:id="R62a036668fb54a1a"/>
+            <c:chart xmlns:r="http://schemas.openxmlformats.org/officeDocument/2006/relationships" xmlns:c="http://schemas.openxmlformats.org/drawingml/2006/chart" r:id="R5c2537c502e1443f"/>
           </a:graphicData>
         </a:graphic>
       </p:graphicFrame>
@@ -8674,7 +10362,7 @@
           <p:cNvPr id="7" name="qd-effect">
             <a:extLst xmlns:a="http://schemas.openxmlformats.org/drawingml/2006/main">
               <a:ext uri="{FF2B5EF4-FFF2-40B4-BE49-F238E27FC236}">
-                <a16:creationId xmlns:a16="http://schemas.microsoft.com/office/drawing/2014/main" id="{F897DEB4-D292-4256-8207-F05B6BC5233F}"/>
+                <a16:creationId xmlns:a16="http://schemas.microsoft.com/office/drawing/2014/main" id="{BCE55922-9AD7-48ED-8D35-63F94B5EDCC7}"/>
               </a:ext>
             </a:extLst>
           </p:cNvPr>
@@ -8742,7 +10430,7 @@
           <p:cNvPr id="8" name="qd-effect-2">
             <a:extLst xmlns:a="http://schemas.openxmlformats.org/drawingml/2006/main">
               <a:ext uri="{FF2B5EF4-FFF2-40B4-BE49-F238E27FC236}">
-                <a16:creationId xmlns:a16="http://schemas.microsoft.com/office/drawing/2014/main" id="{F77AE18F-8842-4C78-BE27-9E5FFC22326B}"/>
+                <a16:creationId xmlns:a16="http://schemas.microsoft.com/office/drawing/2014/main" id="{2C77049A-B236-4A32-8809-26E55E7B2185}"/>
               </a:ext>
             </a:extLst>
           </p:cNvPr>
@@ -8879,7 +10567,7 @@
           <p:cNvPr id="9" name="actual-qd-caption">
             <a:extLst xmlns:a="http://schemas.openxmlformats.org/drawingml/2006/main">
               <a:ext uri="{FF2B5EF4-FFF2-40B4-BE49-F238E27FC236}">
-                <a16:creationId xmlns:a16="http://schemas.microsoft.com/office/drawing/2014/main" id="{354FD11F-094D-4935-A5AD-1F2BFA6791CC}"/>
+                <a16:creationId xmlns:a16="http://schemas.microsoft.com/office/drawing/2014/main" id="{0A615E00-708C-4F23-9AC3-46B6E78F308E}"/>
               </a:ext>
             </a:extLst>
           </p:cNvPr>
@@ -8947,7 +10635,7 @@
           <p:cNvPr id="10" name="actual-qd">
             <a:extLst xmlns:a="http://schemas.openxmlformats.org/drawingml/2006/main">
               <a:ext uri="{FF2B5EF4-FFF2-40B4-BE49-F238E27FC236}">
-                <a16:creationId xmlns:a16="http://schemas.microsoft.com/office/drawing/2014/main" id="{34DD9FBD-0199-4665-9F81-93AF726930D5}"/>
+                <a16:creationId xmlns:a16="http://schemas.microsoft.com/office/drawing/2014/main" id="{0C0DC32F-040D-4ED4-BB84-D354DE907284}"/>
               </a:ext>
             </a:extLst>
           </p:cNvPr>
@@ -9342,7 +11030,7 @@
     </p:spTree>
     <p:extLst>
       <p:ext uri="{BB962C8B-B14F-4D97-AF65-F5344CB8AC3E}">
-        <p14:creationId xmlns:p14="http://schemas.microsoft.com/office/powerpoint/2010/main" val="449512056"/>
+        <p14:creationId xmlns:p14="http://schemas.microsoft.com/office/powerpoint/2010/main" val="1212069429"/>
       </p:ext>
     </p:extLst>
   </p:cSld>
@@ -9373,7 +11061,7 @@
           <p:cNvPr id="10" name="title">
             <a:extLst xmlns:a="http://schemas.openxmlformats.org/drawingml/2006/main">
               <a:ext uri="{FF2B5EF4-FFF2-40B4-BE49-F238E27FC236}">
-                <a16:creationId xmlns:a16="http://schemas.microsoft.com/office/drawing/2014/main" id="{FCD7E5FD-3810-4D6D-9E25-14EDC809A61C}"/>
+                <a16:creationId xmlns:a16="http://schemas.microsoft.com/office/drawing/2014/main" id="{DA8CFBF5-D54B-4E38-8F70-5F9550D9976A}"/>
               </a:ext>
             </a:extLst>
           </p:cNvPr>
@@ -9441,7 +11129,7 @@
           <p:cNvPr id="2" name="subtitle">
             <a:extLst xmlns:a="http://schemas.openxmlformats.org/drawingml/2006/main">
               <a:ext uri="{FF2B5EF4-FFF2-40B4-BE49-F238E27FC236}">
-                <a16:creationId xmlns:a16="http://schemas.microsoft.com/office/drawing/2014/main" id="{05B03926-9EE7-4FC4-9D1D-894A2C7DF615}"/>
+                <a16:creationId xmlns:a16="http://schemas.microsoft.com/office/drawing/2014/main" id="{A742F5E4-AD8C-4498-B585-B1F5F77704E2}"/>
               </a:ext>
             </a:extLst>
           </p:cNvPr>
@@ -9509,7 +11197,7 @@
           <p:cNvPr id="3" name="footer">
             <a:extLst xmlns:a="http://schemas.openxmlformats.org/drawingml/2006/main">
               <a:ext uri="{FF2B5EF4-FFF2-40B4-BE49-F238E27FC236}">
-                <a16:creationId xmlns:a16="http://schemas.microsoft.com/office/drawing/2014/main" id="{81DF4C8A-61B8-4F22-83C6-64E770175DB6}"/>
+                <a16:creationId xmlns:a16="http://schemas.microsoft.com/office/drawing/2014/main" id="{3E897FFB-3234-435C-870E-FFB116E243A4}"/>
               </a:ext>
             </a:extLst>
           </p:cNvPr>
@@ -9577,7 +11265,7 @@
           <p:cNvPr id="4" name="page">
             <a:extLst xmlns:a="http://schemas.openxmlformats.org/drawingml/2006/main">
               <a:ext uri="{FF2B5EF4-FFF2-40B4-BE49-F238E27FC236}">
-                <a16:creationId xmlns:a16="http://schemas.microsoft.com/office/drawing/2014/main" id="{6DE95620-421A-40FE-BBAB-15D0262362FB}"/>
+                <a16:creationId xmlns:a16="http://schemas.microsoft.com/office/drawing/2014/main" id="{169FAC9A-D719-4139-98BF-AC2DD18B7211}"/>
               </a:ext>
             </a:extLst>
           </p:cNvPr>
@@ -9645,7 +11333,7 @@
           <p:cNvPr id="5" name="buffer-choices">
             <a:extLst xmlns:a="http://schemas.openxmlformats.org/drawingml/2006/main">
               <a:ext uri="{FF2B5EF4-FFF2-40B4-BE49-F238E27FC236}">
-                <a16:creationId xmlns:a16="http://schemas.microsoft.com/office/drawing/2014/main" id="{F7A93B15-23DD-4860-95A2-F3EF1C7C55B7}"/>
+                <a16:creationId xmlns:a16="http://schemas.microsoft.com/office/drawing/2014/main" id="{72AB2D5D-7DB4-4928-84F5-B24503555EFF}"/>
               </a:ext>
             </a:extLst>
           </p:cNvPr>
@@ -10067,7 +11755,7 @@
           <p:cNvPr id="6" name="current-configuration">
             <a:extLst xmlns:a="http://schemas.openxmlformats.org/drawingml/2006/main">
               <a:ext uri="{FF2B5EF4-FFF2-40B4-BE49-F238E27FC236}">
-                <a16:creationId xmlns:a16="http://schemas.microsoft.com/office/drawing/2014/main" id="{D8F545BB-A4FC-456D-9AEA-95A4E54F644C}"/>
+                <a16:creationId xmlns:a16="http://schemas.microsoft.com/office/drawing/2014/main" id="{05E26295-7000-4EBE-B2F9-FD89E2FFF67B}"/>
               </a:ext>
             </a:extLst>
           </p:cNvPr>
@@ -10135,7 +11823,7 @@
           <p:cNvPr id="7" name="current-configuration-detail">
             <a:extLst xmlns:a="http://schemas.openxmlformats.org/drawingml/2006/main">
               <a:ext uri="{FF2B5EF4-FFF2-40B4-BE49-F238E27FC236}">
-                <a16:creationId xmlns:a16="http://schemas.microsoft.com/office/drawing/2014/main" id="{600B73D1-53AC-47EB-B6EE-36F962F510B6}"/>
+                <a16:creationId xmlns:a16="http://schemas.microsoft.com/office/drawing/2014/main" id="{BD8CA57B-4613-4CAB-A083-F43E82772511}"/>
               </a:ext>
             </a:extLst>
           </p:cNvPr>
@@ -10295,7 +11983,7 @@
           <p:cNvPr id="8" name="buffer-choice-explanation">
             <a:extLst xmlns:a="http://schemas.openxmlformats.org/drawingml/2006/main">
               <a:ext uri="{FF2B5EF4-FFF2-40B4-BE49-F238E27FC236}">
-                <a16:creationId xmlns:a16="http://schemas.microsoft.com/office/drawing/2014/main" id="{19911F2E-013D-4748-8204-73BB4B4F9392}"/>
+                <a16:creationId xmlns:a16="http://schemas.microsoft.com/office/drawing/2014/main" id="{60848CE8-5D9A-41E9-8C5F-2E5531121B77}"/>
               </a:ext>
             </a:extLst>
           </p:cNvPr>
@@ -10386,7 +12074,7 @@
           <p:cNvPr id="9" name="partial-read-limit">
             <a:extLst xmlns:a="http://schemas.openxmlformats.org/drawingml/2006/main">
               <a:ext uri="{FF2B5EF4-FFF2-40B4-BE49-F238E27FC236}">
-                <a16:creationId xmlns:a16="http://schemas.microsoft.com/office/drawing/2014/main" id="{B12A930A-8487-482A-8680-5CA8E1FAB55A}"/>
+                <a16:creationId xmlns:a16="http://schemas.microsoft.com/office/drawing/2014/main" id="{3EA508EC-D58D-4A5B-B367-777FDAC0BB11}"/>
               </a:ext>
             </a:extLst>
           </p:cNvPr>
@@ -10475,7 +12163,7 @@
     </p:spTree>
     <p:extLst>
       <p:ext uri="{BB962C8B-B14F-4D97-AF65-F5344CB8AC3E}">
-        <p14:creationId xmlns:p14="http://schemas.microsoft.com/office/powerpoint/2010/main" val="962032270"/>
+        <p14:creationId xmlns:p14="http://schemas.microsoft.com/office/powerpoint/2010/main" val="1713015743"/>
       </p:ext>
     </p:extLst>
   </p:cSld>
@@ -10506,7 +12194,7 @@
           <p:cNvPr id="9" name="title">
             <a:extLst xmlns:a="http://schemas.openxmlformats.org/drawingml/2006/main">
               <a:ext uri="{FF2B5EF4-FFF2-40B4-BE49-F238E27FC236}">
-                <a16:creationId xmlns:a16="http://schemas.microsoft.com/office/drawing/2014/main" id="{15CD16D7-8B6F-4F6B-8638-80FF441987E2}"/>
+                <a16:creationId xmlns:a16="http://schemas.microsoft.com/office/drawing/2014/main" id="{A973E97F-8038-437D-8601-127554123BC6}"/>
               </a:ext>
             </a:extLst>
           </p:cNvPr>
@@ -10574,7 +12262,7 @@
           <p:cNvPr id="2" name="subtitle">
             <a:extLst xmlns:a="http://schemas.openxmlformats.org/drawingml/2006/main">
               <a:ext uri="{FF2B5EF4-FFF2-40B4-BE49-F238E27FC236}">
-                <a16:creationId xmlns:a16="http://schemas.microsoft.com/office/drawing/2014/main" id="{304E4617-B0D3-401D-923F-DAD43B3BBA9E}"/>
+                <a16:creationId xmlns:a16="http://schemas.microsoft.com/office/drawing/2014/main" id="{FF5CD5FB-5C05-425C-BFFE-F290628DBB99}"/>
               </a:ext>
             </a:extLst>
           </p:cNvPr>
@@ -10642,7 +12330,7 @@
           <p:cNvPr id="3" name="footer">
             <a:extLst xmlns:a="http://schemas.openxmlformats.org/drawingml/2006/main">
               <a:ext uri="{FF2B5EF4-FFF2-40B4-BE49-F238E27FC236}">
-                <a16:creationId xmlns:a16="http://schemas.microsoft.com/office/drawing/2014/main" id="{2AB2869C-5D9C-416D-88BC-ED232D5883C7}"/>
+                <a16:creationId xmlns:a16="http://schemas.microsoft.com/office/drawing/2014/main" id="{AD951231-35D1-45AE-91B8-B2DD0F29924D}"/>
               </a:ext>
             </a:extLst>
           </p:cNvPr>
@@ -10710,7 +12398,7 @@
           <p:cNvPr id="4" name="page">
             <a:extLst xmlns:a="http://schemas.openxmlformats.org/drawingml/2006/main">
               <a:ext uri="{FF2B5EF4-FFF2-40B4-BE49-F238E27FC236}">
-                <a16:creationId xmlns:a16="http://schemas.microsoft.com/office/drawing/2014/main" id="{0531BC2D-3928-473A-AE75-C3A20DFD6013}"/>
+                <a16:creationId xmlns:a16="http://schemas.microsoft.com/office/drawing/2014/main" id="{510DC3C1-34BF-4674-BD16-238DDB88614E}"/>
               </a:ext>
             </a:extLst>
           </p:cNvPr>
@@ -10778,7 +12466,7 @@
           <p:cNvPr id="5" name="comparison-contract">
             <a:extLst xmlns:a="http://schemas.openxmlformats.org/drawingml/2006/main">
               <a:ext uri="{FF2B5EF4-FFF2-40B4-BE49-F238E27FC236}">
-                <a16:creationId xmlns:a16="http://schemas.microsoft.com/office/drawing/2014/main" id="{66098466-40BC-4C18-A3F0-7C69F6143752}"/>
+                <a16:creationId xmlns:a16="http://schemas.microsoft.com/office/drawing/2014/main" id="{462D6BD9-0568-4246-BAF7-6F3CC936ABD1}"/>
               </a:ext>
             </a:extLst>
           </p:cNvPr>
@@ -11103,7 +12791,7 @@
           <p:cNvPr id="6" name="tr-preserved">
             <a:extLst xmlns:a="http://schemas.openxmlformats.org/drawingml/2006/main">
               <a:ext uri="{FF2B5EF4-FFF2-40B4-BE49-F238E27FC236}">
-                <a16:creationId xmlns:a16="http://schemas.microsoft.com/office/drawing/2014/main" id="{B1D40A1F-2900-491D-9302-C81FA23E39C6}"/>
+                <a16:creationId xmlns:a16="http://schemas.microsoft.com/office/drawing/2014/main" id="{FA80CF6B-F194-4D1E-BE42-0CBD782176BD}"/>
               </a:ext>
             </a:extLst>
           </p:cNvPr>
@@ -11171,7 +12859,7 @@
           <p:cNvPr id="7" name="tr-values">
             <a:extLst xmlns:a="http://schemas.openxmlformats.org/drawingml/2006/main">
               <a:ext uri="{FF2B5EF4-FFF2-40B4-BE49-F238E27FC236}">
-                <a16:creationId xmlns:a16="http://schemas.microsoft.com/office/drawing/2014/main" id="{4E63B78C-F286-42EB-908F-5640C596BBB1}"/>
+                <a16:creationId xmlns:a16="http://schemas.microsoft.com/office/drawing/2014/main" id="{DB76E6A8-1F46-4FFF-BB8F-EA01D75223F3}"/>
               </a:ext>
             </a:extLst>
           </p:cNvPr>
@@ -11239,7 +12927,7 @@
           <p:cNvPr id="8" name="limits">
             <a:extLst xmlns:a="http://schemas.openxmlformats.org/drawingml/2006/main">
               <a:ext uri="{FF2B5EF4-FFF2-40B4-BE49-F238E27FC236}">
-                <a16:creationId xmlns:a16="http://schemas.microsoft.com/office/drawing/2014/main" id="{C82548F4-A5DB-4B0B-B6AA-5873527619CF}"/>
+                <a16:creationId xmlns:a16="http://schemas.microsoft.com/office/drawing/2014/main" id="{DE2465C4-9A31-4654-8C12-6E34AF09ED5D}"/>
               </a:ext>
             </a:extLst>
           </p:cNvPr>
@@ -11328,7 +13016,1017 @@
     </p:spTree>
     <p:extLst>
       <p:ext uri="{BB962C8B-B14F-4D97-AF65-F5344CB8AC3E}">
-        <p14:creationId xmlns:p14="http://schemas.microsoft.com/office/powerpoint/2010/main" val="1897784740"/>
+        <p14:creationId xmlns:p14="http://schemas.microsoft.com/office/powerpoint/2010/main" val="980831528"/>
+      </p:ext>
+    </p:extLst>
+  </p:cSld>
+</p:sld>
+</file>
+
+<file path=ppt/slides/slide9.xml><?xml version="1.0" encoding="utf-8"?>
+<p:sld xmlns:p="http://schemas.openxmlformats.org/presentationml/2006/main">
+  <p:cSld>
+    <p:bg>
+      <p:bgPr>
+        <a:solidFill xmlns:a="http://schemas.openxmlformats.org/drawingml/2006/main">
+          <a:srgbClr val="FFFFFF"/>
+        </a:solidFill>
+      </p:bgPr>
+    </p:bg>
+    <p:spTree>
+      <p:nvGrpSpPr>
+        <p:cNvPr id="1" name=""/>
+        <p:cNvGrpSpPr/>
+        <p:nvPr/>
+      </p:nvGrpSpPr>
+      <p:grpSpPr>
+        <a:xfrm xmlns:a="http://schemas.openxmlformats.org/drawingml/2006/main"/>
+      </p:grpSpPr>
+      <p:sp>
+        <p:nvSpPr>
+          <p:cNvPr id="7" name="title">
+            <a:extLst xmlns:a="http://schemas.openxmlformats.org/drawingml/2006/main">
+              <a:ext uri="{FF2B5EF4-FFF2-40B4-BE49-F238E27FC236}">
+                <a16:creationId xmlns:a16="http://schemas.microsoft.com/office/drawing/2014/main" id="{BC77FDC2-B95A-42C2-B86D-21CFD4612774}"/>
+              </a:ext>
+            </a:extLst>
+          </p:cNvPr>
+          <p:cNvSpPr>
+            <a:spLocks xmlns:a="http://schemas.openxmlformats.org/drawingml/2006/main" noGrp="1"/>
+          </p:cNvSpPr>
+          <p:nvPr/>
+        </p:nvSpPr>
+        <p:spPr>
+          <a:xfrm xmlns:a="http://schemas.openxmlformats.org/drawingml/2006/main">
+            <a:off x="533400" y="438150"/>
+            <a:ext cx="11125200" cy="628650"/>
+          </a:xfrm>
+          <a:prstGeom xmlns:a="http://schemas.openxmlformats.org/drawingml/2006/main" prst="rect">
+            <a:avLst/>
+          </a:prstGeom>
+          <a:noFill xmlns:a="http://schemas.openxmlformats.org/drawingml/2006/main"/>
+          <a:ln xmlns:a="http://schemas.openxmlformats.org/drawingml/2006/main" w="0">
+            <a:noFill/>
+          </a:ln>
+        </p:spPr>
+        <p:txBody>
+          <a:bodyPr xmlns:a="http://schemas.openxmlformats.org/drawingml/2006/main" wrap="square" lIns="0" tIns="0" rIns="0" bIns="0" anchor="t">
+            <a:noAutofit/>
+          </a:bodyPr>
+          <a:lstStyle xmlns:a="http://schemas.openxmlformats.org/drawingml/2006/main">
+            <a:defPPr>
+              <a:defRPr sz="3300" b="1">
+                <a:solidFill>
+                  <a:srgbClr val="172738"/>
+                </a:solidFill>
+                <a:latin typeface="Apple SD Gothic Neo"/>
+                <a:ea typeface="Apple SD Gothic Neo"/>
+                <a:cs typeface="Apple SD Gothic Neo"/>
+              </a:defRPr>
+            </a:defPPr>
+          </a:lstStyle>
+          <a:p xmlns:a="http://schemas.openxmlformats.org/drawingml/2006/main">
+            <a:pPr>
+              <a:defRPr sz="3300" b="1">
+                <a:solidFill>
+                  <a:srgbClr val="172738"/>
+                </a:solidFill>
+                <a:latin typeface="Apple SD Gothic Neo"/>
+                <a:ea typeface="Apple SD Gothic Neo"/>
+                <a:cs typeface="Apple SD Gothic Neo"/>
+              </a:defRPr>
+            </a:pPr>
+            <a:r>
+              <a:rPr sz="3300" b="1">
+                <a:solidFill>
+                  <a:srgbClr val="172738"/>
+                </a:solidFill>
+                <a:latin typeface="Apple SD Gothic Neo"/>
+                <a:ea typeface="Apple SD Gothic Neo"/>
+                <a:cs typeface="Apple SD Gothic Neo"/>
+              </a:rPr>
+              <a:t>A·B 워크로드의 요청 크기와 접근 순서</a:t>
+            </a:r>
+          </a:p>
+        </p:txBody>
+      </p:sp>
+      <p:sp>
+        <p:nvSpPr>
+          <p:cNvPr id="2" name="subtitle">
+            <a:extLst xmlns:a="http://schemas.openxmlformats.org/drawingml/2006/main">
+              <a:ext uri="{FF2B5EF4-FFF2-40B4-BE49-F238E27FC236}">
+                <a16:creationId xmlns:a16="http://schemas.microsoft.com/office/drawing/2014/main" id="{7D9CF4C3-BC68-4B21-A470-00DD3DFB1004}"/>
+              </a:ext>
+            </a:extLst>
+          </p:cNvPr>
+          <p:cNvSpPr>
+            <a:spLocks xmlns:a="http://schemas.openxmlformats.org/drawingml/2006/main" noGrp="1"/>
+          </p:cNvSpPr>
+          <p:nvPr/>
+        </p:nvSpPr>
+        <p:spPr>
+          <a:xfrm xmlns:a="http://schemas.openxmlformats.org/drawingml/2006/main">
+            <a:off x="552450" y="1104900"/>
+            <a:ext cx="11087100" cy="571500"/>
+          </a:xfrm>
+          <a:prstGeom xmlns:a="http://schemas.openxmlformats.org/drawingml/2006/main" prst="rect">
+            <a:avLst/>
+          </a:prstGeom>
+          <a:noFill xmlns:a="http://schemas.openxmlformats.org/drawingml/2006/main"/>
+          <a:ln xmlns:a="http://schemas.openxmlformats.org/drawingml/2006/main" w="0">
+            <a:noFill/>
+          </a:ln>
+        </p:spPr>
+        <p:txBody>
+          <a:bodyPr xmlns:a="http://schemas.openxmlformats.org/drawingml/2006/main" wrap="square" lIns="0" tIns="0" rIns="0" bIns="0" anchor="t">
+            <a:noAutofit/>
+          </a:bodyPr>
+          <a:lstStyle xmlns:a="http://schemas.openxmlformats.org/drawingml/2006/main">
+            <a:defPPr>
+              <a:defRPr sz="1800" b="0">
+                <a:solidFill>
+                  <a:srgbClr val="586875"/>
+                </a:solidFill>
+                <a:latin typeface="Apple SD Gothic Neo"/>
+                <a:ea typeface="Apple SD Gothic Neo"/>
+                <a:cs typeface="Apple SD Gothic Neo"/>
+              </a:defRPr>
+            </a:defPPr>
+          </a:lstStyle>
+          <a:p xmlns:a="http://schemas.openxmlformats.org/drawingml/2006/main">
+            <a:pPr>
+              <a:defRPr sz="1800" b="0">
+                <a:solidFill>
+                  <a:srgbClr val="586875"/>
+                </a:solidFill>
+                <a:latin typeface="Apple SD Gothic Neo"/>
+                <a:ea typeface="Apple SD Gothic Neo"/>
+                <a:cs typeface="Apple SD Gothic Neo"/>
+              </a:defRPr>
+            </a:pPr>
+            <a:r>
+              <a:rPr sz="1800" b="0">
+                <a:solidFill>
+                  <a:srgbClr val="586875"/>
+                </a:solidFill>
+                <a:latin typeface="Apple SD Gothic Neo"/>
+                <a:ea typeface="Apple SD Gothic Neo"/>
+                <a:cs typeface="Apple SD Gothic Neo"/>
+              </a:rPr>
+              <a:t>아래 P1, P2는 각각 4KiB 논리 페이지입니다. NAND의 16KiB 물리 페이지와 구분합니다.</a:t>
+            </a:r>
+          </a:p>
+        </p:txBody>
+      </p:sp>
+      <p:sp>
+        <p:nvSpPr>
+          <p:cNvPr id="3" name="footer">
+            <a:extLst xmlns:a="http://schemas.openxmlformats.org/drawingml/2006/main">
+              <a:ext uri="{FF2B5EF4-FFF2-40B4-BE49-F238E27FC236}">
+                <a16:creationId xmlns:a16="http://schemas.microsoft.com/office/drawing/2014/main" id="{D664E148-9575-4A52-A056-8F27162C3162}"/>
+              </a:ext>
+            </a:extLst>
+          </p:cNvPr>
+          <p:cNvSpPr>
+            <a:spLocks xmlns:a="http://schemas.openxmlformats.org/drawingml/2006/main" noGrp="1"/>
+          </p:cNvSpPr>
+          <p:nvPr/>
+        </p:nvSpPr>
+        <p:spPr>
+          <a:xfrm xmlns:a="http://schemas.openxmlformats.org/drawingml/2006/main">
+            <a:off x="533400" y="6419850"/>
+            <a:ext cx="10477500" cy="257175"/>
+          </a:xfrm>
+          <a:prstGeom xmlns:a="http://schemas.openxmlformats.org/drawingml/2006/main" prst="rect">
+            <a:avLst/>
+          </a:prstGeom>
+          <a:noFill xmlns:a="http://schemas.openxmlformats.org/drawingml/2006/main"/>
+          <a:ln xmlns:a="http://schemas.openxmlformats.org/drawingml/2006/main" w="0">
+            <a:noFill/>
+          </a:ln>
+        </p:spPr>
+        <p:txBody>
+          <a:bodyPr xmlns:a="http://schemas.openxmlformats.org/drawingml/2006/main" wrap="square" lIns="0" tIns="0" rIns="0" bIns="0" anchor="t">
+            <a:noAutofit/>
+          </a:bodyPr>
+          <a:lstStyle xmlns:a="http://schemas.openxmlformats.org/drawingml/2006/main">
+            <a:defPPr>
+              <a:defRPr sz="1200" b="0">
+                <a:solidFill>
+                  <a:srgbClr val="586875"/>
+                </a:solidFill>
+                <a:latin typeface="Apple SD Gothic Neo"/>
+                <a:ea typeface="Apple SD Gothic Neo"/>
+                <a:cs typeface="Apple SD Gothic Neo"/>
+              </a:defRPr>
+            </a:defPPr>
+          </a:lstStyle>
+          <a:p xmlns:a="http://schemas.openxmlformats.org/drawingml/2006/main">
+            <a:pPr>
+              <a:defRPr sz="1200" b="0">
+                <a:solidFill>
+                  <a:srgbClr val="586875"/>
+                </a:solidFill>
+                <a:latin typeface="Apple SD Gothic Neo"/>
+                <a:ea typeface="Apple SD Gothic Neo"/>
+                <a:cs typeface="Apple SD Gothic Neo"/>
+              </a:defRPr>
+            </a:pPr>
+            <a:r>
+              <a:rPr sz="1200" b="0">
+                <a:solidFill>
+                  <a:srgbClr val="586875"/>
+                </a:solidFill>
+                <a:latin typeface="Apple SD Gothic Neo"/>
+                <a:ea typeface="Apple SD Gothic Neo"/>
+                <a:cs typeface="Apple SD Gothic Neo"/>
+              </a:rPr>
+              <a:t>근거: model.py의 workload(), A/B 지속 부하 생성기. A2/B2는 3개 단위의 국소 순열</a:t>
+            </a:r>
+          </a:p>
+        </p:txBody>
+      </p:sp>
+      <p:sp>
+        <p:nvSpPr>
+          <p:cNvPr id="4" name="page">
+            <a:extLst xmlns:a="http://schemas.openxmlformats.org/drawingml/2006/main">
+              <a:ext uri="{FF2B5EF4-FFF2-40B4-BE49-F238E27FC236}">
+                <a16:creationId xmlns:a16="http://schemas.microsoft.com/office/drawing/2014/main" id="{2559EDB8-D37E-49FF-B8E3-C7FEDCA88E3C}"/>
+              </a:ext>
+            </a:extLst>
+          </p:cNvPr>
+          <p:cNvSpPr>
+            <a:spLocks xmlns:a="http://schemas.openxmlformats.org/drawingml/2006/main" noGrp="1"/>
+          </p:cNvSpPr>
+          <p:nvPr/>
+        </p:nvSpPr>
+        <p:spPr>
+          <a:xfrm xmlns:a="http://schemas.openxmlformats.org/drawingml/2006/main">
+            <a:off x="11144250" y="6419850"/>
+            <a:ext cx="495300" cy="257175"/>
+          </a:xfrm>
+          <a:prstGeom xmlns:a="http://schemas.openxmlformats.org/drawingml/2006/main" prst="rect">
+            <a:avLst/>
+          </a:prstGeom>
+          <a:noFill xmlns:a="http://schemas.openxmlformats.org/drawingml/2006/main"/>
+          <a:ln xmlns:a="http://schemas.openxmlformats.org/drawingml/2006/main" w="0">
+            <a:noFill/>
+          </a:ln>
+        </p:spPr>
+        <p:txBody>
+          <a:bodyPr xmlns:a="http://schemas.openxmlformats.org/drawingml/2006/main" wrap="square" lIns="0" tIns="0" rIns="0" bIns="0" anchor="t">
+            <a:noAutofit/>
+          </a:bodyPr>
+          <a:lstStyle xmlns:a="http://schemas.openxmlformats.org/drawingml/2006/main">
+            <a:defPPr>
+              <a:defRPr sz="1200" b="0">
+                <a:solidFill>
+                  <a:srgbClr val="586875"/>
+                </a:solidFill>
+                <a:latin typeface="Apple SD Gothic Neo"/>
+                <a:ea typeface="Apple SD Gothic Neo"/>
+                <a:cs typeface="Apple SD Gothic Neo"/>
+              </a:defRPr>
+            </a:defPPr>
+          </a:lstStyle>
+          <a:p xmlns:a="http://schemas.openxmlformats.org/drawingml/2006/main">
+            <a:pPr>
+              <a:defRPr sz="1200" b="0">
+                <a:solidFill>
+                  <a:srgbClr val="586875"/>
+                </a:solidFill>
+                <a:latin typeface="Apple SD Gothic Neo"/>
+                <a:ea typeface="Apple SD Gothic Neo"/>
+                <a:cs typeface="Apple SD Gothic Neo"/>
+              </a:defRPr>
+            </a:pPr>
+            <a:r>
+              <a:rPr sz="1200" b="0">
+                <a:solidFill>
+                  <a:srgbClr val="586875"/>
+                </a:solidFill>
+                <a:latin typeface="Apple SD Gothic Neo"/>
+                <a:ea typeface="Apple SD Gothic Neo"/>
+                <a:cs typeface="Apple SD Gothic Neo"/>
+              </a:rPr>
+              <a:t>09</a:t>
+            </a:r>
+          </a:p>
+        </p:txBody>
+      </p:sp>
+      <p:graphicFrame>
+        <p:nvGraphicFramePr>
+          <p:cNvPr id="5" name="workload-patterns">
+            <a:extLst xmlns:a="http://schemas.openxmlformats.org/drawingml/2006/main">
+              <a:ext uri="{FF2B5EF4-FFF2-40B4-BE49-F238E27FC236}">
+                <a16:creationId xmlns:a16="http://schemas.microsoft.com/office/drawing/2014/main" id="{751C8724-80FB-4562-926B-CEB03F5BEAE0}"/>
+              </a:ext>
+            </a:extLst>
+          </p:cNvPr>
+          <p:cNvGraphicFramePr/>
+          <p:nvPr/>
+        </p:nvGraphicFramePr>
+        <p:xfrm>
+          <a:off xmlns:a="http://schemas.openxmlformats.org/drawingml/2006/main" x="533400" y="1819275"/>
+          <a:ext xmlns:a="http://schemas.openxmlformats.org/drawingml/2006/main" cx="11125200" cy="3467100"/>
+        </p:xfrm>
+        <a:graphic xmlns:a="http://schemas.openxmlformats.org/drawingml/2006/main">
+          <a:graphicData uri="http://schemas.openxmlformats.org/drawingml/2006/table">
+            <a:tbl>
+              <a:tblPr/>
+              <a:tblGrid>
+                <a:gridCol w="1000125"/>
+                <a:gridCol w="1571625"/>
+                <a:gridCol w="4429125"/>
+                <a:gridCol w="4124325"/>
+              </a:tblGrid>
+              <a:tr h="577850">
+                <a:tc>
+                  <a:txBody>
+                    <a:bodyPr lIns="114300" tIns="114300" rIns="114300" bIns="114300"/>
+                    <a:lstStyle/>
+                    <a:p>
+                      <a:r>
+                        <a:rPr sz="1725" b="1">
+                          <a:solidFill>
+                            <a:srgbClr val="FFFFFF"/>
+                          </a:solidFill>
+                          <a:latin typeface="Apple SD Gothic Neo"/>
+                          <a:ea typeface="Apple SD Gothic Neo"/>
+                          <a:cs typeface="Apple SD Gothic Neo"/>
+                        </a:rPr>
+                        <a:t>패턴</a:t>
+                      </a:r>
+                    </a:p>
+                  </a:txBody>
+                  <a:tcPr marL="133350" marR="133350" marT="95250" marB="95250" anchor="ctr">
+                    <a:solidFill>
+                      <a:srgbClr val="122C40"/>
+                    </a:solidFill>
+                  </a:tcPr>
+                </a:tc>
+                <a:tc>
+                  <a:txBody>
+                    <a:bodyPr lIns="114300" tIns="114300" rIns="114300" bIns="114300"/>
+                    <a:lstStyle/>
+                    <a:p>
+                      <a:r>
+                        <a:rPr sz="1725" b="1">
+                          <a:solidFill>
+                            <a:srgbClr val="FFFFFF"/>
+                          </a:solidFill>
+                          <a:latin typeface="Apple SD Gothic Neo"/>
+                          <a:ea typeface="Apple SD Gothic Neo"/>
+                          <a:cs typeface="Apple SD Gothic Neo"/>
+                        </a:rPr>
+                        <a:t>요청당 반환</a:t>
+                      </a:r>
+                    </a:p>
+                  </a:txBody>
+                  <a:tcPr marL="133350" marR="133350" marT="95250" marB="95250" anchor="ctr">
+                    <a:solidFill>
+                      <a:srgbClr val="122C40"/>
+                    </a:solidFill>
+                  </a:tcPr>
+                </a:tc>
+                <a:tc>
+                  <a:txBody>
+                    <a:bodyPr lIns="114300" tIns="114300" rIns="114300" bIns="114300"/>
+                    <a:lstStyle/>
+                    <a:p>
+                      <a:r>
+                        <a:rPr sz="1725" b="1">
+                          <a:solidFill>
+                            <a:srgbClr val="FFFFFF"/>
+                          </a:solidFill>
+                          <a:latin typeface="Apple SD Gothic Neo"/>
+                          <a:ea typeface="Apple SD Gothic Neo"/>
+                          <a:cs typeface="Apple SD Gothic Neo"/>
+                        </a:rPr>
+                        <a:t>논리 페이지 접근 순서</a:t>
+                      </a:r>
+                    </a:p>
+                  </a:txBody>
+                  <a:tcPr marL="133350" marR="133350" marT="95250" marB="95250" anchor="ctr">
+                    <a:solidFill>
+                      <a:srgbClr val="122C40"/>
+                    </a:solidFill>
+                  </a:tcPr>
+                </a:tc>
+                <a:tc>
+                  <a:txBody>
+                    <a:bodyPr lIns="114300" tIns="114300" rIns="114300" bIns="114300"/>
+                    <a:lstStyle/>
+                    <a:p>
+                      <a:r>
+                        <a:rPr sz="1725" b="1">
+                          <a:solidFill>
+                            <a:srgbClr val="FFFFFF"/>
+                          </a:solidFill>
+                          <a:latin typeface="Apple SD Gothic Neo"/>
+                          <a:ea typeface="Apple SD Gothic Neo"/>
+                          <a:cs typeface="Apple SD Gothic Neo"/>
+                        </a:rPr>
+                        <a:t>패턴의 의미</a:t>
+                      </a:r>
+                    </a:p>
+                  </a:txBody>
+                  <a:tcPr marL="133350" marR="133350" marT="95250" marB="95250" anchor="ctr">
+                    <a:solidFill>
+                      <a:srgbClr val="122C40"/>
+                    </a:solidFill>
+                  </a:tcPr>
+                </a:tc>
+              </a:tr>
+              <a:tr h="577850">
+                <a:tc>
+                  <a:txBody>
+                    <a:bodyPr lIns="114300" tIns="114300" rIns="114300" bIns="114300"/>
+                    <a:lstStyle/>
+                    <a:p>
+                      <a:r>
+                        <a:rPr sz="1725" b="0">
+                          <a:solidFill>
+                            <a:srgbClr val="172738"/>
+                          </a:solidFill>
+                          <a:latin typeface="Apple SD Gothic Neo"/>
+                          <a:ea typeface="Apple SD Gothic Neo"/>
+                          <a:cs typeface="Apple SD Gothic Neo"/>
+                        </a:rPr>
+                        <a:t>A1</a:t>
+                      </a:r>
+                    </a:p>
+                  </a:txBody>
+                  <a:tcPr marL="133350" marR="133350" marT="95250" marB="95250" anchor="ctr">
+                    <a:solidFill>
+                      <a:srgbClr val="FFFFFF"/>
+                    </a:solidFill>
+                  </a:tcPr>
+                </a:tc>
+                <a:tc>
+                  <a:txBody>
+                    <a:bodyPr lIns="114300" tIns="114300" rIns="114300" bIns="114300"/>
+                    <a:lstStyle/>
+                    <a:p>
+                      <a:r>
+                        <a:rPr sz="1725" b="0">
+                          <a:solidFill>
+                            <a:srgbClr val="172738"/>
+                          </a:solidFill>
+                          <a:latin typeface="Apple SD Gothic Neo"/>
+                          <a:ea typeface="Apple SD Gothic Neo"/>
+                          <a:cs typeface="Apple SD Gothic Neo"/>
+                        </a:rPr>
+                        <a:t>4KiB</a:t>
+                      </a:r>
+                    </a:p>
+                  </a:txBody>
+                  <a:tcPr marL="133350" marR="133350" marT="95250" marB="95250" anchor="ctr">
+                    <a:solidFill>
+                      <a:srgbClr val="FFFFFF"/>
+                    </a:solidFill>
+                  </a:tcPr>
+                </a:tc>
+                <a:tc>
+                  <a:txBody>
+                    <a:bodyPr lIns="114300" tIns="114300" rIns="114300" bIns="114300"/>
+                    <a:lstStyle/>
+                    <a:p>
+                      <a:r>
+                        <a:rPr sz="1725" b="0">
+                          <a:solidFill>
+                            <a:srgbClr val="172738"/>
+                          </a:solidFill>
+                          <a:latin typeface="Apple SD Gothic Neo"/>
+                          <a:ea typeface="Apple SD Gothic Neo"/>
+                          <a:cs typeface="Apple SD Gothic Neo"/>
+                        </a:rPr>
+                        <a:t>P1, P2, P3, P4, …</a:t>
+                      </a:r>
+                    </a:p>
+                  </a:txBody>
+                  <a:tcPr marL="133350" marR="133350" marT="95250" marB="95250" anchor="ctr">
+                    <a:solidFill>
+                      <a:srgbClr val="FFFFFF"/>
+                    </a:solidFill>
+                  </a:tcPr>
+                </a:tc>
+                <a:tc>
+                  <a:txBody>
+                    <a:bodyPr lIns="114300" tIns="114300" rIns="114300" bIns="114300"/>
+                    <a:lstStyle/>
+                    <a:p>
+                      <a:r>
+                        <a:rPr sz="1725" b="0">
+                          <a:solidFill>
+                            <a:srgbClr val="172738"/>
+                          </a:solidFill>
+                          <a:latin typeface="Apple SD Gothic Neo"/>
+                          <a:ea typeface="Apple SD Gothic Neo"/>
+                          <a:cs typeface="Apple SD Gothic Neo"/>
+                        </a:rPr>
+                        <a:t>각 논리 페이지 전체를 순서대로 읽음</a:t>
+                      </a:r>
+                    </a:p>
+                  </a:txBody>
+                  <a:tcPr marL="133350" marR="133350" marT="95250" marB="95250" anchor="ctr">
+                    <a:solidFill>
+                      <a:srgbClr val="FFFFFF"/>
+                    </a:solidFill>
+                  </a:tcPr>
+                </a:tc>
+              </a:tr>
+              <a:tr h="577850">
+                <a:tc>
+                  <a:txBody>
+                    <a:bodyPr lIns="114300" tIns="114300" rIns="114300" bIns="114300"/>
+                    <a:lstStyle/>
+                    <a:p>
+                      <a:r>
+                        <a:rPr sz="1725" b="0">
+                          <a:solidFill>
+                            <a:srgbClr val="172738"/>
+                          </a:solidFill>
+                          <a:latin typeface="Apple SD Gothic Neo"/>
+                          <a:ea typeface="Apple SD Gothic Neo"/>
+                          <a:cs typeface="Apple SD Gothic Neo"/>
+                        </a:rPr>
+                        <a:t>A2</a:t>
+                      </a:r>
+                    </a:p>
+                  </a:txBody>
+                  <a:tcPr marL="133350" marR="133350" marT="95250" marB="95250" anchor="ctr">
+                    <a:solidFill>
+                      <a:srgbClr val="F1F5F8"/>
+                    </a:solidFill>
+                  </a:tcPr>
+                </a:tc>
+                <a:tc>
+                  <a:txBody>
+                    <a:bodyPr lIns="114300" tIns="114300" rIns="114300" bIns="114300"/>
+                    <a:lstStyle/>
+                    <a:p>
+                      <a:r>
+                        <a:rPr sz="1725" b="0">
+                          <a:solidFill>
+                            <a:srgbClr val="172738"/>
+                          </a:solidFill>
+                          <a:latin typeface="Apple SD Gothic Neo"/>
+                          <a:ea typeface="Apple SD Gothic Neo"/>
+                          <a:cs typeface="Apple SD Gothic Neo"/>
+                        </a:rPr>
+                        <a:t>4KiB</a:t>
+                      </a:r>
+                    </a:p>
+                  </a:txBody>
+                  <a:tcPr marL="133350" marR="133350" marT="95250" marB="95250" anchor="ctr">
+                    <a:solidFill>
+                      <a:srgbClr val="F1F5F8"/>
+                    </a:solidFill>
+                  </a:tcPr>
+                </a:tc>
+                <a:tc>
+                  <a:txBody>
+                    <a:bodyPr lIns="114300" tIns="114300" rIns="114300" bIns="114300"/>
+                    <a:lstStyle/>
+                    <a:p>
+                      <a:r>
+                        <a:rPr sz="1725" b="0">
+                          <a:solidFill>
+                            <a:srgbClr val="172738"/>
+                          </a:solidFill>
+                          <a:latin typeface="Apple SD Gothic Neo"/>
+                          <a:ea typeface="Apple SD Gothic Neo"/>
+                          <a:cs typeface="Apple SD Gothic Neo"/>
+                        </a:rPr>
+                        <a:t>P1, P3, P2, P4, P6, P5, …</a:t>
+                      </a:r>
+                    </a:p>
+                  </a:txBody>
+                  <a:tcPr marL="133350" marR="133350" marT="95250" marB="95250" anchor="ctr">
+                    <a:solidFill>
+                      <a:srgbClr val="F1F5F8"/>
+                    </a:solidFill>
+                  </a:tcPr>
+                </a:tc>
+                <a:tc>
+                  <a:txBody>
+                    <a:bodyPr lIns="114300" tIns="114300" rIns="114300" bIns="114300"/>
+                    <a:lstStyle/>
+                    <a:p>
+                      <a:r>
+                        <a:rPr sz="1725" b="0">
+                          <a:solidFill>
+                            <a:srgbClr val="172738"/>
+                          </a:solidFill>
+                          <a:latin typeface="Apple SD Gothic Neo"/>
+                          <a:ea typeface="Apple SD Gothic Neo"/>
+                          <a:cs typeface="Apple SD Gothic Neo"/>
+                        </a:rPr>
+                        <a:t>3개씩 순서를 바꿔 페이지 전체를 읽음</a:t>
+                      </a:r>
+                    </a:p>
+                  </a:txBody>
+                  <a:tcPr marL="133350" marR="133350" marT="95250" marB="95250" anchor="ctr">
+                    <a:solidFill>
+                      <a:srgbClr val="F1F5F8"/>
+                    </a:solidFill>
+                  </a:tcPr>
+                </a:tc>
+              </a:tr>
+              <a:tr h="577850">
+                <a:tc>
+                  <a:txBody>
+                    <a:bodyPr lIns="114300" tIns="114300" rIns="114300" bIns="114300"/>
+                    <a:lstStyle/>
+                    <a:p>
+                      <a:r>
+                        <a:rPr sz="1725" b="0">
+                          <a:solidFill>
+                            <a:srgbClr val="172738"/>
+                          </a:solidFill>
+                          <a:latin typeface="Apple SD Gothic Neo"/>
+                          <a:ea typeface="Apple SD Gothic Neo"/>
+                          <a:cs typeface="Apple SD Gothic Neo"/>
+                        </a:rPr>
+                        <a:t>B1</a:t>
+                      </a:r>
+                    </a:p>
+                  </a:txBody>
+                  <a:tcPr marL="133350" marR="133350" marT="95250" marB="95250" anchor="ctr">
+                    <a:solidFill>
+                      <a:srgbClr val="FFFFFF"/>
+                    </a:solidFill>
+                  </a:tcPr>
+                </a:tc>
+                <a:tc>
+                  <a:txBody>
+                    <a:bodyPr lIns="114300" tIns="114300" rIns="114300" bIns="114300"/>
+                    <a:lstStyle/>
+                    <a:p>
+                      <a:r>
+                        <a:rPr sz="1725" b="0">
+                          <a:solidFill>
+                            <a:srgbClr val="172738"/>
+                          </a:solidFill>
+                          <a:latin typeface="Apple SD Gothic Neo"/>
+                          <a:ea typeface="Apple SD Gothic Neo"/>
+                          <a:cs typeface="Apple SD Gothic Neo"/>
+                        </a:rPr>
+                        <a:t>64B</a:t>
+                      </a:r>
+                    </a:p>
+                  </a:txBody>
+                  <a:tcPr marL="133350" marR="133350" marT="95250" marB="95250" anchor="ctr">
+                    <a:solidFill>
+                      <a:srgbClr val="FFFFFF"/>
+                    </a:solidFill>
+                  </a:tcPr>
+                </a:tc>
+                <a:tc>
+                  <a:txBody>
+                    <a:bodyPr lIns="114300" tIns="114300" rIns="114300" bIns="114300"/>
+                    <a:lstStyle/>
+                    <a:p>
+                      <a:r>
+                        <a:rPr sz="1725" b="0">
+                          <a:solidFill>
+                            <a:srgbClr val="172738"/>
+                          </a:solidFill>
+                          <a:latin typeface="Apple SD Gothic Neo"/>
+                          <a:ea typeface="Apple SD Gothic Neo"/>
+                          <a:cs typeface="Apple SD Gothic Neo"/>
+                        </a:rPr>
+                        <a:t>P1, P2, P3, P4, …</a:t>
+                      </a:r>
+                    </a:p>
+                  </a:txBody>
+                  <a:tcPr marL="133350" marR="133350" marT="95250" marB="95250" anchor="ctr">
+                    <a:solidFill>
+                      <a:srgbClr val="FFFFFF"/>
+                    </a:solidFill>
+                  </a:tcPr>
+                </a:tc>
+                <a:tc>
+                  <a:txBody>
+                    <a:bodyPr lIns="114300" tIns="114300" rIns="114300" bIns="114300"/>
+                    <a:lstStyle/>
+                    <a:p>
+                      <a:r>
+                        <a:rPr sz="1725" b="0">
+                          <a:solidFill>
+                            <a:srgbClr val="172738"/>
+                          </a:solidFill>
+                          <a:latin typeface="Apple SD Gothic Neo"/>
+                          <a:ea typeface="Apple SD Gothic Neo"/>
+                          <a:cs typeface="Apple SD Gothic Neo"/>
+                        </a:rPr>
+                        <a:t>각 페이지의 시작 64B만 읽음</a:t>
+                      </a:r>
+                    </a:p>
+                  </a:txBody>
+                  <a:tcPr marL="133350" marR="133350" marT="95250" marB="95250" anchor="ctr">
+                    <a:solidFill>
+                      <a:srgbClr val="FFFFFF"/>
+                    </a:solidFill>
+                  </a:tcPr>
+                </a:tc>
+              </a:tr>
+              <a:tr h="577850">
+                <a:tc>
+                  <a:txBody>
+                    <a:bodyPr lIns="114300" tIns="114300" rIns="114300" bIns="114300"/>
+                    <a:lstStyle/>
+                    <a:p>
+                      <a:r>
+                        <a:rPr sz="1725" b="0">
+                          <a:solidFill>
+                            <a:srgbClr val="172738"/>
+                          </a:solidFill>
+                          <a:latin typeface="Apple SD Gothic Neo"/>
+                          <a:ea typeface="Apple SD Gothic Neo"/>
+                          <a:cs typeface="Apple SD Gothic Neo"/>
+                        </a:rPr>
+                        <a:t>B2</a:t>
+                      </a:r>
+                    </a:p>
+                  </a:txBody>
+                  <a:tcPr marL="133350" marR="133350" marT="95250" marB="95250" anchor="ctr">
+                    <a:solidFill>
+                      <a:srgbClr val="F1F5F8"/>
+                    </a:solidFill>
+                  </a:tcPr>
+                </a:tc>
+                <a:tc>
+                  <a:txBody>
+                    <a:bodyPr lIns="114300" tIns="114300" rIns="114300" bIns="114300"/>
+                    <a:lstStyle/>
+                    <a:p>
+                      <a:r>
+                        <a:rPr sz="1725" b="0">
+                          <a:solidFill>
+                            <a:srgbClr val="172738"/>
+                          </a:solidFill>
+                          <a:latin typeface="Apple SD Gothic Neo"/>
+                          <a:ea typeface="Apple SD Gothic Neo"/>
+                          <a:cs typeface="Apple SD Gothic Neo"/>
+                        </a:rPr>
+                        <a:t>64B</a:t>
+                      </a:r>
+                    </a:p>
+                  </a:txBody>
+                  <a:tcPr marL="133350" marR="133350" marT="95250" marB="95250" anchor="ctr">
+                    <a:solidFill>
+                      <a:srgbClr val="F1F5F8"/>
+                    </a:solidFill>
+                  </a:tcPr>
+                </a:tc>
+                <a:tc>
+                  <a:txBody>
+                    <a:bodyPr lIns="114300" tIns="114300" rIns="114300" bIns="114300"/>
+                    <a:lstStyle/>
+                    <a:p>
+                      <a:r>
+                        <a:rPr sz="1725" b="0">
+                          <a:solidFill>
+                            <a:srgbClr val="172738"/>
+                          </a:solidFill>
+                          <a:latin typeface="Apple SD Gothic Neo"/>
+                          <a:ea typeface="Apple SD Gothic Neo"/>
+                          <a:cs typeface="Apple SD Gothic Neo"/>
+                        </a:rPr>
+                        <a:t>P1, P3, P2, P4, P6, P5, …</a:t>
+                      </a:r>
+                    </a:p>
+                  </a:txBody>
+                  <a:tcPr marL="133350" marR="133350" marT="95250" marB="95250" anchor="ctr">
+                    <a:solidFill>
+                      <a:srgbClr val="F1F5F8"/>
+                    </a:solidFill>
+                  </a:tcPr>
+                </a:tc>
+                <a:tc>
+                  <a:txBody>
+                    <a:bodyPr lIns="114300" tIns="114300" rIns="114300" bIns="114300"/>
+                    <a:lstStyle/>
+                    <a:p>
+                      <a:r>
+                        <a:rPr sz="1725" b="0">
+                          <a:solidFill>
+                            <a:srgbClr val="172738"/>
+                          </a:solidFill>
+                          <a:latin typeface="Apple SD Gothic Neo"/>
+                          <a:ea typeface="Apple SD Gothic Neo"/>
+                          <a:cs typeface="Apple SD Gothic Neo"/>
+                        </a:rPr>
+                        <a:t>B1과 크기는 같고 접근 순서만 바꿈</a:t>
+                      </a:r>
+                    </a:p>
+                  </a:txBody>
+                  <a:tcPr marL="133350" marR="133350" marT="95250" marB="95250" anchor="ctr">
+                    <a:solidFill>
+                      <a:srgbClr val="F1F5F8"/>
+                    </a:solidFill>
+                  </a:tcPr>
+                </a:tc>
+              </a:tr>
+              <a:tr h="577850">
+                <a:tc>
+                  <a:txBody>
+                    <a:bodyPr lIns="114300" tIns="114300" rIns="114300" bIns="114300"/>
+                    <a:lstStyle/>
+                    <a:p>
+                      <a:r>
+                        <a:rPr sz="1725" b="0">
+                          <a:solidFill>
+                            <a:srgbClr val="172738"/>
+                          </a:solidFill>
+                          <a:latin typeface="Apple SD Gothic Neo"/>
+                          <a:ea typeface="Apple SD Gothic Neo"/>
+                          <a:cs typeface="Apple SD Gothic Neo"/>
+                        </a:rPr>
+                        <a:t>B3</a:t>
+                      </a:r>
+                    </a:p>
+                  </a:txBody>
+                  <a:tcPr marL="133350" marR="133350" marT="95250" marB="95250" anchor="ctr">
+                    <a:solidFill>
+                      <a:srgbClr val="FFFFFF"/>
+                    </a:solidFill>
+                  </a:tcPr>
+                </a:tc>
+                <a:tc>
+                  <a:txBody>
+                    <a:bodyPr lIns="114300" tIns="114300" rIns="114300" bIns="114300"/>
+                    <a:lstStyle/>
+                    <a:p>
+                      <a:r>
+                        <a:rPr sz="1725" b="0">
+                          <a:solidFill>
+                            <a:srgbClr val="172738"/>
+                          </a:solidFill>
+                          <a:latin typeface="Apple SD Gothic Neo"/>
+                          <a:ea typeface="Apple SD Gothic Neo"/>
+                          <a:cs typeface="Apple SD Gothic Neo"/>
+                        </a:rPr>
+                        <a:t>64B</a:t>
+                      </a:r>
+                    </a:p>
+                  </a:txBody>
+                  <a:tcPr marL="133350" marR="133350" marT="95250" marB="95250" anchor="ctr">
+                    <a:solidFill>
+                      <a:srgbClr val="FFFFFF"/>
+                    </a:solidFill>
+                  </a:tcPr>
+                </a:tc>
+                <a:tc>
+                  <a:txBody>
+                    <a:bodyPr lIns="114300" tIns="114300" rIns="114300" bIns="114300"/>
+                    <a:lstStyle/>
+                    <a:p>
+                      <a:r>
+                        <a:rPr sz="1725" b="0">
+                          <a:solidFill>
+                            <a:srgbClr val="172738"/>
+                          </a:solidFill>
+                          <a:latin typeface="Apple SD Gothic Neo"/>
+                          <a:ea typeface="Apple SD Gothic Neo"/>
+                          <a:cs typeface="Apple SD Gothic Neo"/>
+                        </a:rPr>
+                        <a:t>P1, P3, P1(재방문), P2, …</a:t>
+                      </a:r>
+                    </a:p>
+                  </a:txBody>
+                  <a:tcPr marL="133350" marR="133350" marT="95250" marB="95250" anchor="ctr">
+                    <a:solidFill>
+                      <a:srgbClr val="FFFFFF"/>
+                    </a:solidFill>
+                  </a:tcPr>
+                </a:tc>
+                <a:tc>
+                  <a:txBody>
+                    <a:bodyPr lIns="114300" tIns="114300" rIns="114300" bIns="114300"/>
+                    <a:lstStyle/>
+                    <a:p>
+                      <a:r>
+                        <a:rPr sz="1725" b="0">
+                          <a:solidFill>
+                            <a:srgbClr val="172738"/>
+                          </a:solidFill>
+                          <a:latin typeface="Apple SD Gothic Neo"/>
+                          <a:ea typeface="Apple SD Gothic Neo"/>
+                          <a:cs typeface="Apple SD Gothic Neo"/>
+                        </a:rPr>
+                        <a:t>P1 재방문 시 offset +64B를 읽음</a:t>
+                      </a:r>
+                    </a:p>
+                  </a:txBody>
+                  <a:tcPr marL="133350" marR="133350" marT="95250" marB="95250" anchor="ctr">
+                    <a:solidFill>
+                      <a:srgbClr val="FFFFFF"/>
+                    </a:solidFill>
+                  </a:tcPr>
+                </a:tc>
+              </a:tr>
+            </a:tbl>
+          </a:graphicData>
+        </a:graphic>
+      </p:graphicFrame>
+      <p:sp>
+        <p:nvSpPr>
+          <p:cNvPr id="6" name="logical-not-physical">
+            <a:extLst xmlns:a="http://schemas.openxmlformats.org/drawingml/2006/main">
+              <a:ext uri="{FF2B5EF4-FFF2-40B4-BE49-F238E27FC236}">
+                <a16:creationId xmlns:a16="http://schemas.microsoft.com/office/drawing/2014/main" id="{31934106-267E-4465-AD35-D9F0F3C622F2}"/>
+              </a:ext>
+            </a:extLst>
+          </p:cNvPr>
+          <p:cNvSpPr>
+            <a:spLocks xmlns:a="http://schemas.openxmlformats.org/drawingml/2006/main" noGrp="1"/>
+          </p:cNvSpPr>
+          <p:nvPr/>
+        </p:nvSpPr>
+        <p:spPr>
+          <a:xfrm xmlns:a="http://schemas.openxmlformats.org/drawingml/2006/main">
+            <a:off x="571500" y="5514975"/>
+            <a:ext cx="11049000" cy="600075"/>
+          </a:xfrm>
+          <a:prstGeom xmlns:a="http://schemas.openxmlformats.org/drawingml/2006/main" prst="rect">
+            <a:avLst/>
+          </a:prstGeom>
+          <a:noFill xmlns:a="http://schemas.openxmlformats.org/drawingml/2006/main"/>
+          <a:ln xmlns:a="http://schemas.openxmlformats.org/drawingml/2006/main" w="0">
+            <a:noFill/>
+          </a:ln>
+        </p:spPr>
+        <p:txBody>
+          <a:bodyPr xmlns:a="http://schemas.openxmlformats.org/drawingml/2006/main" wrap="square" lIns="0" tIns="0" rIns="0" bIns="0" anchor="t">
+            <a:noAutofit/>
+          </a:bodyPr>
+          <a:lstStyle xmlns:a="http://schemas.openxmlformats.org/drawingml/2006/main">
+            <a:defPPr>
+              <a:defRPr sz="1800" b="0">
+                <a:solidFill>
+                  <a:srgbClr val="172738"/>
+                </a:solidFill>
+                <a:latin typeface="Apple SD Gothic Neo"/>
+                <a:ea typeface="Apple SD Gothic Neo"/>
+                <a:cs typeface="Apple SD Gothic Neo"/>
+              </a:defRPr>
+            </a:defPPr>
+          </a:lstStyle>
+          <a:p xmlns:a="http://schemas.openxmlformats.org/drawingml/2006/main">
+            <a:pPr>
+              <a:defRPr sz="1800" b="0">
+                <a:solidFill>
+                  <a:srgbClr val="172738"/>
+                </a:solidFill>
+                <a:latin typeface="Apple SD Gothic Neo"/>
+                <a:ea typeface="Apple SD Gothic Neo"/>
+                <a:cs typeface="Apple SD Gothic Neo"/>
+              </a:defRPr>
+            </a:pPr>
+            <a:r>
+              <a:rPr sz="1800" b="0">
+                <a:solidFill>
+                  <a:srgbClr val="172738"/>
+                </a:solidFill>
+                <a:latin typeface="Apple SD Gothic Neo"/>
+                <a:ea typeface="Apple SD Gothic Neo"/>
+                <a:cs typeface="Apple SD Gothic Neo"/>
+              </a:rPr>
+              <a:t>B3의 재방문은 같은 논리 페이지의 다른 데이터를 읽습니다.</a:t>
+            </a:r>
+          </a:p>
+          <a:p xmlns:a="http://schemas.openxmlformats.org/drawingml/2006/main">
+            <a:pPr>
+              <a:defRPr sz="1800" b="0">
+                <a:solidFill>
+                  <a:srgbClr val="172738"/>
+                </a:solidFill>
+                <a:latin typeface="Apple SD Gothic Neo"/>
+                <a:ea typeface="Apple SD Gothic Neo"/>
+                <a:cs typeface="Apple SD Gothic Neo"/>
+              </a:defRPr>
+            </a:pPr>
+            <a:r>
+              <a:rPr sz="1800" b="0">
+                <a:solidFill>
+                  <a:srgbClr val="172738"/>
+                </a:solidFill>
+                <a:latin typeface="Apple SD Gothic Neo"/>
+                <a:ea typeface="Apple SD Gothic Neo"/>
+                <a:cs typeface="Apple SD Gothic Neo"/>
+              </a:rPr>
+              <a:t>논리 페이지의 접근 순서와 실제 Channel·Plane·물리 페이지는 L2P 배치를 거쳐 연결됩니다.</a:t>
+            </a:r>
+          </a:p>
+        </p:txBody>
+      </p:sp>
+    </p:spTree>
+    <p:extLst>
+      <p:ext uri="{BB962C8B-B14F-4D97-AF65-F5344CB8AC3E}">
+        <p14:creationId xmlns:p14="http://schemas.microsoft.com/office/powerpoint/2010/main" val="53370302"/>
       </p:ext>
     </p:extLst>
   </p:cSld>

</xml_diff>